<commit_message>
feat(pitch-deck): integrate 3D glassmorphic assets and visual badges into web & pptx decks
</commit_message>
<xml_diff>
--- a/public/formu_pitch_deck.pptx
+++ b/public/formu_pitch_deck.pptx
@@ -3433,120 +3433,40 @@
           </a:p>
         </p:txBody>
       </p:sp>
-      <p:sp>
-        <p:nvSpPr>
-          <p:cNvPr id="10" name="Rounded Rectangle 9"/>
+      <p:pic>
+        <p:nvPicPr>
+          <p:cNvPr id="10" name="Picture 9" descr="glass_bottle.jpg"/>
+          <p:cNvPicPr>
+            <a:picLocks noChangeAspect="1"/>
+          </p:cNvPicPr>
+          <p:nvPr/>
+        </p:nvPicPr>
+        <p:blipFill>
+          <a:blip r:embed="rId2"/>
+          <a:stretch>
+            <a:fillRect/>
+          </a:stretch>
+        </p:blipFill>
+        <p:spPr>
+          <a:xfrm>
+            <a:off x="8458200" y="2514600"/>
+            <a:ext cx="2011680" cy="2011680"/>
+          </a:xfrm>
+          <a:prstGeom prst="rect">
+            <a:avLst/>
+          </a:prstGeom>
+        </p:spPr>
+      </p:pic>
+      <p:sp>
+        <p:nvSpPr>
+          <p:cNvPr id="11" name="Rounded Rectangle 10"/>
           <p:cNvSpPr/>
           <p:nvPr/>
         </p:nvSpPr>
         <p:spPr>
           <a:xfrm>
-            <a:off x="8046720" y="2926080"/>
-            <a:ext cx="2834640" cy="1463040"/>
-          </a:xfrm>
-          <a:prstGeom prst="roundRect">
-            <a:avLst/>
-          </a:prstGeom>
-          <a:solidFill>
-            <a:srgbClr val="FFFFFF"/>
-          </a:solidFill>
-          <a:ln w="19050">
-            <a:solidFill>
-              <a:srgbClr val="1E60F2"/>
-            </a:solidFill>
-          </a:ln>
-        </p:spPr>
-        <p:style>
-          <a:lnRef idx="1">
-            <a:schemeClr val="accent1"/>
-          </a:lnRef>
-          <a:fillRef idx="3">
-            <a:schemeClr val="accent1"/>
-          </a:fillRef>
-          <a:effectRef idx="2">
-            <a:schemeClr val="accent1"/>
-          </a:effectRef>
-          <a:fontRef idx="minor">
-            <a:schemeClr val="lt1"/>
-          </a:fontRef>
-        </p:style>
-        <p:txBody>
-          <a:bodyPr rtlCol="0" anchor="ctr"/>
-          <a:lstStyle/>
-          <a:p>
-            <a:pPr algn="ctr"/>
-          </a:p>
-        </p:txBody>
-      </p:sp>
-      <p:sp>
-        <p:nvSpPr>
-          <p:cNvPr id="11" name="TextBox 10"/>
-          <p:cNvSpPr txBox="1"/>
-          <p:nvPr/>
-        </p:nvSpPr>
-        <p:spPr>
-          <a:xfrm>
-            <a:off x="8046720" y="3108960"/>
-            <a:ext cx="2834640" cy="1097280"/>
-          </a:xfrm>
-          <a:prstGeom prst="rect">
-            <a:avLst/>
-          </a:prstGeom>
-          <a:noFill/>
-        </p:spPr>
-        <p:txBody>
-          <a:bodyPr wrap="square">
-            <a:spAutoFit/>
-          </a:bodyPr>
-          <a:lstStyle/>
-          <a:p>
-            <a:pPr algn="ctr">
-              <a:defRPr sz="1050" b="1">
-                <a:solidFill>
-                  <a:srgbClr val="1E60F2"/>
-                </a:solidFill>
-              </a:defRPr>
-            </a:pPr>
-            <a:r>
-              <a:t>FORMU REGTECH OS</a:t>
-            </a:r>
-          </a:p>
-          <a:p>
-            <a:pPr algn="ctr">
-              <a:defRPr sz="1600" b="1">
-                <a:solidFill>
-                  <a:srgbClr val="0B132B"/>
-                </a:solidFill>
-              </a:defRPr>
-            </a:pPr>
-            <a:r>
-              <a:t>원클릭 규제 완성</a:t>
-            </a:r>
-          </a:p>
-          <a:p>
-            <a:pPr algn="ctr">
-              <a:defRPr sz="1000">
-                <a:solidFill>
-                  <a:srgbClr val="64748B"/>
-                </a:solidFill>
-              </a:defRPr>
-            </a:pPr>
-            <a:r>
-              <a:t>배합표 즉시 분기 출력</a:t>
-            </a:r>
-          </a:p>
-        </p:txBody>
-      </p:sp>
-      <p:sp>
-        <p:nvSpPr>
-          <p:cNvPr id="12" name="Rounded Rectangle 11"/>
-          <p:cNvSpPr/>
-          <p:nvPr/>
-        </p:nvSpPr>
-        <p:spPr>
-          <a:xfrm>
-            <a:off x="7772400" y="1920240"/>
-            <a:ext cx="3383280" cy="822960"/>
+            <a:off x="7772400" y="1874519"/>
+            <a:ext cx="3383280" cy="777240"/>
           </a:xfrm>
           <a:prstGeom prst="roundRect">
             <a:avLst/>
@@ -3582,14 +3502,14 @@
       </p:sp>
       <p:sp>
         <p:nvSpPr>
-          <p:cNvPr id="13" name="TextBox 12"/>
+          <p:cNvPr id="12" name="TextBox 11"/>
           <p:cNvSpPr txBox="1"/>
           <p:nvPr/>
         </p:nvSpPr>
         <p:spPr>
           <a:xfrm>
-            <a:off x="7955279" y="1965960"/>
-            <a:ext cx="3017520" cy="731520"/>
+            <a:off x="7955279" y="1920240"/>
+            <a:ext cx="3017520" cy="685800"/>
           </a:xfrm>
           <a:prstGeom prst="rect">
             <a:avLst/>
@@ -3603,7 +3523,7 @@
           <a:lstStyle/>
           <a:p>
             <a:pPr>
-              <a:defRPr sz="2000" b="1">
+              <a:defRPr sz="1900" b="1">
                 <a:solidFill>
                   <a:srgbClr val="FFFFFF"/>
                 </a:solidFill>
@@ -3629,14 +3549,14 @@
       </p:sp>
       <p:sp>
         <p:nvSpPr>
-          <p:cNvPr id="14" name="Rounded Rectangle 13"/>
+          <p:cNvPr id="13" name="Rounded Rectangle 12"/>
           <p:cNvSpPr/>
           <p:nvPr/>
         </p:nvSpPr>
         <p:spPr>
           <a:xfrm>
-            <a:off x="7772400" y="4617720"/>
-            <a:ext cx="3383280" cy="822960"/>
+            <a:off x="7772400" y="4709160"/>
+            <a:ext cx="3383280" cy="777240"/>
           </a:xfrm>
           <a:prstGeom prst="roundRect">
             <a:avLst/>
@@ -3674,14 +3594,14 @@
       </p:sp>
       <p:sp>
         <p:nvSpPr>
-          <p:cNvPr id="15" name="TextBox 14"/>
+          <p:cNvPr id="14" name="TextBox 13"/>
           <p:cNvSpPr txBox="1"/>
           <p:nvPr/>
         </p:nvSpPr>
         <p:spPr>
           <a:xfrm>
-            <a:off x="7955279" y="4663440"/>
-            <a:ext cx="3017520" cy="731520"/>
+            <a:off x="7955279" y="4754880"/>
+            <a:ext cx="3017520" cy="685800"/>
           </a:xfrm>
           <a:prstGeom prst="rect">
             <a:avLst/>
@@ -3695,7 +3615,7 @@
           <a:lstStyle/>
           <a:p>
             <a:pPr>
-              <a:defRPr sz="2000" b="1">
+              <a:defRPr sz="1900" b="1">
                 <a:solidFill>
                   <a:srgbClr val="EF4444"/>
                 </a:solidFill>
@@ -3721,7 +3641,7 @@
       </p:sp>
       <p:sp>
         <p:nvSpPr>
-          <p:cNvPr id="16" name="TextBox 15"/>
+          <p:cNvPr id="15" name="TextBox 14"/>
           <p:cNvSpPr txBox="1"/>
           <p:nvPr/>
         </p:nvSpPr>
@@ -6800,7 +6720,7 @@
               </a:defRPr>
             </a:pPr>
             <a:r>
-              <a:t>※ 출처: 화장품법 제10조(기재사항) 및 화학제품안전법 제10조(안전기준의 적합확인)</a:t>
+              <a:t>※ 출처: 화장품법 제10조 및 화학제품안전법 제10조</a:t>
             </a:r>
           </a:p>
         </p:txBody>
@@ -7534,8 +7454,8 @@
         </p:nvSpPr>
         <p:spPr>
           <a:xfrm>
-            <a:off x="1097280" y="2011680"/>
-            <a:ext cx="2468880" cy="2468880"/>
+            <a:off x="1005840" y="2011680"/>
+            <a:ext cx="2377440" cy="2377440"/>
           </a:xfrm>
           <a:prstGeom prst="ellipse">
             <a:avLst/>
@@ -7579,8 +7499,8 @@
         </p:nvSpPr>
         <p:spPr>
           <a:xfrm>
-            <a:off x="1097280" y="2194560"/>
-            <a:ext cx="2468880" cy="2103120"/>
+            <a:off x="1005840" y="2194560"/>
+            <a:ext cx="2377440" cy="2011680"/>
           </a:xfrm>
           <a:prstGeom prst="rect">
             <a:avLst/>
@@ -7606,7 +7526,7 @@
           </a:p>
           <a:p>
             <a:pPr algn="ctr">
-              <a:defRPr sz="4000" b="1">
+              <a:defRPr sz="3800" b="1">
                 <a:solidFill>
                   <a:srgbClr val="0F172A"/>
                 </a:solidFill>
@@ -7618,7 +7538,7 @@
           </a:p>
           <a:p>
             <a:pPr algn="ctr">
-              <a:defRPr sz="950" b="1">
+              <a:defRPr sz="900" b="1">
                 <a:solidFill>
                   <a:srgbClr val="64748B"/>
                 </a:solidFill>
@@ -7629,7 +7549,7 @@
             </a:r>
             <a:br/>
             <a:r>
-              <a:t>(소요 2~4주 · 22만~100만 원)</a:t>
+              <a:t>(2~4주 · 22만~100만 원)</a:t>
             </a:r>
           </a:p>
         </p:txBody>
@@ -7642,8 +7562,8 @@
         </p:nvSpPr>
         <p:spPr>
           <a:xfrm>
-            <a:off x="3931920" y="2880360"/>
-            <a:ext cx="4114800" cy="777240"/>
+            <a:off x="3566160" y="2834640"/>
+            <a:ext cx="3108960" cy="731520"/>
           </a:xfrm>
           <a:prstGeom prst="rightArrow">
             <a:avLst/>
@@ -7685,8 +7605,8 @@
         </p:nvSpPr>
         <p:spPr>
           <a:xfrm>
-            <a:off x="3931920" y="3017520"/>
-            <a:ext cx="3840480" cy="548640"/>
+            <a:off x="3566160" y="2971800"/>
+            <a:ext cx="2926080" cy="457200"/>
           </a:xfrm>
           <a:prstGeom prst="rect">
             <a:avLst/>
@@ -7700,14 +7620,18 @@
           <a:lstStyle/>
           <a:p>
             <a:pPr algn="ctr">
-              <a:defRPr sz="1300" b="1">
+              <a:defRPr sz="1100" b="1">
                 <a:solidFill>
                   <a:srgbClr val="FFFFFF"/>
                 </a:solidFill>
               </a:defRPr>
             </a:pPr>
             <a:r>
-              <a:t>접점 5개 ➔ 1개 / 소요시간 98% 절감</a:t>
+              <a:t>접점 5개 ➔ 1개</a:t>
+            </a:r>
+            <a:br/>
+            <a:r>
+              <a:t>소요시간 98% 절감</a:t>
             </a:r>
           </a:p>
         </p:txBody>
@@ -7720,8 +7644,8 @@
         </p:nvSpPr>
         <p:spPr>
           <a:xfrm>
-            <a:off x="8412480" y="1874519"/>
-            <a:ext cx="2743200" cy="2743200"/>
+            <a:off x="6858000" y="1920240"/>
+            <a:ext cx="2560320" cy="2560320"/>
           </a:xfrm>
           <a:prstGeom prst="ellipse">
             <a:avLst/>
@@ -7763,8 +7687,8 @@
         </p:nvSpPr>
         <p:spPr>
           <a:xfrm>
-            <a:off x="8412480" y="2103120"/>
-            <a:ext cx="2743200" cy="2286000"/>
+            <a:off x="6858000" y="2148840"/>
+            <a:ext cx="2560320" cy="2103120"/>
           </a:xfrm>
           <a:prstGeom prst="rect">
             <a:avLst/>
@@ -7778,7 +7702,7 @@
           <a:lstStyle/>
           <a:p>
             <a:pPr algn="ctr">
-              <a:defRPr sz="1300" b="1">
+              <a:defRPr sz="1250" b="1">
                 <a:solidFill>
                   <a:srgbClr val="BAE6FD"/>
                 </a:solidFill>
@@ -7790,7 +7714,7 @@
           </a:p>
           <a:p>
             <a:pPr algn="ctr">
-              <a:defRPr sz="4800" b="1">
+              <a:defRPr sz="4400" b="1">
                 <a:solidFill>
                   <a:srgbClr val="FFFFFF"/>
                 </a:solidFill>
@@ -7802,7 +7726,7 @@
           </a:p>
           <a:p>
             <a:pPr algn="ctr">
-              <a:defRPr sz="1050" b="1">
+              <a:defRPr sz="1000" b="1">
                 <a:solidFill>
                   <a:srgbClr val="FFFFFF"/>
                 </a:solidFill>
@@ -7813,14 +7737,73 @@
             </a:r>
             <a:br/>
             <a:r>
-              <a:t>(1초 완성 · 건당 1.9만 원)</a:t>
-            </a:r>
-          </a:p>
-        </p:txBody>
-      </p:sp>
-      <p:sp>
-        <p:nvSpPr>
-          <p:cNvPr id="15" name="Rounded Rectangle 14"/>
+              <a:t>(1초 완성 · 1.9만 원)</a:t>
+            </a:r>
+          </a:p>
+        </p:txBody>
+      </p:sp>
+      <p:pic>
+        <p:nvPicPr>
+          <p:cNvPr id="15" name="Picture 14" descr="glass_growth.jpg"/>
+          <p:cNvPicPr>
+            <a:picLocks noChangeAspect="1"/>
+          </p:cNvPicPr>
+          <p:nvPr/>
+        </p:nvPicPr>
+        <p:blipFill>
+          <a:blip r:embed="rId2"/>
+          <a:stretch>
+            <a:fillRect/>
+          </a:stretch>
+        </p:blipFill>
+        <p:spPr>
+          <a:xfrm>
+            <a:off x="9601200" y="2011680"/>
+            <a:ext cx="1645920" cy="1645920"/>
+          </a:xfrm>
+          <a:prstGeom prst="rect">
+            <a:avLst/>
+          </a:prstGeom>
+        </p:spPr>
+      </p:pic>
+      <p:sp>
+        <p:nvSpPr>
+          <p:cNvPr id="16" name="TextBox 15"/>
+          <p:cNvSpPr txBox="1"/>
+          <p:nvPr/>
+        </p:nvSpPr>
+        <p:spPr>
+          <a:xfrm>
+            <a:off x="9601200" y="3749039"/>
+            <a:ext cx="1645920" cy="365760"/>
+          </a:xfrm>
+          <a:prstGeom prst="rect">
+            <a:avLst/>
+          </a:prstGeom>
+          <a:noFill/>
+        </p:spPr>
+        <p:txBody>
+          <a:bodyPr wrap="none">
+            <a:spAutoFit/>
+          </a:bodyPr>
+          <a:lstStyle/>
+          <a:p>
+            <a:pPr algn="ctr">
+              <a:defRPr sz="950" b="1">
+                <a:solidFill>
+                  <a:srgbClr val="1E60F2"/>
+                </a:solidFill>
+              </a:defRPr>
+            </a:pPr>
+            <a:r>
+              <a:t>+98% 공정 시간 단축</a:t>
+            </a:r>
+          </a:p>
+        </p:txBody>
+      </p:sp>
+      <p:sp>
+        <p:nvSpPr>
+          <p:cNvPr id="17" name="Rounded Rectangle 16"/>
           <p:cNvSpPr/>
           <p:nvPr/>
         </p:nvSpPr>
@@ -7865,7 +7848,7 @@
       </p:sp>
       <p:sp>
         <p:nvSpPr>
-          <p:cNvPr id="16" name="TextBox 15"/>
+          <p:cNvPr id="18" name="TextBox 17"/>
           <p:cNvSpPr txBox="1"/>
           <p:nvPr/>
         </p:nvSpPr>
@@ -7924,7 +7907,7 @@
       </p:sp>
       <p:sp>
         <p:nvSpPr>
-          <p:cNvPr id="17" name="Rounded Rectangle 16"/>
+          <p:cNvPr id="19" name="Rounded Rectangle 18"/>
           <p:cNvSpPr/>
           <p:nvPr/>
         </p:nvSpPr>
@@ -7969,7 +7952,7 @@
       </p:sp>
       <p:sp>
         <p:nvSpPr>
-          <p:cNvPr id="18" name="TextBox 17"/>
+          <p:cNvPr id="20" name="TextBox 19"/>
           <p:cNvSpPr txBox="1"/>
           <p:nvPr/>
         </p:nvSpPr>
@@ -9556,7 +9539,7 @@
           <a:lstStyle/>
           <a:p>
             <a:pPr>
-              <a:defRPr sz="950" b="1">
+              <a:defRPr sz="950">
                 <a:solidFill>
                   <a:srgbClr val="1E60F2"/>
                 </a:solidFill>
@@ -9623,16 +9606,40 @@
           </a:p>
         </p:txBody>
       </p:sp>
-      <p:sp>
-        <p:nvSpPr>
-          <p:cNvPr id="20" name="TextBox 19"/>
+      <p:pic>
+        <p:nvPicPr>
+          <p:cNvPr id="20" name="Picture 19" descr="glass_cart.jpg"/>
+          <p:cNvPicPr>
+            <a:picLocks noChangeAspect="1"/>
+          </p:cNvPicPr>
+          <p:nvPr/>
+        </p:nvPicPr>
+        <p:blipFill>
+          <a:blip r:embed="rId2"/>
+          <a:stretch>
+            <a:fillRect/>
+          </a:stretch>
+        </p:blipFill>
+        <p:spPr>
+          <a:xfrm>
+            <a:off x="10241280" y="1874519"/>
+            <a:ext cx="960120" cy="960120"/>
+          </a:xfrm>
+          <a:prstGeom prst="rect">
+            <a:avLst/>
+          </a:prstGeom>
+        </p:spPr>
+      </p:pic>
+      <p:sp>
+        <p:nvSpPr>
+          <p:cNvPr id="21" name="TextBox 20"/>
           <p:cNvSpPr txBox="1"/>
           <p:nvPr/>
         </p:nvSpPr>
         <p:spPr>
           <a:xfrm>
             <a:off x="6949440" y="1920240"/>
-            <a:ext cx="4206240" cy="3931920"/>
+            <a:ext cx="3291840" cy="731520"/>
           </a:xfrm>
           <a:prstGeom prst="rect">
             <a:avLst/>
@@ -9657,71 +9664,105 @@
             </a:r>
           </a:p>
           <a:p>
+            <a:pPr>
+              <a:defRPr sz="1050">
+                <a:solidFill>
+                  <a:srgbClr val="64748B"/>
+                </a:solidFill>
+              </a:defRPr>
+            </a:pPr>
+            <a:r>
+              <a:t>인디 뷰티 &amp; 향기 커머스 유통 분석</a:t>
+            </a:r>
+          </a:p>
+        </p:txBody>
+      </p:sp>
+      <p:sp>
+        <p:nvSpPr>
+          <p:cNvPr id="22" name="TextBox 21"/>
+          <p:cNvSpPr txBox="1"/>
+          <p:nvPr/>
+        </p:nvSpPr>
+        <p:spPr>
+          <a:xfrm>
+            <a:off x="6949440" y="2834640"/>
+            <a:ext cx="4206240" cy="3017520"/>
+          </a:xfrm>
+          <a:prstGeom prst="rect">
+            <a:avLst/>
+          </a:prstGeom>
+          <a:noFill/>
+        </p:spPr>
+        <p:txBody>
+          <a:bodyPr wrap="square">
+            <a:spAutoFit/>
+          </a:bodyPr>
+          <a:lstStyle/>
+          <a:p>
+            <a:pPr>
+              <a:defRPr sz="1200" b="1">
+                <a:solidFill>
+                  <a:srgbClr val="1E60F2"/>
+                </a:solidFill>
+              </a:defRPr>
+            </a:pPr>
+            <a:r>
+              <a:t>● 1인 인디 브랜드 급증세</a:t>
+            </a:r>
+          </a:p>
+          <a:p>
+            <a:pPr>
+              <a:defRPr sz="1000">
+                <a:solidFill>
+                  <a:srgbClr val="334155"/>
+                </a:solidFill>
+              </a:defRPr>
+            </a:pPr>
+            <a:r>
+              <a:t>K-뷰티 인디 브랜드 열풍으로 연간 4,071개 제조판매업체가 신규 진입하며 전문 규제 인력 부재 문제 심각.</a:t>
+            </a:r>
+          </a:p>
+          <a:p>
             <a:br/>
             <a:pPr>
-              <a:defRPr sz="1250" b="1">
+              <a:defRPr sz="1200" b="1">
                 <a:solidFill>
                   <a:srgbClr val="1E60F2"/>
                 </a:solidFill>
               </a:defRPr>
             </a:pPr>
             <a:r>
-              <a:t>● 1인 인디 브랜드 급증세</a:t>
-            </a:r>
-          </a:p>
-          <a:p>
-            <a:pPr>
-              <a:defRPr sz="1050">
+              <a:t>● 규제 행정 지출 1,200억 원</a:t>
+            </a:r>
+          </a:p>
+          <a:p>
+            <a:pPr>
+              <a:defRPr sz="1000">
                 <a:solidFill>
                   <a:srgbClr val="334155"/>
                 </a:solidFill>
               </a:defRPr>
             </a:pPr>
             <a:r>
-              <a:t>K-뷰티 인디 브랜드 열풍으로 연간 4,071개 제조판매업체가 신규 진입하며 전문 규제 인력 부재 문제 심각.</a:t>
+              <a:t>브랜드당 연간 신제품 5~10종 출시로 매년 수백만 원의 서류 대행 및 인쇄 비용 지출 발생.</a:t>
             </a:r>
           </a:p>
           <a:p>
             <a:br/>
             <a:pPr>
-              <a:defRPr sz="1250" b="1">
+              <a:defRPr sz="1200" b="1">
                 <a:solidFill>
                   <a:srgbClr val="1E60F2"/>
                 </a:solidFill>
               </a:defRPr>
             </a:pPr>
             <a:r>
-              <a:t>● 규제 행정 지출 1,200억 원</a:t>
-            </a:r>
-          </a:p>
-          <a:p>
-            <a:pPr>
-              <a:defRPr sz="1050">
-                <a:solidFill>
-                  <a:srgbClr val="334155"/>
-                </a:solidFill>
-              </a:defRPr>
-            </a:pPr>
-            <a:r>
-              <a:t>브랜드당 연간 신제품 5~10종 출시로 매년 수백만 원의 서류 대행 및 인쇄 비용 지출 발생.</a:t>
-            </a:r>
-          </a:p>
-          <a:p>
-            <a:br/>
-            <a:pPr>
-              <a:defRPr sz="1250" b="1">
-                <a:solidFill>
-                  <a:srgbClr val="1E60F2"/>
-                </a:solidFill>
-              </a:defRPr>
-            </a:pPr>
-            <a:r>
               <a:t>● 초기 SOM 48억 원 선점</a:t>
             </a:r>
           </a:p>
           <a:p>
             <a:pPr>
-              <a:defRPr sz="1050">
+              <a:defRPr sz="1000">
                 <a:solidFill>
                   <a:srgbClr val="334155"/>
                 </a:solidFill>
@@ -10376,16 +10417,40 @@
           </a:p>
         </p:txBody>
       </p:sp>
-      <p:sp>
-        <p:nvSpPr>
-          <p:cNvPr id="15" name="TextBox 14"/>
+      <p:pic>
+        <p:nvPicPr>
+          <p:cNvPr id="15" name="Picture 14" descr="glass_shield.jpg"/>
+          <p:cNvPicPr>
+            <a:picLocks noChangeAspect="1"/>
+          </p:cNvPicPr>
+          <p:nvPr/>
+        </p:nvPicPr>
+        <p:blipFill>
+          <a:blip r:embed="rId2"/>
+          <a:stretch>
+            <a:fillRect/>
+          </a:stretch>
+        </p:blipFill>
+        <p:spPr>
+          <a:xfrm>
+            <a:off x="914400" y="5440680"/>
+            <a:ext cx="658368" cy="658368"/>
+          </a:xfrm>
+          <a:prstGeom prst="rect">
+            <a:avLst/>
+          </a:prstGeom>
+        </p:spPr>
+      </p:pic>
+      <p:sp>
+        <p:nvSpPr>
+          <p:cNvPr id="16" name="TextBox 15"/>
           <p:cNvSpPr txBox="1"/>
           <p:nvPr/>
         </p:nvSpPr>
         <p:spPr>
           <a:xfrm>
-            <a:off x="914400" y="5486400"/>
-            <a:ext cx="10332720" cy="594360"/>
+            <a:off x="1691640" y="5486400"/>
+            <a:ext cx="9509760" cy="594360"/>
           </a:xfrm>
           <a:prstGeom prst="rect">
             <a:avLst/>

</xml_diff>

<commit_message>
refactor(wording): replace colloquial '엑셀 지옥' with professional '수기 연산 및 오기재 리스크'
</commit_message>
<xml_diff>
--- a/public/formu_pitch_deck.pptx
+++ b/public/formu_pitch_deck.pptx
@@ -6994,11 +6994,11 @@
               </a:defRPr>
             </a:pPr>
             <a:r>
-              <a:t>CHEMP 배합비율표</a:t>
+              <a:t>CHEMP 100% 배합비율표</a:t>
             </a:r>
             <a:br/>
             <a:r>
-              <a:t>수기 엑셀 지옥</a:t>
+              <a:t>수기 연산 및 오기재 리스크</a:t>
             </a:r>
             <a:br/>
           </a:p>

</xml_diff>

<commit_message>
feat(design): overhaul landing page and pitch deck to match Synth AI (Tailgrids) modular aesthetic and design system
</commit_message>
<xml_diff>
--- a/public/formu_pitch_deck.pptx
+++ b/public/formu_pitch_deck.pptx
@@ -3113,7 +3113,7 @@
             <a:avLst/>
           </a:prstGeom>
           <a:solidFill>
-            <a:srgbClr val="F8FAFC"/>
+            <a:srgbClr val="F4F4F6"/>
           </a:solidFill>
           <a:ln>
             <a:noFill/>
@@ -3156,7 +3156,7 @@
             <a:avLst/>
           </a:prstGeom>
           <a:solidFill>
-            <a:srgbClr val="F3E8FF"/>
+            <a:srgbClr val="EBEBFC"/>
           </a:solidFill>
           <a:ln w="15240">
             <a:solidFill>
@@ -3246,7 +3246,7 @@
             <a:pPr>
               <a:defRPr sz="5000" b="1">
                 <a:solidFill>
-                  <a:srgbClr val="0F172A"/>
+                  <a:srgbClr val="0A0A0A"/>
                 </a:solidFill>
               </a:defRPr>
             </a:pPr>
@@ -3258,7 +3258,7 @@
             <a:pPr>
               <a:defRPr sz="2200" b="1">
                 <a:solidFill>
-                  <a:srgbClr val="3182F6"/>
+                  <a:srgbClr val="585ECE"/>
                 </a:solidFill>
               </a:defRPr>
             </a:pPr>
@@ -3296,7 +3296,7 @@
               </a:lnSpc>
               <a:defRPr sz="1400">
                 <a:solidFill>
-                  <a:srgbClr val="475569"/>
+                  <a:srgbClr val="52525B"/>
                 </a:solidFill>
               </a:defRPr>
             </a:pPr>
@@ -3335,7 +3335,7 @@
             <a:pPr>
               <a:defRPr sz="1100" b="1">
                 <a:solidFill>
-                  <a:srgbClr val="64748B"/>
+                  <a:srgbClr val="71717A"/>
                 </a:solidFill>
               </a:defRPr>
             </a:pPr>
@@ -3364,7 +3364,7 @@
           </a:solidFill>
           <a:ln w="22860">
             <a:solidFill>
-              <a:srgbClr val="3182F6"/>
+              <a:srgbClr val="585ECE"/>
             </a:solidFill>
           </a:ln>
         </p:spPr>
@@ -3409,7 +3409,7 @@
           </a:solidFill>
           <a:ln w="19050">
             <a:solidFill>
-              <a:srgbClr val="3182F6"/>
+              <a:srgbClr val="585ECE"/>
             </a:solidFill>
           </a:ln>
         </p:spPr>
@@ -3460,7 +3460,7 @@
             <a:pPr>
               <a:defRPr sz="1350" b="1">
                 <a:solidFill>
-                  <a:srgbClr val="3182F6"/>
+                  <a:srgbClr val="585ECE"/>
                 </a:solidFill>
               </a:defRPr>
             </a:pPr>
@@ -3472,7 +3472,7 @@
             <a:pPr>
               <a:defRPr sz="1050">
                 <a:solidFill>
-                  <a:srgbClr val="475569"/>
+                  <a:srgbClr val="52525B"/>
                 </a:solidFill>
               </a:defRPr>
             </a:pPr>
@@ -3564,7 +3564,7 @@
             <a:pPr>
               <a:defRPr sz="1050">
                 <a:solidFill>
-                  <a:srgbClr val="475569"/>
+                  <a:srgbClr val="52525B"/>
                 </a:solidFill>
               </a:defRPr>
             </a:pPr>
@@ -3656,7 +3656,7 @@
             <a:pPr>
               <a:defRPr sz="1050">
                 <a:solidFill>
-                  <a:srgbClr val="475569"/>
+                  <a:srgbClr val="52525B"/>
                 </a:solidFill>
               </a:defRPr>
             </a:pPr>
@@ -3691,7 +3691,7 @@
             <a:pPr>
               <a:defRPr sz="900">
                 <a:solidFill>
-                  <a:srgbClr val="64748B"/>
+                  <a:srgbClr val="71717A"/>
                 </a:solidFill>
                 <a:latin typeface="Pretendard"/>
               </a:defRPr>
@@ -3727,7 +3727,7 @@
             <a:pPr algn="r">
               <a:defRPr sz="1000" b="1">
                 <a:solidFill>
-                  <a:srgbClr val="3182F6"/>
+                  <a:srgbClr val="585ECE"/>
                 </a:solidFill>
                 <a:latin typeface="Pretendard"/>
               </a:defRPr>
@@ -3771,7 +3771,7 @@
             <a:avLst/>
           </a:prstGeom>
           <a:solidFill>
-            <a:srgbClr val="F8FAFC"/>
+            <a:srgbClr val="F4F4F6"/>
           </a:solidFill>
           <a:ln>
             <a:noFill/>
@@ -3814,11 +3814,11 @@
             <a:avLst/>
           </a:prstGeom>
           <a:solidFill>
-            <a:srgbClr val="EEF4FF"/>
+            <a:srgbClr val="F4F5FF"/>
           </a:solidFill>
           <a:ln w="12700">
             <a:solidFill>
-              <a:srgbClr val="3182F6"/>
+              <a:srgbClr val="585ECE"/>
             </a:solidFill>
           </a:ln>
         </p:spPr>
@@ -3869,7 +3869,7 @@
             <a:pPr>
               <a:defRPr sz="1000" b="1">
                 <a:solidFill>
-                  <a:srgbClr val="3182F6"/>
+                  <a:srgbClr val="585ECE"/>
                 </a:solidFill>
                 <a:latin typeface="Pretendard"/>
               </a:defRPr>
@@ -3905,7 +3905,7 @@
             <a:pPr>
               <a:defRPr sz="2300" b="1">
                 <a:solidFill>
-                  <a:srgbClr val="0F172A"/>
+                  <a:srgbClr val="0A0A0A"/>
                 </a:solidFill>
                 <a:latin typeface="Pretendard"/>
               </a:defRPr>
@@ -3941,7 +3941,7 @@
             <a:pPr>
               <a:defRPr sz="1200">
                 <a:solidFill>
-                  <a:srgbClr val="475569"/>
+                  <a:srgbClr val="52525B"/>
                 </a:solidFill>
                 <a:latin typeface="Pretendard"/>
               </a:defRPr>
@@ -3977,7 +3977,7 @@
             <a:pPr>
               <a:defRPr sz="900">
                 <a:solidFill>
-                  <a:srgbClr val="64748B"/>
+                  <a:srgbClr val="71717A"/>
                 </a:solidFill>
                 <a:latin typeface="Pretendard"/>
               </a:defRPr>
@@ -4013,7 +4013,7 @@
             <a:pPr algn="r">
               <a:defRPr sz="1000" b="1">
                 <a:solidFill>
-                  <a:srgbClr val="3182F6"/>
+                  <a:srgbClr val="585ECE"/>
                 </a:solidFill>
                 <a:latin typeface="Pretendard"/>
               </a:defRPr>
@@ -4172,7 +4172,7 @@
             <a:pPr>
               <a:defRPr sz="1500" b="1">
                 <a:solidFill>
-                  <a:srgbClr val="0F172A"/>
+                  <a:srgbClr val="0A0A0A"/>
                 </a:solidFill>
               </a:defRPr>
             </a:pPr>
@@ -4210,7 +4210,7 @@
               </a:lnSpc>
               <a:defRPr sz="1100">
                 <a:solidFill>
-                  <a:srgbClr val="475569"/>
+                  <a:srgbClr val="52525B"/>
                 </a:solidFill>
               </a:defRPr>
             </a:pPr>
@@ -4243,7 +4243,7 @@
           </a:solidFill>
           <a:ln w="22860">
             <a:solidFill>
-              <a:srgbClr val="3182F6"/>
+              <a:srgbClr val="585ECE"/>
             </a:solidFill>
           </a:ln>
         </p:spPr>
@@ -4284,7 +4284,7 @@
             <a:avLst/>
           </a:prstGeom>
           <a:solidFill>
-            <a:srgbClr val="3182F6"/>
+            <a:srgbClr val="585ECE"/>
           </a:solidFill>
           <a:ln>
             <a:noFill/>
@@ -4372,7 +4372,7 @@
             <a:pPr>
               <a:defRPr sz="1500" b="1">
                 <a:solidFill>
-                  <a:srgbClr val="0F172A"/>
+                  <a:srgbClr val="0A0A0A"/>
                 </a:solidFill>
               </a:defRPr>
             </a:pPr>
@@ -4410,7 +4410,7 @@
               </a:lnSpc>
               <a:defRPr sz="1100">
                 <a:solidFill>
-                  <a:srgbClr val="475569"/>
+                  <a:srgbClr val="52525B"/>
                 </a:solidFill>
               </a:defRPr>
             </a:pPr>
@@ -4568,7 +4568,7 @@
             <a:pPr>
               <a:defRPr sz="1500" b="1">
                 <a:solidFill>
-                  <a:srgbClr val="0F172A"/>
+                  <a:srgbClr val="0A0A0A"/>
                 </a:solidFill>
               </a:defRPr>
             </a:pPr>
@@ -4606,7 +4606,7 @@
               </a:lnSpc>
               <a:defRPr sz="1100">
                 <a:solidFill>
-                  <a:srgbClr val="475569"/>
+                  <a:srgbClr val="52525B"/>
                 </a:solidFill>
               </a:defRPr>
             </a:pPr>
@@ -4635,7 +4635,7 @@
           </a:solidFill>
           <a:ln w="19050">
             <a:solidFill>
-              <a:srgbClr val="3182F6"/>
+              <a:srgbClr val="585ECE"/>
             </a:solidFill>
           </a:ln>
         </p:spPr>
@@ -4686,7 +4686,7 @@
             <a:pPr>
               <a:defRPr sz="1100" b="1">
                 <a:solidFill>
-                  <a:srgbClr val="3182F6"/>
+                  <a:srgbClr val="585ECE"/>
                 </a:solidFill>
               </a:defRPr>
             </a:pPr>
@@ -4698,7 +4698,7 @@
             <a:pPr>
               <a:defRPr sz="950">
                 <a:solidFill>
-                  <a:srgbClr val="475569"/>
+                  <a:srgbClr val="52525B"/>
                 </a:solidFill>
               </a:defRPr>
             </a:pPr>
@@ -4745,7 +4745,7 @@
             <a:avLst/>
           </a:prstGeom>
           <a:solidFill>
-            <a:srgbClr val="F8FAFC"/>
+            <a:srgbClr val="F4F4F6"/>
           </a:solidFill>
           <a:ln>
             <a:noFill/>
@@ -4788,11 +4788,11 @@
             <a:avLst/>
           </a:prstGeom>
           <a:solidFill>
-            <a:srgbClr val="EEF4FF"/>
+            <a:srgbClr val="F4F5FF"/>
           </a:solidFill>
           <a:ln w="12700">
             <a:solidFill>
-              <a:srgbClr val="3182F6"/>
+              <a:srgbClr val="585ECE"/>
             </a:solidFill>
           </a:ln>
         </p:spPr>
@@ -4843,7 +4843,7 @@
             <a:pPr>
               <a:defRPr sz="1000" b="1">
                 <a:solidFill>
-                  <a:srgbClr val="3182F6"/>
+                  <a:srgbClr val="585ECE"/>
                 </a:solidFill>
                 <a:latin typeface="Pretendard"/>
               </a:defRPr>
@@ -4879,7 +4879,7 @@
             <a:pPr>
               <a:defRPr sz="2300" b="1">
                 <a:solidFill>
-                  <a:srgbClr val="0F172A"/>
+                  <a:srgbClr val="0A0A0A"/>
                 </a:solidFill>
                 <a:latin typeface="Pretendard"/>
               </a:defRPr>
@@ -4915,7 +4915,7 @@
             <a:pPr>
               <a:defRPr sz="1200">
                 <a:solidFill>
-                  <a:srgbClr val="475569"/>
+                  <a:srgbClr val="52525B"/>
                 </a:solidFill>
                 <a:latin typeface="Pretendard"/>
               </a:defRPr>
@@ -4951,7 +4951,7 @@
             <a:pPr>
               <a:defRPr sz="900">
                 <a:solidFill>
-                  <a:srgbClr val="64748B"/>
+                  <a:srgbClr val="71717A"/>
                 </a:solidFill>
                 <a:latin typeface="Pretendard"/>
               </a:defRPr>
@@ -4987,7 +4987,7 @@
             <a:pPr algn="r">
               <a:defRPr sz="1000" b="1">
                 <a:solidFill>
-                  <a:srgbClr val="3182F6"/>
+                  <a:srgbClr val="585ECE"/>
                 </a:solidFill>
                 <a:latin typeface="Pretendard"/>
               </a:defRPr>
@@ -5013,11 +5013,11 @@
             <a:avLst/>
           </a:prstGeom>
           <a:solidFill>
-            <a:srgbClr val="0F172A"/>
+            <a:srgbClr val="0A0A0A"/>
           </a:solidFill>
           <a:ln w="25400">
             <a:solidFill>
-              <a:srgbClr val="3182F6"/>
+              <a:srgbClr val="585ECE"/>
             </a:solidFill>
           </a:ln>
         </p:spPr>
@@ -5116,7 +5116,7 @@
           </a:solidFill>
           <a:ln w="22860">
             <a:solidFill>
-              <a:srgbClr val="3182F6"/>
+              <a:srgbClr val="585ECE"/>
             </a:solidFill>
           </a:ln>
         </p:spPr>
@@ -5167,7 +5167,7 @@
             <a:pPr>
               <a:defRPr sz="1100" b="1">
                 <a:solidFill>
-                  <a:srgbClr val="3182F6"/>
+                  <a:srgbClr val="585ECE"/>
                 </a:solidFill>
               </a:defRPr>
             </a:pPr>
@@ -5202,7 +5202,7 @@
             <a:pPr>
               <a:defRPr sz="1600" b="1">
                 <a:solidFill>
-                  <a:srgbClr val="0F172A"/>
+                  <a:srgbClr val="0A0A0A"/>
                 </a:solidFill>
               </a:defRPr>
             </a:pPr>
@@ -5240,7 +5240,7 @@
               </a:lnSpc>
               <a:defRPr sz="1100">
                 <a:solidFill>
-                  <a:srgbClr val="475569"/>
+                  <a:srgbClr val="52525B"/>
                 </a:solidFill>
               </a:defRPr>
             </a:pPr>
@@ -5355,7 +5355,7 @@
             <a:pPr>
               <a:defRPr sz="1600" b="1">
                 <a:solidFill>
-                  <a:srgbClr val="0F172A"/>
+                  <a:srgbClr val="0A0A0A"/>
                 </a:solidFill>
               </a:defRPr>
             </a:pPr>
@@ -5393,7 +5393,7 @@
               </a:lnSpc>
               <a:defRPr sz="1100">
                 <a:solidFill>
-                  <a:srgbClr val="475569"/>
+                  <a:srgbClr val="52525B"/>
                 </a:solidFill>
               </a:defRPr>
             </a:pPr>
@@ -5422,7 +5422,7 @@
           </a:solidFill>
           <a:ln w="22860">
             <a:solidFill>
-              <a:srgbClr val="03C75A"/>
+              <a:srgbClr val="10B981"/>
             </a:solidFill>
           </a:ln>
         </p:spPr>
@@ -5473,7 +5473,7 @@
             <a:pPr>
               <a:defRPr sz="1100" b="1">
                 <a:solidFill>
-                  <a:srgbClr val="03C75A"/>
+                  <a:srgbClr val="10B981"/>
                 </a:solidFill>
               </a:defRPr>
             </a:pPr>
@@ -5508,7 +5508,7 @@
             <a:pPr>
               <a:defRPr sz="1600" b="1">
                 <a:solidFill>
-                  <a:srgbClr val="0F172A"/>
+                  <a:srgbClr val="0A0A0A"/>
                 </a:solidFill>
               </a:defRPr>
             </a:pPr>
@@ -5546,7 +5546,7 @@
               </a:lnSpc>
               <a:defRPr sz="1100">
                 <a:solidFill>
-                  <a:srgbClr val="475569"/>
+                  <a:srgbClr val="52525B"/>
                 </a:solidFill>
               </a:defRPr>
             </a:pPr>
@@ -5589,7 +5589,7 @@
             <a:avLst/>
           </a:prstGeom>
           <a:solidFill>
-            <a:srgbClr val="F8FAFC"/>
+            <a:srgbClr val="F4F4F6"/>
           </a:solidFill>
           <a:ln>
             <a:noFill/>
@@ -5632,11 +5632,11 @@
             <a:avLst/>
           </a:prstGeom>
           <a:solidFill>
-            <a:srgbClr val="EEF4FF"/>
+            <a:srgbClr val="F4F5FF"/>
           </a:solidFill>
           <a:ln w="12700">
             <a:solidFill>
-              <a:srgbClr val="3182F6"/>
+              <a:srgbClr val="585ECE"/>
             </a:solidFill>
           </a:ln>
         </p:spPr>
@@ -5687,7 +5687,7 @@
             <a:pPr>
               <a:defRPr sz="1000" b="1">
                 <a:solidFill>
-                  <a:srgbClr val="3182F6"/>
+                  <a:srgbClr val="585ECE"/>
                 </a:solidFill>
                 <a:latin typeface="Pretendard"/>
               </a:defRPr>
@@ -5723,7 +5723,7 @@
             <a:pPr>
               <a:defRPr sz="2300" b="1">
                 <a:solidFill>
-                  <a:srgbClr val="0F172A"/>
+                  <a:srgbClr val="0A0A0A"/>
                 </a:solidFill>
                 <a:latin typeface="Pretendard"/>
               </a:defRPr>
@@ -5759,7 +5759,7 @@
             <a:pPr>
               <a:defRPr sz="1200">
                 <a:solidFill>
-                  <a:srgbClr val="475569"/>
+                  <a:srgbClr val="52525B"/>
                 </a:solidFill>
                 <a:latin typeface="Pretendard"/>
               </a:defRPr>
@@ -5795,7 +5795,7 @@
             <a:pPr>
               <a:defRPr sz="900">
                 <a:solidFill>
-                  <a:srgbClr val="64748B"/>
+                  <a:srgbClr val="71717A"/>
                 </a:solidFill>
                 <a:latin typeface="Pretendard"/>
               </a:defRPr>
@@ -5831,7 +5831,7 @@
             <a:pPr algn="r">
               <a:defRPr sz="1000" b="1">
                 <a:solidFill>
-                  <a:srgbClr val="3182F6"/>
+                  <a:srgbClr val="585ECE"/>
                 </a:solidFill>
                 <a:latin typeface="Pretendard"/>
               </a:defRPr>
@@ -5861,7 +5861,7 @@
           </a:solidFill>
           <a:ln w="15240">
             <a:solidFill>
-              <a:srgbClr val="3182F6"/>
+              <a:srgbClr val="585ECE"/>
             </a:solidFill>
           </a:ln>
         </p:spPr>
@@ -5902,7 +5902,7 @@
             <a:avLst/>
           </a:prstGeom>
           <a:solidFill>
-            <a:srgbClr val="3182F6"/>
+            <a:srgbClr val="585ECE"/>
           </a:solidFill>
           <a:ln>
             <a:noFill/>
@@ -5990,7 +5990,7 @@
             <a:pPr>
               <a:defRPr sz="1300" b="1">
                 <a:solidFill>
-                  <a:srgbClr val="3182F6"/>
+                  <a:srgbClr val="585ECE"/>
                 </a:solidFill>
               </a:defRPr>
             </a:pPr>
@@ -6002,7 +6002,7 @@
             <a:pPr>
               <a:defRPr sz="1000">
                 <a:solidFill>
-                  <a:srgbClr val="475569"/>
+                  <a:srgbClr val="52525B"/>
                 </a:solidFill>
               </a:defRPr>
             </a:pPr>
@@ -6031,7 +6031,7 @@
           </a:solidFill>
           <a:ln w="15240">
             <a:solidFill>
-              <a:srgbClr val="3182F6"/>
+              <a:srgbClr val="585ECE"/>
             </a:solidFill>
           </a:ln>
         </p:spPr>
@@ -6072,7 +6072,7 @@
             <a:avLst/>
           </a:prstGeom>
           <a:solidFill>
-            <a:srgbClr val="3182F6"/>
+            <a:srgbClr val="585ECE"/>
           </a:solidFill>
           <a:ln>
             <a:noFill/>
@@ -6160,7 +6160,7 @@
             <a:pPr>
               <a:defRPr sz="1300" b="1">
                 <a:solidFill>
-                  <a:srgbClr val="3182F6"/>
+                  <a:srgbClr val="585ECE"/>
                 </a:solidFill>
               </a:defRPr>
             </a:pPr>
@@ -6172,7 +6172,7 @@
             <a:pPr>
               <a:defRPr sz="1000">
                 <a:solidFill>
-                  <a:srgbClr val="475569"/>
+                  <a:srgbClr val="52525B"/>
                 </a:solidFill>
               </a:defRPr>
             </a:pPr>
@@ -6201,7 +6201,7 @@
           </a:solidFill>
           <a:ln w="15240">
             <a:solidFill>
-              <a:srgbClr val="3182F6"/>
+              <a:srgbClr val="585ECE"/>
             </a:solidFill>
           </a:ln>
         </p:spPr>
@@ -6242,7 +6242,7 @@
             <a:avLst/>
           </a:prstGeom>
           <a:solidFill>
-            <a:srgbClr val="3182F6"/>
+            <a:srgbClr val="585ECE"/>
           </a:solidFill>
           <a:ln>
             <a:noFill/>
@@ -6330,7 +6330,7 @@
             <a:pPr>
               <a:defRPr sz="1300" b="1">
                 <a:solidFill>
-                  <a:srgbClr val="3182F6"/>
+                  <a:srgbClr val="585ECE"/>
                 </a:solidFill>
               </a:defRPr>
             </a:pPr>
@@ -6342,7 +6342,7 @@
             <a:pPr>
               <a:defRPr sz="1000">
                 <a:solidFill>
-                  <a:srgbClr val="475569"/>
+                  <a:srgbClr val="52525B"/>
                 </a:solidFill>
               </a:defRPr>
             </a:pPr>
@@ -6371,7 +6371,7 @@
           </a:solidFill>
           <a:ln w="15240">
             <a:solidFill>
-              <a:srgbClr val="3182F6"/>
+              <a:srgbClr val="585ECE"/>
             </a:solidFill>
           </a:ln>
         </p:spPr>
@@ -6412,7 +6412,7 @@
             <a:avLst/>
           </a:prstGeom>
           <a:solidFill>
-            <a:srgbClr val="3182F6"/>
+            <a:srgbClr val="585ECE"/>
           </a:solidFill>
           <a:ln>
             <a:noFill/>
@@ -6500,7 +6500,7 @@
             <a:pPr>
               <a:defRPr sz="1300" b="1">
                 <a:solidFill>
-                  <a:srgbClr val="3182F6"/>
+                  <a:srgbClr val="585ECE"/>
                 </a:solidFill>
               </a:defRPr>
             </a:pPr>
@@ -6512,7 +6512,7 @@
             <a:pPr>
               <a:defRPr sz="1000">
                 <a:solidFill>
-                  <a:srgbClr val="475569"/>
+                  <a:srgbClr val="52525B"/>
                 </a:solidFill>
               </a:defRPr>
             </a:pPr>
@@ -6682,7 +6682,7 @@
             <a:pPr>
               <a:defRPr sz="1000">
                 <a:solidFill>
-                  <a:srgbClr val="475569"/>
+                  <a:srgbClr val="52525B"/>
                 </a:solidFill>
               </a:defRPr>
             </a:pPr>
@@ -6852,7 +6852,7 @@
             <a:pPr>
               <a:defRPr sz="1000">
                 <a:solidFill>
-                  <a:srgbClr val="475569"/>
+                  <a:srgbClr val="52525B"/>
                 </a:solidFill>
               </a:defRPr>
             </a:pPr>
@@ -6944,7 +6944,7 @@
             <a:pPr>
               <a:defRPr sz="1200" b="1">
                 <a:solidFill>
-                  <a:srgbClr val="1E293B"/>
+                  <a:srgbClr val="18181B"/>
                 </a:solidFill>
               </a:defRPr>
             </a:pPr>
@@ -6957,7 +6957,7 @@
             <a:pPr>
               <a:defRPr sz="1050">
                 <a:solidFill>
-                  <a:srgbClr val="475569"/>
+                  <a:srgbClr val="52525B"/>
                 </a:solidFill>
               </a:defRPr>
             </a:pPr>
@@ -7035,7 +7035,7 @@
             <a:pPr>
               <a:defRPr sz="1050" b="1">
                 <a:solidFill>
-                  <a:srgbClr val="1E293B"/>
+                  <a:srgbClr val="18181B"/>
                 </a:solidFill>
               </a:defRPr>
             </a:pPr>
@@ -7113,7 +7113,7 @@
             <a:pPr>
               <a:defRPr sz="1050" b="1">
                 <a:solidFill>
-                  <a:srgbClr val="1E293B"/>
+                  <a:srgbClr val="18181B"/>
                 </a:solidFill>
               </a:defRPr>
             </a:pPr>
@@ -7191,7 +7191,7 @@
             <a:pPr>
               <a:defRPr sz="1050" b="1">
                 <a:solidFill>
-                  <a:srgbClr val="1E293B"/>
+                  <a:srgbClr val="18181B"/>
                 </a:solidFill>
               </a:defRPr>
             </a:pPr>
@@ -7234,7 +7234,7 @@
             <a:avLst/>
           </a:prstGeom>
           <a:solidFill>
-            <a:srgbClr val="F8FAFC"/>
+            <a:srgbClr val="F4F4F6"/>
           </a:solidFill>
           <a:ln>
             <a:noFill/>
@@ -7277,11 +7277,11 @@
             <a:avLst/>
           </a:prstGeom>
           <a:solidFill>
-            <a:srgbClr val="EEF4FF"/>
+            <a:srgbClr val="F4F5FF"/>
           </a:solidFill>
           <a:ln w="12700">
             <a:solidFill>
-              <a:srgbClr val="3182F6"/>
+              <a:srgbClr val="585ECE"/>
             </a:solidFill>
           </a:ln>
         </p:spPr>
@@ -7332,7 +7332,7 @@
             <a:pPr>
               <a:defRPr sz="1000" b="1">
                 <a:solidFill>
-                  <a:srgbClr val="3182F6"/>
+                  <a:srgbClr val="585ECE"/>
                 </a:solidFill>
                 <a:latin typeface="Pretendard"/>
               </a:defRPr>
@@ -7368,7 +7368,7 @@
             <a:pPr>
               <a:defRPr sz="2300" b="1">
                 <a:solidFill>
-                  <a:srgbClr val="0F172A"/>
+                  <a:srgbClr val="0A0A0A"/>
                 </a:solidFill>
                 <a:latin typeface="Pretendard"/>
               </a:defRPr>
@@ -7404,7 +7404,7 @@
             <a:pPr>
               <a:defRPr sz="1200">
                 <a:solidFill>
-                  <a:srgbClr val="475569"/>
+                  <a:srgbClr val="52525B"/>
                 </a:solidFill>
                 <a:latin typeface="Pretendard"/>
               </a:defRPr>
@@ -7440,7 +7440,7 @@
             <a:pPr>
               <a:defRPr sz="900">
                 <a:solidFill>
-                  <a:srgbClr val="64748B"/>
+                  <a:srgbClr val="71717A"/>
                 </a:solidFill>
                 <a:latin typeface="Pretendard"/>
               </a:defRPr>
@@ -7476,7 +7476,7 @@
             <a:pPr algn="r">
               <a:defRPr sz="1000" b="1">
                 <a:solidFill>
-                  <a:srgbClr val="3182F6"/>
+                  <a:srgbClr val="585ECE"/>
                 </a:solidFill>
                 <a:latin typeface="Pretendard"/>
               </a:defRPr>
@@ -7506,7 +7506,7 @@
           </a:solidFill>
           <a:ln w="15240">
             <a:solidFill>
-              <a:srgbClr val="E2E8F0"/>
+              <a:srgbClr val="E4E4E7"/>
             </a:solidFill>
           </a:ln>
         </p:spPr>
@@ -7557,7 +7557,7 @@
             <a:pPr>
               <a:defRPr sz="1200" b="1">
                 <a:solidFill>
-                  <a:srgbClr val="64748B"/>
+                  <a:srgbClr val="71717A"/>
                 </a:solidFill>
               </a:defRPr>
             </a:pPr>
@@ -7582,11 +7582,11 @@
             <a:avLst/>
           </a:prstGeom>
           <a:solidFill>
-            <a:srgbClr val="F8FAFC"/>
+            <a:srgbClr val="F4F4F6"/>
           </a:solidFill>
           <a:ln w="15240">
             <a:solidFill>
-              <a:srgbClr val="E2E8F0"/>
+              <a:srgbClr val="E4E4E7"/>
             </a:solidFill>
           </a:ln>
         </p:spPr>
@@ -7637,7 +7637,7 @@
             <a:pPr>
               <a:defRPr sz="1100" b="1">
                 <a:solidFill>
-                  <a:srgbClr val="1E293B"/>
+                  <a:srgbClr val="18181B"/>
                 </a:solidFill>
               </a:defRPr>
             </a:pPr>
@@ -7649,7 +7649,7 @@
             <a:pPr>
               <a:defRPr sz="950">
                 <a:solidFill>
-                  <a:srgbClr val="64748B"/>
+                  <a:srgbClr val="71717A"/>
                 </a:solidFill>
               </a:defRPr>
             </a:pPr>
@@ -7674,11 +7674,11 @@
             <a:avLst/>
           </a:prstGeom>
           <a:solidFill>
-            <a:srgbClr val="F8FAFC"/>
+            <a:srgbClr val="F4F4F6"/>
           </a:solidFill>
           <a:ln w="15240">
             <a:solidFill>
-              <a:srgbClr val="E2E8F0"/>
+              <a:srgbClr val="E4E4E7"/>
             </a:solidFill>
           </a:ln>
         </p:spPr>
@@ -7729,7 +7729,7 @@
             <a:pPr>
               <a:defRPr sz="1100" b="1">
                 <a:solidFill>
-                  <a:srgbClr val="1E293B"/>
+                  <a:srgbClr val="18181B"/>
                 </a:solidFill>
               </a:defRPr>
             </a:pPr>
@@ -7741,7 +7741,7 @@
             <a:pPr>
               <a:defRPr sz="950">
                 <a:solidFill>
-                  <a:srgbClr val="64748B"/>
+                  <a:srgbClr val="71717A"/>
                 </a:solidFill>
               </a:defRPr>
             </a:pPr>
@@ -7766,11 +7766,11 @@
             <a:avLst/>
           </a:prstGeom>
           <a:solidFill>
-            <a:srgbClr val="F8FAFC"/>
+            <a:srgbClr val="F4F4F6"/>
           </a:solidFill>
           <a:ln w="15240">
             <a:solidFill>
-              <a:srgbClr val="E2E8F0"/>
+              <a:srgbClr val="E4E4E7"/>
             </a:solidFill>
           </a:ln>
         </p:spPr>
@@ -7821,7 +7821,7 @@
             <a:pPr>
               <a:defRPr sz="1100" b="1">
                 <a:solidFill>
-                  <a:srgbClr val="1E293B"/>
+                  <a:srgbClr val="18181B"/>
                 </a:solidFill>
               </a:defRPr>
             </a:pPr>
@@ -7833,7 +7833,7 @@
             <a:pPr>
               <a:defRPr sz="950">
                 <a:solidFill>
-                  <a:srgbClr val="64748B"/>
+                  <a:srgbClr val="71717A"/>
                 </a:solidFill>
               </a:defRPr>
             </a:pPr>
@@ -7858,11 +7858,11 @@
             <a:avLst/>
           </a:prstGeom>
           <a:solidFill>
-            <a:srgbClr val="F8FAFC"/>
+            <a:srgbClr val="F4F4F6"/>
           </a:solidFill>
           <a:ln w="15240">
             <a:solidFill>
-              <a:srgbClr val="E2E8F0"/>
+              <a:srgbClr val="E4E4E7"/>
             </a:solidFill>
           </a:ln>
         </p:spPr>
@@ -7913,7 +7913,7 @@
             <a:pPr>
               <a:defRPr sz="1100" b="1">
                 <a:solidFill>
-                  <a:srgbClr val="1E293B"/>
+                  <a:srgbClr val="18181B"/>
                 </a:solidFill>
               </a:defRPr>
             </a:pPr>
@@ -7925,7 +7925,7 @@
             <a:pPr>
               <a:defRPr sz="950">
                 <a:solidFill>
-                  <a:srgbClr val="64748B"/>
+                  <a:srgbClr val="71717A"/>
                 </a:solidFill>
               </a:defRPr>
             </a:pPr>
@@ -7950,11 +7950,11 @@
             <a:avLst/>
           </a:prstGeom>
           <a:solidFill>
-            <a:srgbClr val="F8FAFC"/>
+            <a:srgbClr val="F4F4F6"/>
           </a:solidFill>
           <a:ln w="15240">
             <a:solidFill>
-              <a:srgbClr val="E2E8F0"/>
+              <a:srgbClr val="E4E4E7"/>
             </a:solidFill>
           </a:ln>
         </p:spPr>
@@ -8005,7 +8005,7 @@
             <a:pPr>
               <a:defRPr sz="1100" b="1">
                 <a:solidFill>
-                  <a:srgbClr val="1E293B"/>
+                  <a:srgbClr val="18181B"/>
                 </a:solidFill>
               </a:defRPr>
             </a:pPr>
@@ -8017,7 +8017,7 @@
             <a:pPr>
               <a:defRPr sz="950">
                 <a:solidFill>
-                  <a:srgbClr val="64748B"/>
+                  <a:srgbClr val="71717A"/>
                 </a:solidFill>
               </a:defRPr>
             </a:pPr>
@@ -8046,7 +8046,7 @@
           </a:solidFill>
           <a:ln w="27940">
             <a:solidFill>
-              <a:srgbClr val="3182F6"/>
+              <a:srgbClr val="585ECE"/>
             </a:solidFill>
           </a:ln>
         </p:spPr>
@@ -8097,7 +8097,7 @@
             <a:pPr>
               <a:defRPr sz="1250" b="1">
                 <a:solidFill>
-                  <a:srgbClr val="3182F6"/>
+                  <a:srgbClr val="585ECE"/>
                 </a:solidFill>
               </a:defRPr>
             </a:pPr>
@@ -8122,11 +8122,11 @@
             <a:avLst/>
           </a:prstGeom>
           <a:solidFill>
-            <a:srgbClr val="EEF4FF"/>
+            <a:srgbClr val="F4F5FF"/>
           </a:solidFill>
           <a:ln w="15240">
             <a:solidFill>
-              <a:srgbClr val="3182F6"/>
+              <a:srgbClr val="585ECE"/>
             </a:solidFill>
           </a:ln>
         </p:spPr>
@@ -8177,7 +8177,7 @@
             <a:pPr>
               <a:defRPr sz="1100" b="1">
                 <a:solidFill>
-                  <a:srgbClr val="3182F6"/>
+                  <a:srgbClr val="585ECE"/>
                 </a:solidFill>
               </a:defRPr>
             </a:pPr>
@@ -8189,7 +8189,7 @@
             <a:pPr>
               <a:defRPr sz="950">
                 <a:solidFill>
-                  <a:srgbClr val="1E293B"/>
+                  <a:srgbClr val="18181B"/>
                 </a:solidFill>
               </a:defRPr>
             </a:pPr>
@@ -8214,11 +8214,11 @@
             <a:avLst/>
           </a:prstGeom>
           <a:solidFill>
-            <a:srgbClr val="EEF4FF"/>
+            <a:srgbClr val="F4F5FF"/>
           </a:solidFill>
           <a:ln w="15240">
             <a:solidFill>
-              <a:srgbClr val="3182F6"/>
+              <a:srgbClr val="585ECE"/>
             </a:solidFill>
           </a:ln>
         </p:spPr>
@@ -8269,7 +8269,7 @@
             <a:pPr>
               <a:defRPr sz="1100" b="1">
                 <a:solidFill>
-                  <a:srgbClr val="3182F6"/>
+                  <a:srgbClr val="585ECE"/>
                 </a:solidFill>
               </a:defRPr>
             </a:pPr>
@@ -8281,7 +8281,7 @@
             <a:pPr>
               <a:defRPr sz="950">
                 <a:solidFill>
-                  <a:srgbClr val="1E293B"/>
+                  <a:srgbClr val="18181B"/>
                 </a:solidFill>
               </a:defRPr>
             </a:pPr>
@@ -8306,7 +8306,7 @@
             <a:avLst/>
           </a:prstGeom>
           <a:solidFill>
-            <a:srgbClr val="F3E8FF"/>
+            <a:srgbClr val="EBEBFC"/>
           </a:solidFill>
           <a:ln w="15240">
             <a:solidFill>
@@ -8373,7 +8373,7 @@
             <a:pPr>
               <a:defRPr sz="950">
                 <a:solidFill>
-                  <a:srgbClr val="1E293B"/>
+                  <a:srgbClr val="18181B"/>
                 </a:solidFill>
               </a:defRPr>
             </a:pPr>
@@ -8402,7 +8402,7 @@
           </a:solidFill>
           <a:ln w="15240">
             <a:solidFill>
-              <a:srgbClr val="03C75A"/>
+              <a:srgbClr val="10B981"/>
             </a:solidFill>
           </a:ln>
         </p:spPr>
@@ -8453,7 +8453,7 @@
             <a:pPr>
               <a:defRPr sz="1100" b="1">
                 <a:solidFill>
-                  <a:srgbClr val="03C75A"/>
+                  <a:srgbClr val="10B981"/>
                 </a:solidFill>
               </a:defRPr>
             </a:pPr>
@@ -8465,7 +8465,7 @@
             <a:pPr>
               <a:defRPr sz="950">
                 <a:solidFill>
-                  <a:srgbClr val="1E293B"/>
+                  <a:srgbClr val="18181B"/>
                 </a:solidFill>
               </a:defRPr>
             </a:pPr>
@@ -8557,7 +8557,7 @@
             <a:pPr>
               <a:defRPr sz="950">
                 <a:solidFill>
-                  <a:srgbClr val="1E293B"/>
+                  <a:srgbClr val="18181B"/>
                 </a:solidFill>
               </a:defRPr>
             </a:pPr>
@@ -8600,7 +8600,7 @@
             <a:avLst/>
           </a:prstGeom>
           <a:solidFill>
-            <a:srgbClr val="F8FAFC"/>
+            <a:srgbClr val="F4F4F6"/>
           </a:solidFill>
           <a:ln>
             <a:noFill/>
@@ -8643,11 +8643,11 @@
             <a:avLst/>
           </a:prstGeom>
           <a:solidFill>
-            <a:srgbClr val="EEF4FF"/>
+            <a:srgbClr val="F4F5FF"/>
           </a:solidFill>
           <a:ln w="12700">
             <a:solidFill>
-              <a:srgbClr val="3182F6"/>
+              <a:srgbClr val="585ECE"/>
             </a:solidFill>
           </a:ln>
         </p:spPr>
@@ -8698,7 +8698,7 @@
             <a:pPr>
               <a:defRPr sz="1000" b="1">
                 <a:solidFill>
-                  <a:srgbClr val="3182F6"/>
+                  <a:srgbClr val="585ECE"/>
                 </a:solidFill>
                 <a:latin typeface="Pretendard"/>
               </a:defRPr>
@@ -8734,7 +8734,7 @@
             <a:pPr>
               <a:defRPr sz="2300" b="1">
                 <a:solidFill>
-                  <a:srgbClr val="0F172A"/>
+                  <a:srgbClr val="0A0A0A"/>
                 </a:solidFill>
                 <a:latin typeface="Pretendard"/>
               </a:defRPr>
@@ -8770,7 +8770,7 @@
             <a:pPr>
               <a:defRPr sz="1200">
                 <a:solidFill>
-                  <a:srgbClr val="475569"/>
+                  <a:srgbClr val="52525B"/>
                 </a:solidFill>
                 <a:latin typeface="Pretendard"/>
               </a:defRPr>
@@ -8806,7 +8806,7 @@
             <a:pPr>
               <a:defRPr sz="900">
                 <a:solidFill>
-                  <a:srgbClr val="64748B"/>
+                  <a:srgbClr val="71717A"/>
                 </a:solidFill>
                 <a:latin typeface="Pretendard"/>
               </a:defRPr>
@@ -8842,7 +8842,7 @@
             <a:pPr algn="r">
               <a:defRPr sz="1000" b="1">
                 <a:solidFill>
-                  <a:srgbClr val="3182F6"/>
+                  <a:srgbClr val="585ECE"/>
                 </a:solidFill>
                 <a:latin typeface="Pretendard"/>
               </a:defRPr>
@@ -8872,7 +8872,7 @@
           </a:solidFill>
           <a:ln w="19050">
             <a:solidFill>
-              <a:srgbClr val="3182F6"/>
+              <a:srgbClr val="585ECE"/>
             </a:solidFill>
           </a:ln>
         </p:spPr>
@@ -8923,7 +8923,7 @@
             <a:pPr>
               <a:defRPr sz="1200" b="1">
                 <a:solidFill>
-                  <a:srgbClr val="0F172A"/>
+                  <a:srgbClr val="0A0A0A"/>
                 </a:solidFill>
               </a:defRPr>
             </a:pPr>
@@ -8948,7 +8948,7 @@
             <a:avLst/>
           </a:prstGeom>
           <a:solidFill>
-            <a:srgbClr val="F8FAFC"/>
+            <a:srgbClr val="F4F4F6"/>
           </a:solidFill>
           <a:ln>
             <a:noFill/>
@@ -9001,7 +9001,7 @@
             <a:pPr>
               <a:defRPr sz="1100" b="1">
                 <a:solidFill>
-                  <a:srgbClr val="64748B"/>
+                  <a:srgbClr val="71717A"/>
                 </a:solidFill>
               </a:defRPr>
             </a:pPr>
@@ -9026,7 +9026,7 @@
             <a:avLst/>
           </a:prstGeom>
           <a:solidFill>
-            <a:srgbClr val="64748B"/>
+            <a:srgbClr val="71717A"/>
           </a:solidFill>
           <a:ln>
             <a:noFill/>
@@ -9069,7 +9069,7 @@
             <a:avLst/>
           </a:prstGeom>
           <a:solidFill>
-            <a:srgbClr val="EEF4FF"/>
+            <a:srgbClr val="F4F5FF"/>
           </a:solidFill>
           <a:ln>
             <a:noFill/>
@@ -9122,7 +9122,7 @@
             <a:pPr>
               <a:defRPr sz="1150" b="1">
                 <a:solidFill>
-                  <a:srgbClr val="3182F6"/>
+                  <a:srgbClr val="585ECE"/>
                 </a:solidFill>
               </a:defRPr>
             </a:pPr>
@@ -9147,7 +9147,7 @@
             <a:avLst/>
           </a:prstGeom>
           <a:solidFill>
-            <a:srgbClr val="3182F6"/>
+            <a:srgbClr val="585ECE"/>
           </a:solidFill>
           <a:ln>
             <a:noFill/>
@@ -9225,7 +9225,7 @@
             <a:avLst/>
           </a:prstGeom>
           <a:solidFill>
-            <a:srgbClr val="F3E8FF"/>
+            <a:srgbClr val="EBEBFC"/>
           </a:solidFill>
           <a:ln w="15240">
             <a:solidFill>
@@ -9292,7 +9292,7 @@
             <a:pPr>
               <a:defRPr sz="1000">
                 <a:solidFill>
-                  <a:srgbClr val="475569"/>
+                  <a:srgbClr val="52525B"/>
                 </a:solidFill>
               </a:defRPr>
             </a:pPr>
@@ -9384,7 +9384,7 @@
             <a:pPr>
               <a:defRPr sz="1250" b="1">
                 <a:solidFill>
-                  <a:srgbClr val="0F172A"/>
+                  <a:srgbClr val="0A0A0A"/>
                 </a:solidFill>
               </a:defRPr>
             </a:pPr>
@@ -9396,7 +9396,7 @@
             <a:pPr>
               <a:defRPr sz="1000">
                 <a:solidFill>
-                  <a:srgbClr val="475569"/>
+                  <a:srgbClr val="52525B"/>
                 </a:solidFill>
               </a:defRPr>
             </a:pPr>
@@ -9488,7 +9488,7 @@
             <a:pPr>
               <a:defRPr sz="1250" b="1">
                 <a:solidFill>
-                  <a:srgbClr val="0F172A"/>
+                  <a:srgbClr val="0A0A0A"/>
                 </a:solidFill>
               </a:defRPr>
             </a:pPr>
@@ -9500,7 +9500,7 @@
             <a:pPr>
               <a:defRPr sz="1000">
                 <a:solidFill>
-                  <a:srgbClr val="475569"/>
+                  <a:srgbClr val="52525B"/>
                 </a:solidFill>
               </a:defRPr>
             </a:pPr>
@@ -9529,7 +9529,7 @@
           </a:solidFill>
           <a:ln w="19050">
             <a:solidFill>
-              <a:srgbClr val="03C75A"/>
+              <a:srgbClr val="10B981"/>
             </a:solidFill>
           </a:ln>
         </p:spPr>
@@ -9580,7 +9580,7 @@
             <a:pPr>
               <a:defRPr sz="2400" b="1">
                 <a:solidFill>
-                  <a:srgbClr val="03C75A"/>
+                  <a:srgbClr val="10B981"/>
                 </a:solidFill>
               </a:defRPr>
             </a:pPr>
@@ -9592,7 +9592,7 @@
             <a:pPr>
               <a:defRPr sz="1250" b="1">
                 <a:solidFill>
-                  <a:srgbClr val="0F172A"/>
+                  <a:srgbClr val="0A0A0A"/>
                 </a:solidFill>
               </a:defRPr>
             </a:pPr>
@@ -9604,7 +9604,7 @@
             <a:pPr>
               <a:defRPr sz="1000">
                 <a:solidFill>
-                  <a:srgbClr val="475569"/>
+                  <a:srgbClr val="52525B"/>
                 </a:solidFill>
               </a:defRPr>
             </a:pPr>
@@ -9647,7 +9647,7 @@
             <a:avLst/>
           </a:prstGeom>
           <a:solidFill>
-            <a:srgbClr val="F8FAFC"/>
+            <a:srgbClr val="F4F4F6"/>
           </a:solidFill>
           <a:ln>
             <a:noFill/>
@@ -9690,11 +9690,11 @@
             <a:avLst/>
           </a:prstGeom>
           <a:solidFill>
-            <a:srgbClr val="EEF4FF"/>
+            <a:srgbClr val="F4F5FF"/>
           </a:solidFill>
           <a:ln w="12700">
             <a:solidFill>
-              <a:srgbClr val="3182F6"/>
+              <a:srgbClr val="585ECE"/>
             </a:solidFill>
           </a:ln>
         </p:spPr>
@@ -9745,7 +9745,7 @@
             <a:pPr>
               <a:defRPr sz="1000" b="1">
                 <a:solidFill>
-                  <a:srgbClr val="3182F6"/>
+                  <a:srgbClr val="585ECE"/>
                 </a:solidFill>
                 <a:latin typeface="Pretendard"/>
               </a:defRPr>
@@ -9781,7 +9781,7 @@
             <a:pPr>
               <a:defRPr sz="2300" b="1">
                 <a:solidFill>
-                  <a:srgbClr val="0F172A"/>
+                  <a:srgbClr val="0A0A0A"/>
                 </a:solidFill>
                 <a:latin typeface="Pretendard"/>
               </a:defRPr>
@@ -9817,7 +9817,7 @@
             <a:pPr>
               <a:defRPr sz="1200">
                 <a:solidFill>
-                  <a:srgbClr val="475569"/>
+                  <a:srgbClr val="52525B"/>
                 </a:solidFill>
                 <a:latin typeface="Pretendard"/>
               </a:defRPr>
@@ -9853,7 +9853,7 @@
             <a:pPr>
               <a:defRPr sz="900">
                 <a:solidFill>
-                  <a:srgbClr val="64748B"/>
+                  <a:srgbClr val="71717A"/>
                 </a:solidFill>
                 <a:latin typeface="Pretendard"/>
               </a:defRPr>
@@ -9889,7 +9889,7 @@
             <a:pPr algn="r">
               <a:defRPr sz="1000" b="1">
                 <a:solidFill>
-                  <a:srgbClr val="3182F6"/>
+                  <a:srgbClr val="585ECE"/>
                 </a:solidFill>
                 <a:latin typeface="Pretendard"/>
               </a:defRPr>
@@ -9919,7 +9919,7 @@
           </a:solidFill>
           <a:ln w="22860">
             <a:solidFill>
-              <a:srgbClr val="3182F6"/>
+              <a:srgbClr val="585ECE"/>
             </a:solidFill>
           </a:ln>
         </p:spPr>
@@ -9960,7 +9960,7 @@
             <a:avLst/>
           </a:prstGeom>
           <a:solidFill>
-            <a:srgbClr val="3182F6"/>
+            <a:srgbClr val="585ECE"/>
           </a:solidFill>
           <a:ln>
             <a:noFill/>
@@ -10048,7 +10048,7 @@
             <a:pPr>
               <a:defRPr sz="1500" b="1">
                 <a:solidFill>
-                  <a:srgbClr val="0F172A"/>
+                  <a:srgbClr val="0A0A0A"/>
                 </a:solidFill>
               </a:defRPr>
             </a:pPr>
@@ -10063,7 +10063,7 @@
               </a:lnSpc>
               <a:defRPr sz="1100">
                 <a:solidFill>
-                  <a:srgbClr val="475569"/>
+                  <a:srgbClr val="52525B"/>
                 </a:solidFill>
               </a:defRPr>
             </a:pPr>
@@ -10225,7 +10225,7 @@
             <a:pPr>
               <a:defRPr sz="1500" b="1">
                 <a:solidFill>
-                  <a:srgbClr val="0F172A"/>
+                  <a:srgbClr val="0A0A0A"/>
                 </a:solidFill>
               </a:defRPr>
             </a:pPr>
@@ -10240,7 +10240,7 @@
               </a:lnSpc>
               <a:defRPr sz="1100">
                 <a:solidFill>
-                  <a:srgbClr val="475569"/>
+                  <a:srgbClr val="52525B"/>
                 </a:solidFill>
               </a:defRPr>
             </a:pPr>
@@ -10398,7 +10398,7 @@
             <a:pPr>
               <a:defRPr sz="1500" b="1">
                 <a:solidFill>
-                  <a:srgbClr val="0F172A"/>
+                  <a:srgbClr val="0A0A0A"/>
                 </a:solidFill>
               </a:defRPr>
             </a:pPr>
@@ -10413,7 +10413,7 @@
               </a:lnSpc>
               <a:defRPr sz="1100">
                 <a:solidFill>
-                  <a:srgbClr val="475569"/>
+                  <a:srgbClr val="52525B"/>
                 </a:solidFill>
               </a:defRPr>
             </a:pPr>
@@ -10442,7 +10442,7 @@
           </a:solidFill>
           <a:ln w="22860">
             <a:solidFill>
-              <a:srgbClr val="03C75A"/>
+              <a:srgbClr val="10B981"/>
             </a:solidFill>
           </a:ln>
         </p:spPr>
@@ -10483,7 +10483,7 @@
             <a:avLst/>
           </a:prstGeom>
           <a:solidFill>
-            <a:srgbClr val="03C75A"/>
+            <a:srgbClr val="10B981"/>
           </a:solidFill>
           <a:ln>
             <a:noFill/>
@@ -10571,7 +10571,7 @@
             <a:pPr>
               <a:defRPr sz="1500" b="1">
                 <a:solidFill>
-                  <a:srgbClr val="0F172A"/>
+                  <a:srgbClr val="0A0A0A"/>
                 </a:solidFill>
               </a:defRPr>
             </a:pPr>
@@ -10586,7 +10586,7 @@
               </a:lnSpc>
               <a:defRPr sz="1100">
                 <a:solidFill>
-                  <a:srgbClr val="475569"/>
+                  <a:srgbClr val="52525B"/>
                 </a:solidFill>
               </a:defRPr>
             </a:pPr>
@@ -10629,7 +10629,7 @@
             <a:avLst/>
           </a:prstGeom>
           <a:solidFill>
-            <a:srgbClr val="F8FAFC"/>
+            <a:srgbClr val="F4F4F6"/>
           </a:solidFill>
           <a:ln>
             <a:noFill/>
@@ -10672,11 +10672,11 @@
             <a:avLst/>
           </a:prstGeom>
           <a:solidFill>
-            <a:srgbClr val="EEF4FF"/>
+            <a:srgbClr val="F4F5FF"/>
           </a:solidFill>
           <a:ln w="12700">
             <a:solidFill>
-              <a:srgbClr val="3182F6"/>
+              <a:srgbClr val="585ECE"/>
             </a:solidFill>
           </a:ln>
         </p:spPr>
@@ -10727,7 +10727,7 @@
             <a:pPr>
               <a:defRPr sz="1000" b="1">
                 <a:solidFill>
-                  <a:srgbClr val="3182F6"/>
+                  <a:srgbClr val="585ECE"/>
                 </a:solidFill>
                 <a:latin typeface="Pretendard"/>
               </a:defRPr>
@@ -10763,7 +10763,7 @@
             <a:pPr>
               <a:defRPr sz="2300" b="1">
                 <a:solidFill>
-                  <a:srgbClr val="0F172A"/>
+                  <a:srgbClr val="0A0A0A"/>
                 </a:solidFill>
                 <a:latin typeface="Pretendard"/>
               </a:defRPr>
@@ -10799,7 +10799,7 @@
             <a:pPr>
               <a:defRPr sz="1200">
                 <a:solidFill>
-                  <a:srgbClr val="475569"/>
+                  <a:srgbClr val="52525B"/>
                 </a:solidFill>
                 <a:latin typeface="Pretendard"/>
               </a:defRPr>
@@ -10835,7 +10835,7 @@
             <a:pPr>
               <a:defRPr sz="900">
                 <a:solidFill>
-                  <a:srgbClr val="64748B"/>
+                  <a:srgbClr val="71717A"/>
                 </a:solidFill>
                 <a:latin typeface="Pretendard"/>
               </a:defRPr>
@@ -10871,7 +10871,7 @@
             <a:pPr algn="r">
               <a:defRPr sz="1000" b="1">
                 <a:solidFill>
-                  <a:srgbClr val="3182F6"/>
+                  <a:srgbClr val="585ECE"/>
                 </a:solidFill>
                 <a:latin typeface="Pretendard"/>
               </a:defRPr>
@@ -10901,7 +10901,7 @@
           </a:solidFill>
           <a:ln w="15240">
             <a:solidFill>
-              <a:srgbClr val="E2E8F0"/>
+              <a:srgbClr val="E4E4E7"/>
             </a:solidFill>
           </a:ln>
         </p:spPr>
@@ -10942,7 +10942,7 @@
             <a:avLst/>
           </a:prstGeom>
           <a:solidFill>
-            <a:srgbClr val="F8FAFC"/>
+            <a:srgbClr val="F4F4F6"/>
           </a:solidFill>
           <a:ln>
             <a:noFill/>
@@ -10995,7 +10995,7 @@
             <a:pPr algn="ctr">
               <a:defRPr sz="1100" b="1">
                 <a:solidFill>
-                  <a:srgbClr val="0F172A"/>
+                  <a:srgbClr val="0A0A0A"/>
                 </a:solidFill>
               </a:defRPr>
             </a:pPr>
@@ -11030,7 +11030,7 @@
             <a:pPr algn="ctr">
               <a:defRPr sz="1100" b="1">
                 <a:solidFill>
-                  <a:srgbClr val="0F172A"/>
+                  <a:srgbClr val="0A0A0A"/>
                 </a:solidFill>
               </a:defRPr>
             </a:pPr>
@@ -11065,7 +11065,7 @@
             <a:pPr algn="ctr">
               <a:defRPr sz="1100" b="1">
                 <a:solidFill>
-                  <a:srgbClr val="0F172A"/>
+                  <a:srgbClr val="0A0A0A"/>
                 </a:solidFill>
               </a:defRPr>
             </a:pPr>
@@ -11100,7 +11100,7 @@
             <a:pPr algn="ctr">
               <a:defRPr sz="1100" b="1">
                 <a:solidFill>
-                  <a:srgbClr val="0F172A"/>
+                  <a:srgbClr val="0A0A0A"/>
                 </a:solidFill>
               </a:defRPr>
             </a:pPr>
@@ -11135,7 +11135,7 @@
             <a:pPr algn="ctr">
               <a:defRPr sz="1100" b="1">
                 <a:solidFill>
-                  <a:srgbClr val="3182F6"/>
+                  <a:srgbClr val="585ECE"/>
                 </a:solidFill>
               </a:defRPr>
             </a:pPr>
@@ -11160,11 +11160,11 @@
             <a:avLst/>
           </a:prstGeom>
           <a:solidFill>
-            <a:srgbClr val="EEF4FF"/>
+            <a:srgbClr val="F4F5FF"/>
           </a:solidFill>
           <a:ln w="15240">
             <a:solidFill>
-              <a:srgbClr val="3182F6"/>
+              <a:srgbClr val="585ECE"/>
             </a:solidFill>
           </a:ln>
         </p:spPr>
@@ -11215,7 +11215,7 @@
             <a:pPr algn="l">
               <a:defRPr sz="1050" b="1">
                 <a:solidFill>
-                  <a:srgbClr val="1E293B"/>
+                  <a:srgbClr val="18181B"/>
                 </a:solidFill>
               </a:defRPr>
             </a:pPr>
@@ -11250,7 +11250,7 @@
             <a:pPr algn="ctr">
               <a:defRPr sz="1050">
                 <a:solidFill>
-                  <a:srgbClr val="475569"/>
+                  <a:srgbClr val="52525B"/>
                 </a:solidFill>
               </a:defRPr>
             </a:pPr>
@@ -11285,7 +11285,7 @@
             <a:pPr algn="ctr">
               <a:defRPr sz="1050">
                 <a:solidFill>
-                  <a:srgbClr val="475569"/>
+                  <a:srgbClr val="52525B"/>
                 </a:solidFill>
               </a:defRPr>
             </a:pPr>
@@ -11320,7 +11320,7 @@
             <a:pPr algn="ctr">
               <a:defRPr sz="1050">
                 <a:solidFill>
-                  <a:srgbClr val="475569"/>
+                  <a:srgbClr val="52525B"/>
                 </a:solidFill>
               </a:defRPr>
             </a:pPr>
@@ -11355,7 +11355,7 @@
             <a:pPr algn="ctr">
               <a:defRPr sz="1050" b="1">
                 <a:solidFill>
-                  <a:srgbClr val="3182F6"/>
+                  <a:srgbClr val="585ECE"/>
                 </a:solidFill>
               </a:defRPr>
             </a:pPr>
@@ -11380,11 +11380,11 @@
             <a:avLst/>
           </a:prstGeom>
           <a:solidFill>
-            <a:srgbClr val="EEF4FF"/>
+            <a:srgbClr val="F4F5FF"/>
           </a:solidFill>
           <a:ln w="15240">
             <a:solidFill>
-              <a:srgbClr val="3182F6"/>
+              <a:srgbClr val="585ECE"/>
             </a:solidFill>
           </a:ln>
         </p:spPr>
@@ -11435,7 +11435,7 @@
             <a:pPr algn="l">
               <a:defRPr sz="1050" b="1">
                 <a:solidFill>
-                  <a:srgbClr val="1E293B"/>
+                  <a:srgbClr val="18181B"/>
                 </a:solidFill>
               </a:defRPr>
             </a:pPr>
@@ -11470,7 +11470,7 @@
             <a:pPr algn="ctr">
               <a:defRPr sz="1050">
                 <a:solidFill>
-                  <a:srgbClr val="475569"/>
+                  <a:srgbClr val="52525B"/>
                 </a:solidFill>
               </a:defRPr>
             </a:pPr>
@@ -11505,7 +11505,7 @@
             <a:pPr algn="ctr">
               <a:defRPr sz="1050">
                 <a:solidFill>
-                  <a:srgbClr val="475569"/>
+                  <a:srgbClr val="52525B"/>
                 </a:solidFill>
               </a:defRPr>
             </a:pPr>
@@ -11540,7 +11540,7 @@
             <a:pPr algn="ctr">
               <a:defRPr sz="1050">
                 <a:solidFill>
-                  <a:srgbClr val="475569"/>
+                  <a:srgbClr val="52525B"/>
                 </a:solidFill>
               </a:defRPr>
             </a:pPr>
@@ -11575,7 +11575,7 @@
             <a:pPr algn="ctr">
               <a:defRPr sz="1050" b="1">
                 <a:solidFill>
-                  <a:srgbClr val="3182F6"/>
+                  <a:srgbClr val="585ECE"/>
                 </a:solidFill>
               </a:defRPr>
             </a:pPr>
@@ -11600,11 +11600,11 @@
             <a:avLst/>
           </a:prstGeom>
           <a:solidFill>
-            <a:srgbClr val="EEF4FF"/>
+            <a:srgbClr val="F4F5FF"/>
           </a:solidFill>
           <a:ln w="15240">
             <a:solidFill>
-              <a:srgbClr val="3182F6"/>
+              <a:srgbClr val="585ECE"/>
             </a:solidFill>
           </a:ln>
         </p:spPr>
@@ -11655,7 +11655,7 @@
             <a:pPr algn="l">
               <a:defRPr sz="1050" b="1">
                 <a:solidFill>
-                  <a:srgbClr val="1E293B"/>
+                  <a:srgbClr val="18181B"/>
                 </a:solidFill>
               </a:defRPr>
             </a:pPr>
@@ -11690,7 +11690,7 @@
             <a:pPr algn="ctr">
               <a:defRPr sz="1050">
                 <a:solidFill>
-                  <a:srgbClr val="475569"/>
+                  <a:srgbClr val="52525B"/>
                 </a:solidFill>
               </a:defRPr>
             </a:pPr>
@@ -11725,7 +11725,7 @@
             <a:pPr algn="ctr">
               <a:defRPr sz="1050">
                 <a:solidFill>
-                  <a:srgbClr val="475569"/>
+                  <a:srgbClr val="52525B"/>
                 </a:solidFill>
               </a:defRPr>
             </a:pPr>
@@ -11760,7 +11760,7 @@
             <a:pPr algn="ctr">
               <a:defRPr sz="1050">
                 <a:solidFill>
-                  <a:srgbClr val="475569"/>
+                  <a:srgbClr val="52525B"/>
                 </a:solidFill>
               </a:defRPr>
             </a:pPr>
@@ -11795,7 +11795,7 @@
             <a:pPr algn="ctr">
               <a:defRPr sz="1050" b="1">
                 <a:solidFill>
-                  <a:srgbClr val="3182F6"/>
+                  <a:srgbClr val="585ECE"/>
                 </a:solidFill>
               </a:defRPr>
             </a:pPr>
@@ -11820,11 +11820,11 @@
             <a:avLst/>
           </a:prstGeom>
           <a:solidFill>
-            <a:srgbClr val="EEF4FF"/>
+            <a:srgbClr val="F4F5FF"/>
           </a:solidFill>
           <a:ln w="15240">
             <a:solidFill>
-              <a:srgbClr val="3182F6"/>
+              <a:srgbClr val="585ECE"/>
             </a:solidFill>
           </a:ln>
         </p:spPr>
@@ -11875,7 +11875,7 @@
             <a:pPr algn="l">
               <a:defRPr sz="1050" b="1">
                 <a:solidFill>
-                  <a:srgbClr val="1E293B"/>
+                  <a:srgbClr val="18181B"/>
                 </a:solidFill>
               </a:defRPr>
             </a:pPr>
@@ -11910,7 +11910,7 @@
             <a:pPr algn="ctr">
               <a:defRPr sz="1050">
                 <a:solidFill>
-                  <a:srgbClr val="475569"/>
+                  <a:srgbClr val="52525B"/>
                 </a:solidFill>
               </a:defRPr>
             </a:pPr>
@@ -11945,7 +11945,7 @@
             <a:pPr algn="ctr">
               <a:defRPr sz="1050">
                 <a:solidFill>
-                  <a:srgbClr val="475569"/>
+                  <a:srgbClr val="52525B"/>
                 </a:solidFill>
               </a:defRPr>
             </a:pPr>
@@ -11980,7 +11980,7 @@
             <a:pPr algn="ctr">
               <a:defRPr sz="1050">
                 <a:solidFill>
-                  <a:srgbClr val="475569"/>
+                  <a:srgbClr val="52525B"/>
                 </a:solidFill>
               </a:defRPr>
             </a:pPr>
@@ -12015,7 +12015,7 @@
             <a:pPr algn="ctr">
               <a:defRPr sz="1050" b="1">
                 <a:solidFill>
-                  <a:srgbClr val="3182F6"/>
+                  <a:srgbClr val="585ECE"/>
                 </a:solidFill>
               </a:defRPr>
             </a:pPr>
@@ -12040,11 +12040,11 @@
             <a:avLst/>
           </a:prstGeom>
           <a:solidFill>
-            <a:srgbClr val="EEF4FF"/>
+            <a:srgbClr val="F4F5FF"/>
           </a:solidFill>
           <a:ln w="15240">
             <a:solidFill>
-              <a:srgbClr val="3182F6"/>
+              <a:srgbClr val="585ECE"/>
             </a:solidFill>
           </a:ln>
         </p:spPr>
@@ -12095,7 +12095,7 @@
             <a:pPr algn="l">
               <a:defRPr sz="1050" b="1">
                 <a:solidFill>
-                  <a:srgbClr val="1E293B"/>
+                  <a:srgbClr val="18181B"/>
                 </a:solidFill>
               </a:defRPr>
             </a:pPr>
@@ -12130,7 +12130,7 @@
             <a:pPr algn="ctr">
               <a:defRPr sz="1050">
                 <a:solidFill>
-                  <a:srgbClr val="475569"/>
+                  <a:srgbClr val="52525B"/>
                 </a:solidFill>
               </a:defRPr>
             </a:pPr>
@@ -12165,7 +12165,7 @@
             <a:pPr algn="ctr">
               <a:defRPr sz="1050">
                 <a:solidFill>
-                  <a:srgbClr val="475569"/>
+                  <a:srgbClr val="52525B"/>
                 </a:solidFill>
               </a:defRPr>
             </a:pPr>
@@ -12200,7 +12200,7 @@
             <a:pPr algn="ctr">
               <a:defRPr sz="1050">
                 <a:solidFill>
-                  <a:srgbClr val="475569"/>
+                  <a:srgbClr val="52525B"/>
                 </a:solidFill>
               </a:defRPr>
             </a:pPr>
@@ -12235,7 +12235,7 @@
             <a:pPr algn="ctr">
               <a:defRPr sz="1050" b="1">
                 <a:solidFill>
-                  <a:srgbClr val="3182F6"/>
+                  <a:srgbClr val="585ECE"/>
                 </a:solidFill>
               </a:defRPr>
             </a:pPr>
@@ -12278,7 +12278,7 @@
             <a:avLst/>
           </a:prstGeom>
           <a:solidFill>
-            <a:srgbClr val="F8FAFC"/>
+            <a:srgbClr val="F4F4F6"/>
           </a:solidFill>
           <a:ln>
             <a:noFill/>
@@ -12321,11 +12321,11 @@
             <a:avLst/>
           </a:prstGeom>
           <a:solidFill>
-            <a:srgbClr val="EEF4FF"/>
+            <a:srgbClr val="F4F5FF"/>
           </a:solidFill>
           <a:ln w="12700">
             <a:solidFill>
-              <a:srgbClr val="3182F6"/>
+              <a:srgbClr val="585ECE"/>
             </a:solidFill>
           </a:ln>
         </p:spPr>
@@ -12376,7 +12376,7 @@
             <a:pPr>
               <a:defRPr sz="1000" b="1">
                 <a:solidFill>
-                  <a:srgbClr val="3182F6"/>
+                  <a:srgbClr val="585ECE"/>
                 </a:solidFill>
                 <a:latin typeface="Pretendard"/>
               </a:defRPr>
@@ -12412,7 +12412,7 @@
             <a:pPr>
               <a:defRPr sz="2300" b="1">
                 <a:solidFill>
-                  <a:srgbClr val="0F172A"/>
+                  <a:srgbClr val="0A0A0A"/>
                 </a:solidFill>
                 <a:latin typeface="Pretendard"/>
               </a:defRPr>
@@ -12448,7 +12448,7 @@
             <a:pPr>
               <a:defRPr sz="1200">
                 <a:solidFill>
-                  <a:srgbClr val="475569"/>
+                  <a:srgbClr val="52525B"/>
                 </a:solidFill>
                 <a:latin typeface="Pretendard"/>
               </a:defRPr>
@@ -12484,7 +12484,7 @@
             <a:pPr>
               <a:defRPr sz="900">
                 <a:solidFill>
-                  <a:srgbClr val="64748B"/>
+                  <a:srgbClr val="71717A"/>
                 </a:solidFill>
                 <a:latin typeface="Pretendard"/>
               </a:defRPr>
@@ -12520,7 +12520,7 @@
             <a:pPr algn="r">
               <a:defRPr sz="1000" b="1">
                 <a:solidFill>
-                  <a:srgbClr val="3182F6"/>
+                  <a:srgbClr val="585ECE"/>
                 </a:solidFill>
                 <a:latin typeface="Pretendard"/>
               </a:defRPr>
@@ -12550,7 +12550,7 @@
           </a:solidFill>
           <a:ln w="22860">
             <a:solidFill>
-              <a:srgbClr val="3182F6"/>
+              <a:srgbClr val="585ECE"/>
             </a:solidFill>
           </a:ln>
         </p:spPr>
@@ -12591,7 +12591,7 @@
             <a:avLst/>
           </a:prstGeom>
           <a:solidFill>
-            <a:srgbClr val="3182F6"/>
+            <a:srgbClr val="585ECE"/>
           </a:solidFill>
           <a:ln>
             <a:noFill/>
@@ -12679,7 +12679,7 @@
             <a:pPr>
               <a:defRPr sz="1600" b="1">
                 <a:solidFill>
-                  <a:srgbClr val="0F172A"/>
+                  <a:srgbClr val="0A0A0A"/>
                 </a:solidFill>
               </a:defRPr>
             </a:pPr>
@@ -12714,7 +12714,7 @@
             <a:pPr>
               <a:defRPr sz="1200" b="1">
                 <a:solidFill>
-                  <a:srgbClr val="3182F6"/>
+                  <a:srgbClr val="585ECE"/>
                 </a:solidFill>
               </a:defRPr>
             </a:pPr>
@@ -12752,7 +12752,7 @@
               </a:lnSpc>
               <a:defRPr sz="1100">
                 <a:solidFill>
-                  <a:srgbClr val="475569"/>
+                  <a:srgbClr val="52525B"/>
                 </a:solidFill>
               </a:defRPr>
             </a:pPr>
@@ -12910,7 +12910,7 @@
             <a:pPr>
               <a:defRPr sz="1600" b="1">
                 <a:solidFill>
-                  <a:srgbClr val="0F172A"/>
+                  <a:srgbClr val="0A0A0A"/>
                 </a:solidFill>
               </a:defRPr>
             </a:pPr>
@@ -12983,7 +12983,7 @@
               </a:lnSpc>
               <a:defRPr sz="1100">
                 <a:solidFill>
-                  <a:srgbClr val="475569"/>
+                  <a:srgbClr val="52525B"/>
                 </a:solidFill>
               </a:defRPr>
             </a:pPr>
@@ -13012,7 +13012,7 @@
           </a:solidFill>
           <a:ln w="22860">
             <a:solidFill>
-              <a:srgbClr val="03C75A"/>
+              <a:srgbClr val="10B981"/>
             </a:solidFill>
           </a:ln>
         </p:spPr>
@@ -13053,7 +13053,7 @@
             <a:avLst/>
           </a:prstGeom>
           <a:solidFill>
-            <a:srgbClr val="03C75A"/>
+            <a:srgbClr val="10B981"/>
           </a:solidFill>
           <a:ln>
             <a:noFill/>
@@ -13141,7 +13141,7 @@
             <a:pPr>
               <a:defRPr sz="1600" b="1">
                 <a:solidFill>
-                  <a:srgbClr val="0F172A"/>
+                  <a:srgbClr val="0A0A0A"/>
                 </a:solidFill>
               </a:defRPr>
             </a:pPr>
@@ -13176,7 +13176,7 @@
             <a:pPr>
               <a:defRPr sz="1200" b="1">
                 <a:solidFill>
-                  <a:srgbClr val="03C75A"/>
+                  <a:srgbClr val="10B981"/>
                 </a:solidFill>
               </a:defRPr>
             </a:pPr>
@@ -13214,7 +13214,7 @@
               </a:lnSpc>
               <a:defRPr sz="1100">
                 <a:solidFill>
-                  <a:srgbClr val="475569"/>
+                  <a:srgbClr val="52525B"/>
                 </a:solidFill>
               </a:defRPr>
             </a:pPr>
@@ -13243,7 +13243,7 @@
           </a:solidFill>
           <a:ln w="19050">
             <a:solidFill>
-              <a:srgbClr val="3182F6"/>
+              <a:srgbClr val="585ECE"/>
             </a:solidFill>
           </a:ln>
         </p:spPr>
@@ -13294,7 +13294,7 @@
             <a:pPr>
               <a:defRPr sz="1100" b="1">
                 <a:solidFill>
-                  <a:srgbClr val="3182F6"/>
+                  <a:srgbClr val="585ECE"/>
                 </a:solidFill>
               </a:defRPr>
             </a:pPr>
@@ -13306,7 +13306,7 @@
             <a:pPr>
               <a:defRPr sz="950">
                 <a:solidFill>
-                  <a:srgbClr val="475569"/>
+                  <a:srgbClr val="52525B"/>
                 </a:solidFill>
               </a:defRPr>
             </a:pPr>
@@ -13353,7 +13353,7 @@
             <a:avLst/>
           </a:prstGeom>
           <a:solidFill>
-            <a:srgbClr val="F8FAFC"/>
+            <a:srgbClr val="F4F4F6"/>
           </a:solidFill>
           <a:ln>
             <a:noFill/>
@@ -13396,11 +13396,11 @@
             <a:avLst/>
           </a:prstGeom>
           <a:solidFill>
-            <a:srgbClr val="EEF4FF"/>
+            <a:srgbClr val="F4F5FF"/>
           </a:solidFill>
           <a:ln w="12700">
             <a:solidFill>
-              <a:srgbClr val="3182F6"/>
+              <a:srgbClr val="585ECE"/>
             </a:solidFill>
           </a:ln>
         </p:spPr>
@@ -13451,7 +13451,7 @@
             <a:pPr>
               <a:defRPr sz="1000" b="1">
                 <a:solidFill>
-                  <a:srgbClr val="3182F6"/>
+                  <a:srgbClr val="585ECE"/>
                 </a:solidFill>
                 <a:latin typeface="Pretendard"/>
               </a:defRPr>
@@ -13487,7 +13487,7 @@
             <a:pPr>
               <a:defRPr sz="2300" b="1">
                 <a:solidFill>
-                  <a:srgbClr val="0F172A"/>
+                  <a:srgbClr val="0A0A0A"/>
                 </a:solidFill>
                 <a:latin typeface="Pretendard"/>
               </a:defRPr>
@@ -13523,7 +13523,7 @@
             <a:pPr>
               <a:defRPr sz="1200">
                 <a:solidFill>
-                  <a:srgbClr val="475569"/>
+                  <a:srgbClr val="52525B"/>
                 </a:solidFill>
                 <a:latin typeface="Pretendard"/>
               </a:defRPr>
@@ -13559,7 +13559,7 @@
             <a:pPr>
               <a:defRPr sz="900">
                 <a:solidFill>
-                  <a:srgbClr val="64748B"/>
+                  <a:srgbClr val="71717A"/>
                 </a:solidFill>
                 <a:latin typeface="Pretendard"/>
               </a:defRPr>
@@ -13595,7 +13595,7 @@
             <a:pPr algn="r">
               <a:defRPr sz="1000" b="1">
                 <a:solidFill>
-                  <a:srgbClr val="3182F6"/>
+                  <a:srgbClr val="585ECE"/>
                 </a:solidFill>
                 <a:latin typeface="Pretendard"/>
               </a:defRPr>
@@ -13625,7 +13625,7 @@
           </a:solidFill>
           <a:ln w="15240">
             <a:solidFill>
-              <a:srgbClr val="3182F6"/>
+              <a:srgbClr val="585ECE"/>
             </a:solidFill>
           </a:ln>
         </p:spPr>
@@ -13666,7 +13666,7 @@
             <a:avLst/>
           </a:prstGeom>
           <a:solidFill>
-            <a:srgbClr val="3182F6"/>
+            <a:srgbClr val="585ECE"/>
           </a:solidFill>
           <a:ln>
             <a:noFill/>
@@ -13754,7 +13754,7 @@
             <a:pPr>
               <a:defRPr sz="1300" b="1">
                 <a:solidFill>
-                  <a:srgbClr val="0F172A"/>
+                  <a:srgbClr val="0A0A0A"/>
                 </a:solidFill>
               </a:defRPr>
             </a:pPr>
@@ -13766,7 +13766,7 @@
             <a:pPr>
               <a:defRPr sz="1000">
                 <a:solidFill>
-                  <a:srgbClr val="64748B"/>
+                  <a:srgbClr val="71717A"/>
                 </a:solidFill>
               </a:defRPr>
             </a:pPr>
@@ -13791,11 +13791,11 @@
             <a:avLst/>
           </a:prstGeom>
           <a:solidFill>
-            <a:srgbClr val="EEF4FF"/>
+            <a:srgbClr val="F4F5FF"/>
           </a:solidFill>
           <a:ln w="12700">
             <a:solidFill>
-              <a:srgbClr val="3182F6"/>
+              <a:srgbClr val="585ECE"/>
             </a:solidFill>
           </a:ln>
         </p:spPr>
@@ -13846,7 +13846,7 @@
             <a:pPr algn="ctr">
               <a:defRPr sz="1100" b="1">
                 <a:solidFill>
-                  <a:srgbClr val="3182F6"/>
+                  <a:srgbClr val="585ECE"/>
                 </a:solidFill>
               </a:defRPr>
             </a:pPr>
@@ -13871,7 +13871,7 @@
             <a:avLst/>
           </a:prstGeom>
           <a:solidFill>
-            <a:srgbClr val="F8FAFC"/>
+            <a:srgbClr val="F4F4F6"/>
           </a:solidFill>
           <a:ln>
             <a:noFill/>
@@ -13924,7 +13924,7 @@
             <a:pPr algn="ctr">
               <a:defRPr sz="950" b="1">
                 <a:solidFill>
-                  <a:srgbClr val="3182F6"/>
+                  <a:srgbClr val="585ECE"/>
                 </a:solidFill>
               </a:defRPr>
             </a:pPr>
@@ -13962,7 +13962,7 @@
               </a:lnSpc>
               <a:defRPr sz="1000">
                 <a:solidFill>
-                  <a:srgbClr val="475569"/>
+                  <a:srgbClr val="52525B"/>
                 </a:solidFill>
               </a:defRPr>
             </a:pPr>
@@ -14124,7 +14124,7 @@
             <a:pPr>
               <a:defRPr sz="1300" b="1">
                 <a:solidFill>
-                  <a:srgbClr val="0F172A"/>
+                  <a:srgbClr val="0A0A0A"/>
                 </a:solidFill>
               </a:defRPr>
             </a:pPr>
@@ -14136,7 +14136,7 @@
             <a:pPr>
               <a:defRPr sz="1000">
                 <a:solidFill>
-                  <a:srgbClr val="64748B"/>
+                  <a:srgbClr val="71717A"/>
                 </a:solidFill>
               </a:defRPr>
             </a:pPr>
@@ -14161,7 +14161,7 @@
             <a:avLst/>
           </a:prstGeom>
           <a:solidFill>
-            <a:srgbClr val="F3E8FF"/>
+            <a:srgbClr val="EBEBFC"/>
           </a:solidFill>
           <a:ln w="12700">
             <a:solidFill>
@@ -14241,7 +14241,7 @@
             <a:avLst/>
           </a:prstGeom>
           <a:solidFill>
-            <a:srgbClr val="F8FAFC"/>
+            <a:srgbClr val="F4F4F6"/>
           </a:solidFill>
           <a:ln>
             <a:noFill/>
@@ -14332,7 +14332,7 @@
               </a:lnSpc>
               <a:defRPr sz="1000">
                 <a:solidFill>
-                  <a:srgbClr val="475569"/>
+                  <a:srgbClr val="52525B"/>
                 </a:solidFill>
               </a:defRPr>
             </a:pPr>
@@ -14365,7 +14365,7 @@
           </a:solidFill>
           <a:ln w="22860">
             <a:solidFill>
-              <a:srgbClr val="03C75A"/>
+              <a:srgbClr val="10B981"/>
             </a:solidFill>
           </a:ln>
         </p:spPr>
@@ -14406,7 +14406,7 @@
             <a:avLst/>
           </a:prstGeom>
           <a:solidFill>
-            <a:srgbClr val="03C75A"/>
+            <a:srgbClr val="10B981"/>
           </a:solidFill>
           <a:ln>
             <a:noFill/>
@@ -14494,7 +14494,7 @@
             <a:pPr>
               <a:defRPr sz="1300" b="1">
                 <a:solidFill>
-                  <a:srgbClr val="0F172A"/>
+                  <a:srgbClr val="0A0A0A"/>
                 </a:solidFill>
               </a:defRPr>
             </a:pPr>
@@ -14506,7 +14506,7 @@
             <a:pPr>
               <a:defRPr sz="1000">
                 <a:solidFill>
-                  <a:srgbClr val="64748B"/>
+                  <a:srgbClr val="71717A"/>
                 </a:solidFill>
               </a:defRPr>
             </a:pPr>
@@ -14535,7 +14535,7 @@
           </a:solidFill>
           <a:ln w="12700">
             <a:solidFill>
-              <a:srgbClr val="03C75A"/>
+              <a:srgbClr val="10B981"/>
             </a:solidFill>
           </a:ln>
         </p:spPr>
@@ -14586,7 +14586,7 @@
             <a:pPr algn="ctr">
               <a:defRPr sz="1100" b="1">
                 <a:solidFill>
-                  <a:srgbClr val="03C75A"/>
+                  <a:srgbClr val="10B981"/>
                 </a:solidFill>
               </a:defRPr>
             </a:pPr>
@@ -14611,7 +14611,7 @@
             <a:avLst/>
           </a:prstGeom>
           <a:solidFill>
-            <a:srgbClr val="F8FAFC"/>
+            <a:srgbClr val="F4F4F6"/>
           </a:solidFill>
           <a:ln>
             <a:noFill/>
@@ -14664,7 +14664,7 @@
             <a:pPr algn="ctr">
               <a:defRPr sz="950" b="1">
                 <a:solidFill>
-                  <a:srgbClr val="03C75A"/>
+                  <a:srgbClr val="10B981"/>
                 </a:solidFill>
               </a:defRPr>
             </a:pPr>
@@ -14702,7 +14702,7 @@
               </a:lnSpc>
               <a:defRPr sz="1000">
                 <a:solidFill>
-                  <a:srgbClr val="475569"/>
+                  <a:srgbClr val="52525B"/>
                 </a:solidFill>
               </a:defRPr>
             </a:pPr>
@@ -14864,7 +14864,7 @@
             <a:pPr>
               <a:defRPr sz="1300" b="1">
                 <a:solidFill>
-                  <a:srgbClr val="0F172A"/>
+                  <a:srgbClr val="0A0A0A"/>
                 </a:solidFill>
               </a:defRPr>
             </a:pPr>
@@ -14876,7 +14876,7 @@
             <a:pPr>
               <a:defRPr sz="1000">
                 <a:solidFill>
-                  <a:srgbClr val="64748B"/>
+                  <a:srgbClr val="71717A"/>
                 </a:solidFill>
               </a:defRPr>
             </a:pPr>
@@ -14901,7 +14901,7 @@
             <a:avLst/>
           </a:prstGeom>
           <a:solidFill>
-            <a:srgbClr val="F3E8FF"/>
+            <a:srgbClr val="EBEBFC"/>
           </a:solidFill>
           <a:ln w="12700">
             <a:solidFill>
@@ -14981,7 +14981,7 @@
             <a:avLst/>
           </a:prstGeom>
           <a:solidFill>
-            <a:srgbClr val="F8FAFC"/>
+            <a:srgbClr val="F4F4F6"/>
           </a:solidFill>
           <a:ln>
             <a:noFill/>
@@ -15072,7 +15072,7 @@
               </a:lnSpc>
               <a:defRPr sz="1000">
                 <a:solidFill>
-                  <a:srgbClr val="475569"/>
+                  <a:srgbClr val="52525B"/>
                 </a:solidFill>
               </a:defRPr>
             </a:pPr>
@@ -15105,7 +15105,7 @@
           </a:solidFill>
           <a:ln w="15240">
             <a:solidFill>
-              <a:srgbClr val="64748B"/>
+              <a:srgbClr val="71717A"/>
             </a:solidFill>
           </a:ln>
         </p:spPr>
@@ -15146,7 +15146,7 @@
             <a:avLst/>
           </a:prstGeom>
           <a:solidFill>
-            <a:srgbClr val="64748B"/>
+            <a:srgbClr val="71717A"/>
           </a:solidFill>
           <a:ln>
             <a:noFill/>
@@ -15234,7 +15234,7 @@
             <a:pPr>
               <a:defRPr sz="1300" b="1">
                 <a:solidFill>
-                  <a:srgbClr val="0F172A"/>
+                  <a:srgbClr val="0A0A0A"/>
                 </a:solidFill>
               </a:defRPr>
             </a:pPr>
@@ -15246,7 +15246,7 @@
             <a:pPr>
               <a:defRPr sz="1000">
                 <a:solidFill>
-                  <a:srgbClr val="64748B"/>
+                  <a:srgbClr val="71717A"/>
                 </a:solidFill>
               </a:defRPr>
             </a:pPr>
@@ -15271,11 +15271,11 @@
             <a:avLst/>
           </a:prstGeom>
           <a:solidFill>
-            <a:srgbClr val="F3E8FF"/>
+            <a:srgbClr val="EBEBFC"/>
           </a:solidFill>
           <a:ln w="12700">
             <a:solidFill>
-              <a:srgbClr val="64748B"/>
+              <a:srgbClr val="71717A"/>
             </a:solidFill>
           </a:ln>
         </p:spPr>
@@ -15326,7 +15326,7 @@
             <a:pPr algn="ctr">
               <a:defRPr sz="1100" b="1">
                 <a:solidFill>
-                  <a:srgbClr val="64748B"/>
+                  <a:srgbClr val="71717A"/>
                 </a:solidFill>
               </a:defRPr>
             </a:pPr>
@@ -15351,7 +15351,7 @@
             <a:avLst/>
           </a:prstGeom>
           <a:solidFill>
-            <a:srgbClr val="F8FAFC"/>
+            <a:srgbClr val="F4F4F6"/>
           </a:solidFill>
           <a:ln>
             <a:noFill/>
@@ -15404,7 +15404,7 @@
             <a:pPr algn="ctr">
               <a:defRPr sz="950" b="1">
                 <a:solidFill>
-                  <a:srgbClr val="64748B"/>
+                  <a:srgbClr val="71717A"/>
                 </a:solidFill>
               </a:defRPr>
             </a:pPr>
@@ -15442,7 +15442,7 @@
               </a:lnSpc>
               <a:defRPr sz="1000">
                 <a:solidFill>
-                  <a:srgbClr val="475569"/>
+                  <a:srgbClr val="52525B"/>
                 </a:solidFill>
               </a:defRPr>
             </a:pPr>
@@ -15489,7 +15489,7 @@
             <a:avLst/>
           </a:prstGeom>
           <a:solidFill>
-            <a:srgbClr val="F8FAFC"/>
+            <a:srgbClr val="F4F4F6"/>
           </a:solidFill>
           <a:ln>
             <a:noFill/>
@@ -15532,11 +15532,11 @@
             <a:avLst/>
           </a:prstGeom>
           <a:solidFill>
-            <a:srgbClr val="EEF4FF"/>
+            <a:srgbClr val="F4F5FF"/>
           </a:solidFill>
           <a:ln w="12700">
             <a:solidFill>
-              <a:srgbClr val="3182F6"/>
+              <a:srgbClr val="585ECE"/>
             </a:solidFill>
           </a:ln>
         </p:spPr>
@@ -15587,7 +15587,7 @@
             <a:pPr>
               <a:defRPr sz="1000" b="1">
                 <a:solidFill>
-                  <a:srgbClr val="3182F6"/>
+                  <a:srgbClr val="585ECE"/>
                 </a:solidFill>
                 <a:latin typeface="Pretendard"/>
               </a:defRPr>
@@ -15623,7 +15623,7 @@
             <a:pPr>
               <a:defRPr sz="2300" b="1">
                 <a:solidFill>
-                  <a:srgbClr val="0F172A"/>
+                  <a:srgbClr val="0A0A0A"/>
                 </a:solidFill>
                 <a:latin typeface="Pretendard"/>
               </a:defRPr>
@@ -15659,7 +15659,7 @@
             <a:pPr>
               <a:defRPr sz="1200">
                 <a:solidFill>
-                  <a:srgbClr val="475569"/>
+                  <a:srgbClr val="52525B"/>
                 </a:solidFill>
                 <a:latin typeface="Pretendard"/>
               </a:defRPr>
@@ -15695,7 +15695,7 @@
             <a:pPr>
               <a:defRPr sz="900">
                 <a:solidFill>
-                  <a:srgbClr val="64748B"/>
+                  <a:srgbClr val="71717A"/>
                 </a:solidFill>
                 <a:latin typeface="Pretendard"/>
               </a:defRPr>
@@ -15731,7 +15731,7 @@
             <a:pPr algn="r">
               <a:defRPr sz="1000" b="1">
                 <a:solidFill>
-                  <a:srgbClr val="3182F6"/>
+                  <a:srgbClr val="585ECE"/>
                 </a:solidFill>
                 <a:latin typeface="Pretendard"/>
               </a:defRPr>
@@ -15761,7 +15761,7 @@
           </a:solidFill>
           <a:ln w="22860">
             <a:solidFill>
-              <a:srgbClr val="3182F6"/>
+              <a:srgbClr val="585ECE"/>
             </a:solidFill>
           </a:ln>
         </p:spPr>
@@ -15802,7 +15802,7 @@
             <a:avLst/>
           </a:prstGeom>
           <a:solidFill>
-            <a:srgbClr val="3182F6"/>
+            <a:srgbClr val="585ECE"/>
           </a:solidFill>
           <a:ln>
             <a:noFill/>
@@ -15890,7 +15890,7 @@
             <a:pPr>
               <a:defRPr sz="1700" b="1">
                 <a:solidFill>
-                  <a:srgbClr val="0F172A"/>
+                  <a:srgbClr val="0A0A0A"/>
                 </a:solidFill>
               </a:defRPr>
             </a:pPr>
@@ -15925,7 +15925,7 @@
             <a:pPr>
               <a:defRPr sz="1200" b="1">
                 <a:solidFill>
-                  <a:srgbClr val="3182F6"/>
+                  <a:srgbClr val="585ECE"/>
                 </a:solidFill>
               </a:defRPr>
             </a:pPr>
@@ -15963,7 +15963,7 @@
               </a:lnSpc>
               <a:defRPr sz="1150">
                 <a:solidFill>
-                  <a:srgbClr val="475569"/>
+                  <a:srgbClr val="52525B"/>
                 </a:solidFill>
               </a:defRPr>
             </a:pPr>
@@ -16126,7 +16126,7 @@
             <a:pPr>
               <a:defRPr sz="1700" b="1">
                 <a:solidFill>
-                  <a:srgbClr val="0F172A"/>
+                  <a:srgbClr val="0A0A0A"/>
                 </a:solidFill>
               </a:defRPr>
             </a:pPr>
@@ -16199,7 +16199,7 @@
               </a:lnSpc>
               <a:defRPr sz="1150">
                 <a:solidFill>
-                  <a:srgbClr val="475569"/>
+                  <a:srgbClr val="52525B"/>
                 </a:solidFill>
               </a:defRPr>
             </a:pPr>
@@ -16233,7 +16233,7 @@
           </a:solidFill>
           <a:ln w="22860">
             <a:solidFill>
-              <a:srgbClr val="03C75A"/>
+              <a:srgbClr val="10B981"/>
             </a:solidFill>
           </a:ln>
         </p:spPr>
@@ -16274,7 +16274,7 @@
             <a:avLst/>
           </a:prstGeom>
           <a:solidFill>
-            <a:srgbClr val="03C75A"/>
+            <a:srgbClr val="10B981"/>
           </a:solidFill>
           <a:ln>
             <a:noFill/>
@@ -16362,7 +16362,7 @@
             <a:pPr>
               <a:defRPr sz="1700" b="1">
                 <a:solidFill>
-                  <a:srgbClr val="0F172A"/>
+                  <a:srgbClr val="0A0A0A"/>
                 </a:solidFill>
               </a:defRPr>
             </a:pPr>
@@ -16397,7 +16397,7 @@
             <a:pPr>
               <a:defRPr sz="1200" b="1">
                 <a:solidFill>
-                  <a:srgbClr val="03C75A"/>
+                  <a:srgbClr val="10B981"/>
                 </a:solidFill>
               </a:defRPr>
             </a:pPr>
@@ -16435,7 +16435,7 @@
               </a:lnSpc>
               <a:defRPr sz="1150">
                 <a:solidFill>
-                  <a:srgbClr val="475569"/>
+                  <a:srgbClr val="52525B"/>
                 </a:solidFill>
               </a:defRPr>
             </a:pPr>

</xml_diff>

<commit_message>
fix(design): restore radiant 3D glassmorphism and Toss/Apple sans-serif typography across landing page and pitch deck
</commit_message>
<xml_diff>
--- a/public/formu_pitch_deck.pptx
+++ b/public/formu_pitch_deck.pptx
@@ -3113,7 +3113,7 @@
             <a:avLst/>
           </a:prstGeom>
           <a:solidFill>
-            <a:srgbClr val="F4F4F6"/>
+            <a:srgbClr val="F8FAFC"/>
           </a:solidFill>
           <a:ln>
             <a:noFill/>
@@ -3156,7 +3156,7 @@
             <a:avLst/>
           </a:prstGeom>
           <a:solidFill>
-            <a:srgbClr val="EBEBFC"/>
+            <a:srgbClr val="F5F3FF"/>
           </a:solidFill>
           <a:ln w="15240">
             <a:solidFill>
@@ -3246,7 +3246,7 @@
             <a:pPr>
               <a:defRPr sz="5000" b="1">
                 <a:solidFill>
-                  <a:srgbClr val="0A0A0A"/>
+                  <a:srgbClr val="0F172A"/>
                 </a:solidFill>
               </a:defRPr>
             </a:pPr>
@@ -3258,7 +3258,7 @@
             <a:pPr>
               <a:defRPr sz="2200" b="1">
                 <a:solidFill>
-                  <a:srgbClr val="585ECE"/>
+                  <a:srgbClr val="3182F6"/>
                 </a:solidFill>
               </a:defRPr>
             </a:pPr>
@@ -3296,7 +3296,7 @@
               </a:lnSpc>
               <a:defRPr sz="1400">
                 <a:solidFill>
-                  <a:srgbClr val="52525B"/>
+                  <a:srgbClr val="475569"/>
                 </a:solidFill>
               </a:defRPr>
             </a:pPr>
@@ -3335,7 +3335,7 @@
             <a:pPr>
               <a:defRPr sz="1100" b="1">
                 <a:solidFill>
-                  <a:srgbClr val="71717A"/>
+                  <a:srgbClr val="64748B"/>
                 </a:solidFill>
               </a:defRPr>
             </a:pPr>
@@ -3364,7 +3364,7 @@
           </a:solidFill>
           <a:ln w="22860">
             <a:solidFill>
-              <a:srgbClr val="585ECE"/>
+              <a:srgbClr val="3182F6"/>
             </a:solidFill>
           </a:ln>
         </p:spPr>
@@ -3409,7 +3409,7 @@
           </a:solidFill>
           <a:ln w="19050">
             <a:solidFill>
-              <a:srgbClr val="585ECE"/>
+              <a:srgbClr val="3182F6"/>
             </a:solidFill>
           </a:ln>
         </p:spPr>
@@ -3460,7 +3460,7 @@
             <a:pPr>
               <a:defRPr sz="1350" b="1">
                 <a:solidFill>
-                  <a:srgbClr val="585ECE"/>
+                  <a:srgbClr val="3182F6"/>
                 </a:solidFill>
               </a:defRPr>
             </a:pPr>
@@ -3472,7 +3472,7 @@
             <a:pPr>
               <a:defRPr sz="1050">
                 <a:solidFill>
-                  <a:srgbClr val="52525B"/>
+                  <a:srgbClr val="475569"/>
                 </a:solidFill>
               </a:defRPr>
             </a:pPr>
@@ -3564,7 +3564,7 @@
             <a:pPr>
               <a:defRPr sz="1050">
                 <a:solidFill>
-                  <a:srgbClr val="52525B"/>
+                  <a:srgbClr val="475569"/>
                 </a:solidFill>
               </a:defRPr>
             </a:pPr>
@@ -3656,7 +3656,7 @@
             <a:pPr>
               <a:defRPr sz="1050">
                 <a:solidFill>
-                  <a:srgbClr val="52525B"/>
+                  <a:srgbClr val="475569"/>
                 </a:solidFill>
               </a:defRPr>
             </a:pPr>
@@ -3691,7 +3691,7 @@
             <a:pPr>
               <a:defRPr sz="900">
                 <a:solidFill>
-                  <a:srgbClr val="71717A"/>
+                  <a:srgbClr val="64748B"/>
                 </a:solidFill>
                 <a:latin typeface="Pretendard"/>
               </a:defRPr>
@@ -3727,7 +3727,7 @@
             <a:pPr algn="r">
               <a:defRPr sz="1000" b="1">
                 <a:solidFill>
-                  <a:srgbClr val="585ECE"/>
+                  <a:srgbClr val="3182F6"/>
                 </a:solidFill>
                 <a:latin typeface="Pretendard"/>
               </a:defRPr>
@@ -3771,7 +3771,7 @@
             <a:avLst/>
           </a:prstGeom>
           <a:solidFill>
-            <a:srgbClr val="F4F4F6"/>
+            <a:srgbClr val="F8FAFC"/>
           </a:solidFill>
           <a:ln>
             <a:noFill/>
@@ -3814,11 +3814,11 @@
             <a:avLst/>
           </a:prstGeom>
           <a:solidFill>
-            <a:srgbClr val="F4F5FF"/>
+            <a:srgbClr val="EEF4FF"/>
           </a:solidFill>
           <a:ln w="12700">
             <a:solidFill>
-              <a:srgbClr val="585ECE"/>
+              <a:srgbClr val="3182F6"/>
             </a:solidFill>
           </a:ln>
         </p:spPr>
@@ -3869,7 +3869,7 @@
             <a:pPr>
               <a:defRPr sz="1000" b="1">
                 <a:solidFill>
-                  <a:srgbClr val="585ECE"/>
+                  <a:srgbClr val="3182F6"/>
                 </a:solidFill>
                 <a:latin typeface="Pretendard"/>
               </a:defRPr>
@@ -3905,7 +3905,7 @@
             <a:pPr>
               <a:defRPr sz="2300" b="1">
                 <a:solidFill>
-                  <a:srgbClr val="0A0A0A"/>
+                  <a:srgbClr val="0F172A"/>
                 </a:solidFill>
                 <a:latin typeface="Pretendard"/>
               </a:defRPr>
@@ -3941,7 +3941,7 @@
             <a:pPr>
               <a:defRPr sz="1200">
                 <a:solidFill>
-                  <a:srgbClr val="52525B"/>
+                  <a:srgbClr val="475569"/>
                 </a:solidFill>
                 <a:latin typeface="Pretendard"/>
               </a:defRPr>
@@ -3977,7 +3977,7 @@
             <a:pPr>
               <a:defRPr sz="900">
                 <a:solidFill>
-                  <a:srgbClr val="71717A"/>
+                  <a:srgbClr val="64748B"/>
                 </a:solidFill>
                 <a:latin typeface="Pretendard"/>
               </a:defRPr>
@@ -4013,7 +4013,7 @@
             <a:pPr algn="r">
               <a:defRPr sz="1000" b="1">
                 <a:solidFill>
-                  <a:srgbClr val="585ECE"/>
+                  <a:srgbClr val="3182F6"/>
                 </a:solidFill>
                 <a:latin typeface="Pretendard"/>
               </a:defRPr>
@@ -4172,7 +4172,7 @@
             <a:pPr>
               <a:defRPr sz="1500" b="1">
                 <a:solidFill>
-                  <a:srgbClr val="0A0A0A"/>
+                  <a:srgbClr val="0F172A"/>
                 </a:solidFill>
               </a:defRPr>
             </a:pPr>
@@ -4210,7 +4210,7 @@
               </a:lnSpc>
               <a:defRPr sz="1100">
                 <a:solidFill>
-                  <a:srgbClr val="52525B"/>
+                  <a:srgbClr val="475569"/>
                 </a:solidFill>
               </a:defRPr>
             </a:pPr>
@@ -4243,7 +4243,7 @@
           </a:solidFill>
           <a:ln w="22860">
             <a:solidFill>
-              <a:srgbClr val="585ECE"/>
+              <a:srgbClr val="3182F6"/>
             </a:solidFill>
           </a:ln>
         </p:spPr>
@@ -4284,7 +4284,7 @@
             <a:avLst/>
           </a:prstGeom>
           <a:solidFill>
-            <a:srgbClr val="585ECE"/>
+            <a:srgbClr val="3182F6"/>
           </a:solidFill>
           <a:ln>
             <a:noFill/>
@@ -4372,7 +4372,7 @@
             <a:pPr>
               <a:defRPr sz="1500" b="1">
                 <a:solidFill>
-                  <a:srgbClr val="0A0A0A"/>
+                  <a:srgbClr val="0F172A"/>
                 </a:solidFill>
               </a:defRPr>
             </a:pPr>
@@ -4410,7 +4410,7 @@
               </a:lnSpc>
               <a:defRPr sz="1100">
                 <a:solidFill>
-                  <a:srgbClr val="52525B"/>
+                  <a:srgbClr val="475569"/>
                 </a:solidFill>
               </a:defRPr>
             </a:pPr>
@@ -4568,7 +4568,7 @@
             <a:pPr>
               <a:defRPr sz="1500" b="1">
                 <a:solidFill>
-                  <a:srgbClr val="0A0A0A"/>
+                  <a:srgbClr val="0F172A"/>
                 </a:solidFill>
               </a:defRPr>
             </a:pPr>
@@ -4606,7 +4606,7 @@
               </a:lnSpc>
               <a:defRPr sz="1100">
                 <a:solidFill>
-                  <a:srgbClr val="52525B"/>
+                  <a:srgbClr val="475569"/>
                 </a:solidFill>
               </a:defRPr>
             </a:pPr>
@@ -4635,7 +4635,7 @@
           </a:solidFill>
           <a:ln w="19050">
             <a:solidFill>
-              <a:srgbClr val="585ECE"/>
+              <a:srgbClr val="3182F6"/>
             </a:solidFill>
           </a:ln>
         </p:spPr>
@@ -4686,7 +4686,7 @@
             <a:pPr>
               <a:defRPr sz="1100" b="1">
                 <a:solidFill>
-                  <a:srgbClr val="585ECE"/>
+                  <a:srgbClr val="3182F6"/>
                 </a:solidFill>
               </a:defRPr>
             </a:pPr>
@@ -4698,7 +4698,7 @@
             <a:pPr>
               <a:defRPr sz="950">
                 <a:solidFill>
-                  <a:srgbClr val="52525B"/>
+                  <a:srgbClr val="475569"/>
                 </a:solidFill>
               </a:defRPr>
             </a:pPr>
@@ -4745,7 +4745,7 @@
             <a:avLst/>
           </a:prstGeom>
           <a:solidFill>
-            <a:srgbClr val="F4F4F6"/>
+            <a:srgbClr val="F8FAFC"/>
           </a:solidFill>
           <a:ln>
             <a:noFill/>
@@ -4788,11 +4788,11 @@
             <a:avLst/>
           </a:prstGeom>
           <a:solidFill>
-            <a:srgbClr val="F4F5FF"/>
+            <a:srgbClr val="EEF4FF"/>
           </a:solidFill>
           <a:ln w="12700">
             <a:solidFill>
-              <a:srgbClr val="585ECE"/>
+              <a:srgbClr val="3182F6"/>
             </a:solidFill>
           </a:ln>
         </p:spPr>
@@ -4843,7 +4843,7 @@
             <a:pPr>
               <a:defRPr sz="1000" b="1">
                 <a:solidFill>
-                  <a:srgbClr val="585ECE"/>
+                  <a:srgbClr val="3182F6"/>
                 </a:solidFill>
                 <a:latin typeface="Pretendard"/>
               </a:defRPr>
@@ -4879,7 +4879,7 @@
             <a:pPr>
               <a:defRPr sz="2300" b="1">
                 <a:solidFill>
-                  <a:srgbClr val="0A0A0A"/>
+                  <a:srgbClr val="0F172A"/>
                 </a:solidFill>
                 <a:latin typeface="Pretendard"/>
               </a:defRPr>
@@ -4915,7 +4915,7 @@
             <a:pPr>
               <a:defRPr sz="1200">
                 <a:solidFill>
-                  <a:srgbClr val="52525B"/>
+                  <a:srgbClr val="475569"/>
                 </a:solidFill>
                 <a:latin typeface="Pretendard"/>
               </a:defRPr>
@@ -4951,7 +4951,7 @@
             <a:pPr>
               <a:defRPr sz="900">
                 <a:solidFill>
-                  <a:srgbClr val="71717A"/>
+                  <a:srgbClr val="64748B"/>
                 </a:solidFill>
                 <a:latin typeface="Pretendard"/>
               </a:defRPr>
@@ -4987,7 +4987,7 @@
             <a:pPr algn="r">
               <a:defRPr sz="1000" b="1">
                 <a:solidFill>
-                  <a:srgbClr val="585ECE"/>
+                  <a:srgbClr val="3182F6"/>
                 </a:solidFill>
                 <a:latin typeface="Pretendard"/>
               </a:defRPr>
@@ -5013,11 +5013,11 @@
             <a:avLst/>
           </a:prstGeom>
           <a:solidFill>
-            <a:srgbClr val="0A0A0A"/>
+            <a:srgbClr val="0F172A"/>
           </a:solidFill>
           <a:ln w="25400">
             <a:solidFill>
-              <a:srgbClr val="585ECE"/>
+              <a:srgbClr val="3182F6"/>
             </a:solidFill>
           </a:ln>
         </p:spPr>
@@ -5116,7 +5116,7 @@
           </a:solidFill>
           <a:ln w="22860">
             <a:solidFill>
-              <a:srgbClr val="585ECE"/>
+              <a:srgbClr val="3182F6"/>
             </a:solidFill>
           </a:ln>
         </p:spPr>
@@ -5167,7 +5167,7 @@
             <a:pPr>
               <a:defRPr sz="1100" b="1">
                 <a:solidFill>
-                  <a:srgbClr val="585ECE"/>
+                  <a:srgbClr val="3182F6"/>
                 </a:solidFill>
               </a:defRPr>
             </a:pPr>
@@ -5202,7 +5202,7 @@
             <a:pPr>
               <a:defRPr sz="1600" b="1">
                 <a:solidFill>
-                  <a:srgbClr val="0A0A0A"/>
+                  <a:srgbClr val="0F172A"/>
                 </a:solidFill>
               </a:defRPr>
             </a:pPr>
@@ -5240,7 +5240,7 @@
               </a:lnSpc>
               <a:defRPr sz="1100">
                 <a:solidFill>
-                  <a:srgbClr val="52525B"/>
+                  <a:srgbClr val="475569"/>
                 </a:solidFill>
               </a:defRPr>
             </a:pPr>
@@ -5355,7 +5355,7 @@
             <a:pPr>
               <a:defRPr sz="1600" b="1">
                 <a:solidFill>
-                  <a:srgbClr val="0A0A0A"/>
+                  <a:srgbClr val="0F172A"/>
                 </a:solidFill>
               </a:defRPr>
             </a:pPr>
@@ -5393,7 +5393,7 @@
               </a:lnSpc>
               <a:defRPr sz="1100">
                 <a:solidFill>
-                  <a:srgbClr val="52525B"/>
+                  <a:srgbClr val="475569"/>
                 </a:solidFill>
               </a:defRPr>
             </a:pPr>
@@ -5508,7 +5508,7 @@
             <a:pPr>
               <a:defRPr sz="1600" b="1">
                 <a:solidFill>
-                  <a:srgbClr val="0A0A0A"/>
+                  <a:srgbClr val="0F172A"/>
                 </a:solidFill>
               </a:defRPr>
             </a:pPr>
@@ -5546,7 +5546,7 @@
               </a:lnSpc>
               <a:defRPr sz="1100">
                 <a:solidFill>
-                  <a:srgbClr val="52525B"/>
+                  <a:srgbClr val="475569"/>
                 </a:solidFill>
               </a:defRPr>
             </a:pPr>
@@ -5589,7 +5589,7 @@
             <a:avLst/>
           </a:prstGeom>
           <a:solidFill>
-            <a:srgbClr val="F4F4F6"/>
+            <a:srgbClr val="F8FAFC"/>
           </a:solidFill>
           <a:ln>
             <a:noFill/>
@@ -5632,11 +5632,11 @@
             <a:avLst/>
           </a:prstGeom>
           <a:solidFill>
-            <a:srgbClr val="F4F5FF"/>
+            <a:srgbClr val="EEF4FF"/>
           </a:solidFill>
           <a:ln w="12700">
             <a:solidFill>
-              <a:srgbClr val="585ECE"/>
+              <a:srgbClr val="3182F6"/>
             </a:solidFill>
           </a:ln>
         </p:spPr>
@@ -5687,7 +5687,7 @@
             <a:pPr>
               <a:defRPr sz="1000" b="1">
                 <a:solidFill>
-                  <a:srgbClr val="585ECE"/>
+                  <a:srgbClr val="3182F6"/>
                 </a:solidFill>
                 <a:latin typeface="Pretendard"/>
               </a:defRPr>
@@ -5723,7 +5723,7 @@
             <a:pPr>
               <a:defRPr sz="2300" b="1">
                 <a:solidFill>
-                  <a:srgbClr val="0A0A0A"/>
+                  <a:srgbClr val="0F172A"/>
                 </a:solidFill>
                 <a:latin typeface="Pretendard"/>
               </a:defRPr>
@@ -5759,7 +5759,7 @@
             <a:pPr>
               <a:defRPr sz="1200">
                 <a:solidFill>
-                  <a:srgbClr val="52525B"/>
+                  <a:srgbClr val="475569"/>
                 </a:solidFill>
                 <a:latin typeface="Pretendard"/>
               </a:defRPr>
@@ -5795,7 +5795,7 @@
             <a:pPr>
               <a:defRPr sz="900">
                 <a:solidFill>
-                  <a:srgbClr val="71717A"/>
+                  <a:srgbClr val="64748B"/>
                 </a:solidFill>
                 <a:latin typeface="Pretendard"/>
               </a:defRPr>
@@ -5831,7 +5831,7 @@
             <a:pPr algn="r">
               <a:defRPr sz="1000" b="1">
                 <a:solidFill>
-                  <a:srgbClr val="585ECE"/>
+                  <a:srgbClr val="3182F6"/>
                 </a:solidFill>
                 <a:latin typeface="Pretendard"/>
               </a:defRPr>
@@ -5861,7 +5861,7 @@
           </a:solidFill>
           <a:ln w="15240">
             <a:solidFill>
-              <a:srgbClr val="585ECE"/>
+              <a:srgbClr val="3182F6"/>
             </a:solidFill>
           </a:ln>
         </p:spPr>
@@ -5902,7 +5902,7 @@
             <a:avLst/>
           </a:prstGeom>
           <a:solidFill>
-            <a:srgbClr val="585ECE"/>
+            <a:srgbClr val="3182F6"/>
           </a:solidFill>
           <a:ln>
             <a:noFill/>
@@ -5990,7 +5990,7 @@
             <a:pPr>
               <a:defRPr sz="1300" b="1">
                 <a:solidFill>
-                  <a:srgbClr val="585ECE"/>
+                  <a:srgbClr val="3182F6"/>
                 </a:solidFill>
               </a:defRPr>
             </a:pPr>
@@ -6002,7 +6002,7 @@
             <a:pPr>
               <a:defRPr sz="1000">
                 <a:solidFill>
-                  <a:srgbClr val="52525B"/>
+                  <a:srgbClr val="475569"/>
                 </a:solidFill>
               </a:defRPr>
             </a:pPr>
@@ -6031,7 +6031,7 @@
           </a:solidFill>
           <a:ln w="15240">
             <a:solidFill>
-              <a:srgbClr val="585ECE"/>
+              <a:srgbClr val="3182F6"/>
             </a:solidFill>
           </a:ln>
         </p:spPr>
@@ -6072,7 +6072,7 @@
             <a:avLst/>
           </a:prstGeom>
           <a:solidFill>
-            <a:srgbClr val="585ECE"/>
+            <a:srgbClr val="3182F6"/>
           </a:solidFill>
           <a:ln>
             <a:noFill/>
@@ -6160,7 +6160,7 @@
             <a:pPr>
               <a:defRPr sz="1300" b="1">
                 <a:solidFill>
-                  <a:srgbClr val="585ECE"/>
+                  <a:srgbClr val="3182F6"/>
                 </a:solidFill>
               </a:defRPr>
             </a:pPr>
@@ -6172,7 +6172,7 @@
             <a:pPr>
               <a:defRPr sz="1000">
                 <a:solidFill>
-                  <a:srgbClr val="52525B"/>
+                  <a:srgbClr val="475569"/>
                 </a:solidFill>
               </a:defRPr>
             </a:pPr>
@@ -6201,7 +6201,7 @@
           </a:solidFill>
           <a:ln w="15240">
             <a:solidFill>
-              <a:srgbClr val="585ECE"/>
+              <a:srgbClr val="3182F6"/>
             </a:solidFill>
           </a:ln>
         </p:spPr>
@@ -6242,7 +6242,7 @@
             <a:avLst/>
           </a:prstGeom>
           <a:solidFill>
-            <a:srgbClr val="585ECE"/>
+            <a:srgbClr val="3182F6"/>
           </a:solidFill>
           <a:ln>
             <a:noFill/>
@@ -6330,7 +6330,7 @@
             <a:pPr>
               <a:defRPr sz="1300" b="1">
                 <a:solidFill>
-                  <a:srgbClr val="585ECE"/>
+                  <a:srgbClr val="3182F6"/>
                 </a:solidFill>
               </a:defRPr>
             </a:pPr>
@@ -6342,7 +6342,7 @@
             <a:pPr>
               <a:defRPr sz="1000">
                 <a:solidFill>
-                  <a:srgbClr val="52525B"/>
+                  <a:srgbClr val="475569"/>
                 </a:solidFill>
               </a:defRPr>
             </a:pPr>
@@ -6371,7 +6371,7 @@
           </a:solidFill>
           <a:ln w="15240">
             <a:solidFill>
-              <a:srgbClr val="585ECE"/>
+              <a:srgbClr val="3182F6"/>
             </a:solidFill>
           </a:ln>
         </p:spPr>
@@ -6412,7 +6412,7 @@
             <a:avLst/>
           </a:prstGeom>
           <a:solidFill>
-            <a:srgbClr val="585ECE"/>
+            <a:srgbClr val="3182F6"/>
           </a:solidFill>
           <a:ln>
             <a:noFill/>
@@ -6500,7 +6500,7 @@
             <a:pPr>
               <a:defRPr sz="1300" b="1">
                 <a:solidFill>
-                  <a:srgbClr val="585ECE"/>
+                  <a:srgbClr val="3182F6"/>
                 </a:solidFill>
               </a:defRPr>
             </a:pPr>
@@ -6512,7 +6512,7 @@
             <a:pPr>
               <a:defRPr sz="1000">
                 <a:solidFill>
-                  <a:srgbClr val="52525B"/>
+                  <a:srgbClr val="475569"/>
                 </a:solidFill>
               </a:defRPr>
             </a:pPr>
@@ -6682,7 +6682,7 @@
             <a:pPr>
               <a:defRPr sz="1000">
                 <a:solidFill>
-                  <a:srgbClr val="52525B"/>
+                  <a:srgbClr val="475569"/>
                 </a:solidFill>
               </a:defRPr>
             </a:pPr>
@@ -6852,7 +6852,7 @@
             <a:pPr>
               <a:defRPr sz="1000">
                 <a:solidFill>
-                  <a:srgbClr val="52525B"/>
+                  <a:srgbClr val="475569"/>
                 </a:solidFill>
               </a:defRPr>
             </a:pPr>
@@ -6944,7 +6944,7 @@
             <a:pPr>
               <a:defRPr sz="1200" b="1">
                 <a:solidFill>
-                  <a:srgbClr val="18181B"/>
+                  <a:srgbClr val="1E293B"/>
                 </a:solidFill>
               </a:defRPr>
             </a:pPr>
@@ -6957,7 +6957,7 @@
             <a:pPr>
               <a:defRPr sz="1050">
                 <a:solidFill>
-                  <a:srgbClr val="52525B"/>
+                  <a:srgbClr val="475569"/>
                 </a:solidFill>
               </a:defRPr>
             </a:pPr>
@@ -7035,7 +7035,7 @@
             <a:pPr>
               <a:defRPr sz="1050" b="1">
                 <a:solidFill>
-                  <a:srgbClr val="18181B"/>
+                  <a:srgbClr val="1E293B"/>
                 </a:solidFill>
               </a:defRPr>
             </a:pPr>
@@ -7113,7 +7113,7 @@
             <a:pPr>
               <a:defRPr sz="1050" b="1">
                 <a:solidFill>
-                  <a:srgbClr val="18181B"/>
+                  <a:srgbClr val="1E293B"/>
                 </a:solidFill>
               </a:defRPr>
             </a:pPr>
@@ -7191,7 +7191,7 @@
             <a:pPr>
               <a:defRPr sz="1050" b="1">
                 <a:solidFill>
-                  <a:srgbClr val="18181B"/>
+                  <a:srgbClr val="1E293B"/>
                 </a:solidFill>
               </a:defRPr>
             </a:pPr>
@@ -7234,7 +7234,7 @@
             <a:avLst/>
           </a:prstGeom>
           <a:solidFill>
-            <a:srgbClr val="F4F4F6"/>
+            <a:srgbClr val="F8FAFC"/>
           </a:solidFill>
           <a:ln>
             <a:noFill/>
@@ -7277,11 +7277,11 @@
             <a:avLst/>
           </a:prstGeom>
           <a:solidFill>
-            <a:srgbClr val="F4F5FF"/>
+            <a:srgbClr val="EEF4FF"/>
           </a:solidFill>
           <a:ln w="12700">
             <a:solidFill>
-              <a:srgbClr val="585ECE"/>
+              <a:srgbClr val="3182F6"/>
             </a:solidFill>
           </a:ln>
         </p:spPr>
@@ -7332,7 +7332,7 @@
             <a:pPr>
               <a:defRPr sz="1000" b="1">
                 <a:solidFill>
-                  <a:srgbClr val="585ECE"/>
+                  <a:srgbClr val="3182F6"/>
                 </a:solidFill>
                 <a:latin typeface="Pretendard"/>
               </a:defRPr>
@@ -7368,7 +7368,7 @@
             <a:pPr>
               <a:defRPr sz="2300" b="1">
                 <a:solidFill>
-                  <a:srgbClr val="0A0A0A"/>
+                  <a:srgbClr val="0F172A"/>
                 </a:solidFill>
                 <a:latin typeface="Pretendard"/>
               </a:defRPr>
@@ -7404,7 +7404,7 @@
             <a:pPr>
               <a:defRPr sz="1200">
                 <a:solidFill>
-                  <a:srgbClr val="52525B"/>
+                  <a:srgbClr val="475569"/>
                 </a:solidFill>
                 <a:latin typeface="Pretendard"/>
               </a:defRPr>
@@ -7440,7 +7440,7 @@
             <a:pPr>
               <a:defRPr sz="900">
                 <a:solidFill>
-                  <a:srgbClr val="71717A"/>
+                  <a:srgbClr val="64748B"/>
                 </a:solidFill>
                 <a:latin typeface="Pretendard"/>
               </a:defRPr>
@@ -7476,7 +7476,7 @@
             <a:pPr algn="r">
               <a:defRPr sz="1000" b="1">
                 <a:solidFill>
-                  <a:srgbClr val="585ECE"/>
+                  <a:srgbClr val="3182F6"/>
                 </a:solidFill>
                 <a:latin typeface="Pretendard"/>
               </a:defRPr>
@@ -7506,7 +7506,7 @@
           </a:solidFill>
           <a:ln w="15240">
             <a:solidFill>
-              <a:srgbClr val="E4E4E7"/>
+              <a:srgbClr val="E2E8F0"/>
             </a:solidFill>
           </a:ln>
         </p:spPr>
@@ -7557,7 +7557,7 @@
             <a:pPr>
               <a:defRPr sz="1200" b="1">
                 <a:solidFill>
-                  <a:srgbClr val="71717A"/>
+                  <a:srgbClr val="64748B"/>
                 </a:solidFill>
               </a:defRPr>
             </a:pPr>
@@ -7582,11 +7582,11 @@
             <a:avLst/>
           </a:prstGeom>
           <a:solidFill>
-            <a:srgbClr val="F4F4F6"/>
+            <a:srgbClr val="F8FAFC"/>
           </a:solidFill>
           <a:ln w="15240">
             <a:solidFill>
-              <a:srgbClr val="E4E4E7"/>
+              <a:srgbClr val="E2E8F0"/>
             </a:solidFill>
           </a:ln>
         </p:spPr>
@@ -7637,7 +7637,7 @@
             <a:pPr>
               <a:defRPr sz="1100" b="1">
                 <a:solidFill>
-                  <a:srgbClr val="18181B"/>
+                  <a:srgbClr val="1E293B"/>
                 </a:solidFill>
               </a:defRPr>
             </a:pPr>
@@ -7649,7 +7649,7 @@
             <a:pPr>
               <a:defRPr sz="950">
                 <a:solidFill>
-                  <a:srgbClr val="71717A"/>
+                  <a:srgbClr val="64748B"/>
                 </a:solidFill>
               </a:defRPr>
             </a:pPr>
@@ -7674,11 +7674,11 @@
             <a:avLst/>
           </a:prstGeom>
           <a:solidFill>
-            <a:srgbClr val="F4F4F6"/>
+            <a:srgbClr val="F8FAFC"/>
           </a:solidFill>
           <a:ln w="15240">
             <a:solidFill>
-              <a:srgbClr val="E4E4E7"/>
+              <a:srgbClr val="E2E8F0"/>
             </a:solidFill>
           </a:ln>
         </p:spPr>
@@ -7729,7 +7729,7 @@
             <a:pPr>
               <a:defRPr sz="1100" b="1">
                 <a:solidFill>
-                  <a:srgbClr val="18181B"/>
+                  <a:srgbClr val="1E293B"/>
                 </a:solidFill>
               </a:defRPr>
             </a:pPr>
@@ -7741,7 +7741,7 @@
             <a:pPr>
               <a:defRPr sz="950">
                 <a:solidFill>
-                  <a:srgbClr val="71717A"/>
+                  <a:srgbClr val="64748B"/>
                 </a:solidFill>
               </a:defRPr>
             </a:pPr>
@@ -7766,11 +7766,11 @@
             <a:avLst/>
           </a:prstGeom>
           <a:solidFill>
-            <a:srgbClr val="F4F4F6"/>
+            <a:srgbClr val="F8FAFC"/>
           </a:solidFill>
           <a:ln w="15240">
             <a:solidFill>
-              <a:srgbClr val="E4E4E7"/>
+              <a:srgbClr val="E2E8F0"/>
             </a:solidFill>
           </a:ln>
         </p:spPr>
@@ -7821,7 +7821,7 @@
             <a:pPr>
               <a:defRPr sz="1100" b="1">
                 <a:solidFill>
-                  <a:srgbClr val="18181B"/>
+                  <a:srgbClr val="1E293B"/>
                 </a:solidFill>
               </a:defRPr>
             </a:pPr>
@@ -7833,7 +7833,7 @@
             <a:pPr>
               <a:defRPr sz="950">
                 <a:solidFill>
-                  <a:srgbClr val="71717A"/>
+                  <a:srgbClr val="64748B"/>
                 </a:solidFill>
               </a:defRPr>
             </a:pPr>
@@ -7858,11 +7858,11 @@
             <a:avLst/>
           </a:prstGeom>
           <a:solidFill>
-            <a:srgbClr val="F4F4F6"/>
+            <a:srgbClr val="F8FAFC"/>
           </a:solidFill>
           <a:ln w="15240">
             <a:solidFill>
-              <a:srgbClr val="E4E4E7"/>
+              <a:srgbClr val="E2E8F0"/>
             </a:solidFill>
           </a:ln>
         </p:spPr>
@@ -7913,7 +7913,7 @@
             <a:pPr>
               <a:defRPr sz="1100" b="1">
                 <a:solidFill>
-                  <a:srgbClr val="18181B"/>
+                  <a:srgbClr val="1E293B"/>
                 </a:solidFill>
               </a:defRPr>
             </a:pPr>
@@ -7925,7 +7925,7 @@
             <a:pPr>
               <a:defRPr sz="950">
                 <a:solidFill>
-                  <a:srgbClr val="71717A"/>
+                  <a:srgbClr val="64748B"/>
                 </a:solidFill>
               </a:defRPr>
             </a:pPr>
@@ -7950,11 +7950,11 @@
             <a:avLst/>
           </a:prstGeom>
           <a:solidFill>
-            <a:srgbClr val="F4F4F6"/>
+            <a:srgbClr val="F8FAFC"/>
           </a:solidFill>
           <a:ln w="15240">
             <a:solidFill>
-              <a:srgbClr val="E4E4E7"/>
+              <a:srgbClr val="E2E8F0"/>
             </a:solidFill>
           </a:ln>
         </p:spPr>
@@ -8005,7 +8005,7 @@
             <a:pPr>
               <a:defRPr sz="1100" b="1">
                 <a:solidFill>
-                  <a:srgbClr val="18181B"/>
+                  <a:srgbClr val="1E293B"/>
                 </a:solidFill>
               </a:defRPr>
             </a:pPr>
@@ -8017,7 +8017,7 @@
             <a:pPr>
               <a:defRPr sz="950">
                 <a:solidFill>
-                  <a:srgbClr val="71717A"/>
+                  <a:srgbClr val="64748B"/>
                 </a:solidFill>
               </a:defRPr>
             </a:pPr>
@@ -8046,7 +8046,7 @@
           </a:solidFill>
           <a:ln w="27940">
             <a:solidFill>
-              <a:srgbClr val="585ECE"/>
+              <a:srgbClr val="3182F6"/>
             </a:solidFill>
           </a:ln>
         </p:spPr>
@@ -8097,7 +8097,7 @@
             <a:pPr>
               <a:defRPr sz="1250" b="1">
                 <a:solidFill>
-                  <a:srgbClr val="585ECE"/>
+                  <a:srgbClr val="3182F6"/>
                 </a:solidFill>
               </a:defRPr>
             </a:pPr>
@@ -8122,11 +8122,11 @@
             <a:avLst/>
           </a:prstGeom>
           <a:solidFill>
-            <a:srgbClr val="F4F5FF"/>
+            <a:srgbClr val="EEF4FF"/>
           </a:solidFill>
           <a:ln w="15240">
             <a:solidFill>
-              <a:srgbClr val="585ECE"/>
+              <a:srgbClr val="3182F6"/>
             </a:solidFill>
           </a:ln>
         </p:spPr>
@@ -8177,7 +8177,7 @@
             <a:pPr>
               <a:defRPr sz="1100" b="1">
                 <a:solidFill>
-                  <a:srgbClr val="585ECE"/>
+                  <a:srgbClr val="3182F6"/>
                 </a:solidFill>
               </a:defRPr>
             </a:pPr>
@@ -8189,7 +8189,7 @@
             <a:pPr>
               <a:defRPr sz="950">
                 <a:solidFill>
-                  <a:srgbClr val="18181B"/>
+                  <a:srgbClr val="1E293B"/>
                 </a:solidFill>
               </a:defRPr>
             </a:pPr>
@@ -8214,11 +8214,11 @@
             <a:avLst/>
           </a:prstGeom>
           <a:solidFill>
-            <a:srgbClr val="F4F5FF"/>
+            <a:srgbClr val="EEF4FF"/>
           </a:solidFill>
           <a:ln w="15240">
             <a:solidFill>
-              <a:srgbClr val="585ECE"/>
+              <a:srgbClr val="3182F6"/>
             </a:solidFill>
           </a:ln>
         </p:spPr>
@@ -8269,7 +8269,7 @@
             <a:pPr>
               <a:defRPr sz="1100" b="1">
                 <a:solidFill>
-                  <a:srgbClr val="585ECE"/>
+                  <a:srgbClr val="3182F6"/>
                 </a:solidFill>
               </a:defRPr>
             </a:pPr>
@@ -8281,7 +8281,7 @@
             <a:pPr>
               <a:defRPr sz="950">
                 <a:solidFill>
-                  <a:srgbClr val="18181B"/>
+                  <a:srgbClr val="1E293B"/>
                 </a:solidFill>
               </a:defRPr>
             </a:pPr>
@@ -8306,7 +8306,7 @@
             <a:avLst/>
           </a:prstGeom>
           <a:solidFill>
-            <a:srgbClr val="EBEBFC"/>
+            <a:srgbClr val="F5F3FF"/>
           </a:solidFill>
           <a:ln w="15240">
             <a:solidFill>
@@ -8373,7 +8373,7 @@
             <a:pPr>
               <a:defRPr sz="950">
                 <a:solidFill>
-                  <a:srgbClr val="18181B"/>
+                  <a:srgbClr val="1E293B"/>
                 </a:solidFill>
               </a:defRPr>
             </a:pPr>
@@ -8465,7 +8465,7 @@
             <a:pPr>
               <a:defRPr sz="950">
                 <a:solidFill>
-                  <a:srgbClr val="18181B"/>
+                  <a:srgbClr val="1E293B"/>
                 </a:solidFill>
               </a:defRPr>
             </a:pPr>
@@ -8557,7 +8557,7 @@
             <a:pPr>
               <a:defRPr sz="950">
                 <a:solidFill>
-                  <a:srgbClr val="18181B"/>
+                  <a:srgbClr val="1E293B"/>
                 </a:solidFill>
               </a:defRPr>
             </a:pPr>
@@ -8600,7 +8600,7 @@
             <a:avLst/>
           </a:prstGeom>
           <a:solidFill>
-            <a:srgbClr val="F4F4F6"/>
+            <a:srgbClr val="F8FAFC"/>
           </a:solidFill>
           <a:ln>
             <a:noFill/>
@@ -8643,11 +8643,11 @@
             <a:avLst/>
           </a:prstGeom>
           <a:solidFill>
-            <a:srgbClr val="F4F5FF"/>
+            <a:srgbClr val="EEF4FF"/>
           </a:solidFill>
           <a:ln w="12700">
             <a:solidFill>
-              <a:srgbClr val="585ECE"/>
+              <a:srgbClr val="3182F6"/>
             </a:solidFill>
           </a:ln>
         </p:spPr>
@@ -8698,7 +8698,7 @@
             <a:pPr>
               <a:defRPr sz="1000" b="1">
                 <a:solidFill>
-                  <a:srgbClr val="585ECE"/>
+                  <a:srgbClr val="3182F6"/>
                 </a:solidFill>
                 <a:latin typeface="Pretendard"/>
               </a:defRPr>
@@ -8734,7 +8734,7 @@
             <a:pPr>
               <a:defRPr sz="2300" b="1">
                 <a:solidFill>
-                  <a:srgbClr val="0A0A0A"/>
+                  <a:srgbClr val="0F172A"/>
                 </a:solidFill>
                 <a:latin typeface="Pretendard"/>
               </a:defRPr>
@@ -8770,7 +8770,7 @@
             <a:pPr>
               <a:defRPr sz="1200">
                 <a:solidFill>
-                  <a:srgbClr val="52525B"/>
+                  <a:srgbClr val="475569"/>
                 </a:solidFill>
                 <a:latin typeface="Pretendard"/>
               </a:defRPr>
@@ -8806,7 +8806,7 @@
             <a:pPr>
               <a:defRPr sz="900">
                 <a:solidFill>
-                  <a:srgbClr val="71717A"/>
+                  <a:srgbClr val="64748B"/>
                 </a:solidFill>
                 <a:latin typeface="Pretendard"/>
               </a:defRPr>
@@ -8842,7 +8842,7 @@
             <a:pPr algn="r">
               <a:defRPr sz="1000" b="1">
                 <a:solidFill>
-                  <a:srgbClr val="585ECE"/>
+                  <a:srgbClr val="3182F6"/>
                 </a:solidFill>
                 <a:latin typeface="Pretendard"/>
               </a:defRPr>
@@ -8872,7 +8872,7 @@
           </a:solidFill>
           <a:ln w="19050">
             <a:solidFill>
-              <a:srgbClr val="585ECE"/>
+              <a:srgbClr val="3182F6"/>
             </a:solidFill>
           </a:ln>
         </p:spPr>
@@ -8923,7 +8923,7 @@
             <a:pPr>
               <a:defRPr sz="1200" b="1">
                 <a:solidFill>
-                  <a:srgbClr val="0A0A0A"/>
+                  <a:srgbClr val="0F172A"/>
                 </a:solidFill>
               </a:defRPr>
             </a:pPr>
@@ -8948,7 +8948,7 @@
             <a:avLst/>
           </a:prstGeom>
           <a:solidFill>
-            <a:srgbClr val="F4F4F6"/>
+            <a:srgbClr val="F8FAFC"/>
           </a:solidFill>
           <a:ln>
             <a:noFill/>
@@ -9001,7 +9001,7 @@
             <a:pPr>
               <a:defRPr sz="1100" b="1">
                 <a:solidFill>
-                  <a:srgbClr val="71717A"/>
+                  <a:srgbClr val="64748B"/>
                 </a:solidFill>
               </a:defRPr>
             </a:pPr>
@@ -9026,7 +9026,7 @@
             <a:avLst/>
           </a:prstGeom>
           <a:solidFill>
-            <a:srgbClr val="71717A"/>
+            <a:srgbClr val="64748B"/>
           </a:solidFill>
           <a:ln>
             <a:noFill/>
@@ -9069,7 +9069,7 @@
             <a:avLst/>
           </a:prstGeom>
           <a:solidFill>
-            <a:srgbClr val="F4F5FF"/>
+            <a:srgbClr val="EEF4FF"/>
           </a:solidFill>
           <a:ln>
             <a:noFill/>
@@ -9122,7 +9122,7 @@
             <a:pPr>
               <a:defRPr sz="1150" b="1">
                 <a:solidFill>
-                  <a:srgbClr val="585ECE"/>
+                  <a:srgbClr val="3182F6"/>
                 </a:solidFill>
               </a:defRPr>
             </a:pPr>
@@ -9147,7 +9147,7 @@
             <a:avLst/>
           </a:prstGeom>
           <a:solidFill>
-            <a:srgbClr val="585ECE"/>
+            <a:srgbClr val="3182F6"/>
           </a:solidFill>
           <a:ln>
             <a:noFill/>
@@ -9225,7 +9225,7 @@
             <a:avLst/>
           </a:prstGeom>
           <a:solidFill>
-            <a:srgbClr val="EBEBFC"/>
+            <a:srgbClr val="F5F3FF"/>
           </a:solidFill>
           <a:ln w="15240">
             <a:solidFill>
@@ -9292,7 +9292,7 @@
             <a:pPr>
               <a:defRPr sz="1000">
                 <a:solidFill>
-                  <a:srgbClr val="52525B"/>
+                  <a:srgbClr val="475569"/>
                 </a:solidFill>
               </a:defRPr>
             </a:pPr>
@@ -9384,7 +9384,7 @@
             <a:pPr>
               <a:defRPr sz="1250" b="1">
                 <a:solidFill>
-                  <a:srgbClr val="0A0A0A"/>
+                  <a:srgbClr val="0F172A"/>
                 </a:solidFill>
               </a:defRPr>
             </a:pPr>
@@ -9396,7 +9396,7 @@
             <a:pPr>
               <a:defRPr sz="1000">
                 <a:solidFill>
-                  <a:srgbClr val="52525B"/>
+                  <a:srgbClr val="475569"/>
                 </a:solidFill>
               </a:defRPr>
             </a:pPr>
@@ -9488,7 +9488,7 @@
             <a:pPr>
               <a:defRPr sz="1250" b="1">
                 <a:solidFill>
-                  <a:srgbClr val="0A0A0A"/>
+                  <a:srgbClr val="0F172A"/>
                 </a:solidFill>
               </a:defRPr>
             </a:pPr>
@@ -9500,7 +9500,7 @@
             <a:pPr>
               <a:defRPr sz="1000">
                 <a:solidFill>
-                  <a:srgbClr val="52525B"/>
+                  <a:srgbClr val="475569"/>
                 </a:solidFill>
               </a:defRPr>
             </a:pPr>
@@ -9592,7 +9592,7 @@
             <a:pPr>
               <a:defRPr sz="1250" b="1">
                 <a:solidFill>
-                  <a:srgbClr val="0A0A0A"/>
+                  <a:srgbClr val="0F172A"/>
                 </a:solidFill>
               </a:defRPr>
             </a:pPr>
@@ -9604,7 +9604,7 @@
             <a:pPr>
               <a:defRPr sz="1000">
                 <a:solidFill>
-                  <a:srgbClr val="52525B"/>
+                  <a:srgbClr val="475569"/>
                 </a:solidFill>
               </a:defRPr>
             </a:pPr>
@@ -9647,7 +9647,7 @@
             <a:avLst/>
           </a:prstGeom>
           <a:solidFill>
-            <a:srgbClr val="F4F4F6"/>
+            <a:srgbClr val="F8FAFC"/>
           </a:solidFill>
           <a:ln>
             <a:noFill/>
@@ -9690,11 +9690,11 @@
             <a:avLst/>
           </a:prstGeom>
           <a:solidFill>
-            <a:srgbClr val="F4F5FF"/>
+            <a:srgbClr val="EEF4FF"/>
           </a:solidFill>
           <a:ln w="12700">
             <a:solidFill>
-              <a:srgbClr val="585ECE"/>
+              <a:srgbClr val="3182F6"/>
             </a:solidFill>
           </a:ln>
         </p:spPr>
@@ -9745,7 +9745,7 @@
             <a:pPr>
               <a:defRPr sz="1000" b="1">
                 <a:solidFill>
-                  <a:srgbClr val="585ECE"/>
+                  <a:srgbClr val="3182F6"/>
                 </a:solidFill>
                 <a:latin typeface="Pretendard"/>
               </a:defRPr>
@@ -9781,7 +9781,7 @@
             <a:pPr>
               <a:defRPr sz="2300" b="1">
                 <a:solidFill>
-                  <a:srgbClr val="0A0A0A"/>
+                  <a:srgbClr val="0F172A"/>
                 </a:solidFill>
                 <a:latin typeface="Pretendard"/>
               </a:defRPr>
@@ -9817,7 +9817,7 @@
             <a:pPr>
               <a:defRPr sz="1200">
                 <a:solidFill>
-                  <a:srgbClr val="52525B"/>
+                  <a:srgbClr val="475569"/>
                 </a:solidFill>
                 <a:latin typeface="Pretendard"/>
               </a:defRPr>
@@ -9853,7 +9853,7 @@
             <a:pPr>
               <a:defRPr sz="900">
                 <a:solidFill>
-                  <a:srgbClr val="71717A"/>
+                  <a:srgbClr val="64748B"/>
                 </a:solidFill>
                 <a:latin typeface="Pretendard"/>
               </a:defRPr>
@@ -9889,7 +9889,7 @@
             <a:pPr algn="r">
               <a:defRPr sz="1000" b="1">
                 <a:solidFill>
-                  <a:srgbClr val="585ECE"/>
+                  <a:srgbClr val="3182F6"/>
                 </a:solidFill>
                 <a:latin typeface="Pretendard"/>
               </a:defRPr>
@@ -9919,7 +9919,7 @@
           </a:solidFill>
           <a:ln w="22860">
             <a:solidFill>
-              <a:srgbClr val="585ECE"/>
+              <a:srgbClr val="3182F6"/>
             </a:solidFill>
           </a:ln>
         </p:spPr>
@@ -9960,7 +9960,7 @@
             <a:avLst/>
           </a:prstGeom>
           <a:solidFill>
-            <a:srgbClr val="585ECE"/>
+            <a:srgbClr val="3182F6"/>
           </a:solidFill>
           <a:ln>
             <a:noFill/>
@@ -10048,7 +10048,7 @@
             <a:pPr>
               <a:defRPr sz="1500" b="1">
                 <a:solidFill>
-                  <a:srgbClr val="0A0A0A"/>
+                  <a:srgbClr val="0F172A"/>
                 </a:solidFill>
               </a:defRPr>
             </a:pPr>
@@ -10063,7 +10063,7 @@
               </a:lnSpc>
               <a:defRPr sz="1100">
                 <a:solidFill>
-                  <a:srgbClr val="52525B"/>
+                  <a:srgbClr val="475569"/>
                 </a:solidFill>
               </a:defRPr>
             </a:pPr>
@@ -10225,7 +10225,7 @@
             <a:pPr>
               <a:defRPr sz="1500" b="1">
                 <a:solidFill>
-                  <a:srgbClr val="0A0A0A"/>
+                  <a:srgbClr val="0F172A"/>
                 </a:solidFill>
               </a:defRPr>
             </a:pPr>
@@ -10240,7 +10240,7 @@
               </a:lnSpc>
               <a:defRPr sz="1100">
                 <a:solidFill>
-                  <a:srgbClr val="52525B"/>
+                  <a:srgbClr val="475569"/>
                 </a:solidFill>
               </a:defRPr>
             </a:pPr>
@@ -10398,7 +10398,7 @@
             <a:pPr>
               <a:defRPr sz="1500" b="1">
                 <a:solidFill>
-                  <a:srgbClr val="0A0A0A"/>
+                  <a:srgbClr val="0F172A"/>
                 </a:solidFill>
               </a:defRPr>
             </a:pPr>
@@ -10413,7 +10413,7 @@
               </a:lnSpc>
               <a:defRPr sz="1100">
                 <a:solidFill>
-                  <a:srgbClr val="52525B"/>
+                  <a:srgbClr val="475569"/>
                 </a:solidFill>
               </a:defRPr>
             </a:pPr>
@@ -10571,7 +10571,7 @@
             <a:pPr>
               <a:defRPr sz="1500" b="1">
                 <a:solidFill>
-                  <a:srgbClr val="0A0A0A"/>
+                  <a:srgbClr val="0F172A"/>
                 </a:solidFill>
               </a:defRPr>
             </a:pPr>
@@ -10586,7 +10586,7 @@
               </a:lnSpc>
               <a:defRPr sz="1100">
                 <a:solidFill>
-                  <a:srgbClr val="52525B"/>
+                  <a:srgbClr val="475569"/>
                 </a:solidFill>
               </a:defRPr>
             </a:pPr>
@@ -10629,7 +10629,7 @@
             <a:avLst/>
           </a:prstGeom>
           <a:solidFill>
-            <a:srgbClr val="F4F4F6"/>
+            <a:srgbClr val="F8FAFC"/>
           </a:solidFill>
           <a:ln>
             <a:noFill/>
@@ -10672,11 +10672,11 @@
             <a:avLst/>
           </a:prstGeom>
           <a:solidFill>
-            <a:srgbClr val="F4F5FF"/>
+            <a:srgbClr val="EEF4FF"/>
           </a:solidFill>
           <a:ln w="12700">
             <a:solidFill>
-              <a:srgbClr val="585ECE"/>
+              <a:srgbClr val="3182F6"/>
             </a:solidFill>
           </a:ln>
         </p:spPr>
@@ -10727,7 +10727,7 @@
             <a:pPr>
               <a:defRPr sz="1000" b="1">
                 <a:solidFill>
-                  <a:srgbClr val="585ECE"/>
+                  <a:srgbClr val="3182F6"/>
                 </a:solidFill>
                 <a:latin typeface="Pretendard"/>
               </a:defRPr>
@@ -10763,7 +10763,7 @@
             <a:pPr>
               <a:defRPr sz="2300" b="1">
                 <a:solidFill>
-                  <a:srgbClr val="0A0A0A"/>
+                  <a:srgbClr val="0F172A"/>
                 </a:solidFill>
                 <a:latin typeface="Pretendard"/>
               </a:defRPr>
@@ -10799,7 +10799,7 @@
             <a:pPr>
               <a:defRPr sz="1200">
                 <a:solidFill>
-                  <a:srgbClr val="52525B"/>
+                  <a:srgbClr val="475569"/>
                 </a:solidFill>
                 <a:latin typeface="Pretendard"/>
               </a:defRPr>
@@ -10835,7 +10835,7 @@
             <a:pPr>
               <a:defRPr sz="900">
                 <a:solidFill>
-                  <a:srgbClr val="71717A"/>
+                  <a:srgbClr val="64748B"/>
                 </a:solidFill>
                 <a:latin typeface="Pretendard"/>
               </a:defRPr>
@@ -10871,7 +10871,7 @@
             <a:pPr algn="r">
               <a:defRPr sz="1000" b="1">
                 <a:solidFill>
-                  <a:srgbClr val="585ECE"/>
+                  <a:srgbClr val="3182F6"/>
                 </a:solidFill>
                 <a:latin typeface="Pretendard"/>
               </a:defRPr>
@@ -10901,7 +10901,7 @@
           </a:solidFill>
           <a:ln w="15240">
             <a:solidFill>
-              <a:srgbClr val="E4E4E7"/>
+              <a:srgbClr val="E2E8F0"/>
             </a:solidFill>
           </a:ln>
         </p:spPr>
@@ -10942,7 +10942,7 @@
             <a:avLst/>
           </a:prstGeom>
           <a:solidFill>
-            <a:srgbClr val="F4F4F6"/>
+            <a:srgbClr val="F8FAFC"/>
           </a:solidFill>
           <a:ln>
             <a:noFill/>
@@ -10995,7 +10995,7 @@
             <a:pPr algn="ctr">
               <a:defRPr sz="1100" b="1">
                 <a:solidFill>
-                  <a:srgbClr val="0A0A0A"/>
+                  <a:srgbClr val="0F172A"/>
                 </a:solidFill>
               </a:defRPr>
             </a:pPr>
@@ -11030,7 +11030,7 @@
             <a:pPr algn="ctr">
               <a:defRPr sz="1100" b="1">
                 <a:solidFill>
-                  <a:srgbClr val="0A0A0A"/>
+                  <a:srgbClr val="0F172A"/>
                 </a:solidFill>
               </a:defRPr>
             </a:pPr>
@@ -11065,7 +11065,7 @@
             <a:pPr algn="ctr">
               <a:defRPr sz="1100" b="1">
                 <a:solidFill>
-                  <a:srgbClr val="0A0A0A"/>
+                  <a:srgbClr val="0F172A"/>
                 </a:solidFill>
               </a:defRPr>
             </a:pPr>
@@ -11100,7 +11100,7 @@
             <a:pPr algn="ctr">
               <a:defRPr sz="1100" b="1">
                 <a:solidFill>
-                  <a:srgbClr val="0A0A0A"/>
+                  <a:srgbClr val="0F172A"/>
                 </a:solidFill>
               </a:defRPr>
             </a:pPr>
@@ -11135,7 +11135,7 @@
             <a:pPr algn="ctr">
               <a:defRPr sz="1100" b="1">
                 <a:solidFill>
-                  <a:srgbClr val="585ECE"/>
+                  <a:srgbClr val="3182F6"/>
                 </a:solidFill>
               </a:defRPr>
             </a:pPr>
@@ -11160,11 +11160,11 @@
             <a:avLst/>
           </a:prstGeom>
           <a:solidFill>
-            <a:srgbClr val="F4F5FF"/>
+            <a:srgbClr val="EEF4FF"/>
           </a:solidFill>
           <a:ln w="15240">
             <a:solidFill>
-              <a:srgbClr val="585ECE"/>
+              <a:srgbClr val="3182F6"/>
             </a:solidFill>
           </a:ln>
         </p:spPr>
@@ -11215,7 +11215,7 @@
             <a:pPr algn="l">
               <a:defRPr sz="1050" b="1">
                 <a:solidFill>
-                  <a:srgbClr val="18181B"/>
+                  <a:srgbClr val="1E293B"/>
                 </a:solidFill>
               </a:defRPr>
             </a:pPr>
@@ -11250,7 +11250,7 @@
             <a:pPr algn="ctr">
               <a:defRPr sz="1050">
                 <a:solidFill>
-                  <a:srgbClr val="52525B"/>
+                  <a:srgbClr val="475569"/>
                 </a:solidFill>
               </a:defRPr>
             </a:pPr>
@@ -11285,7 +11285,7 @@
             <a:pPr algn="ctr">
               <a:defRPr sz="1050">
                 <a:solidFill>
-                  <a:srgbClr val="52525B"/>
+                  <a:srgbClr val="475569"/>
                 </a:solidFill>
               </a:defRPr>
             </a:pPr>
@@ -11320,7 +11320,7 @@
             <a:pPr algn="ctr">
               <a:defRPr sz="1050">
                 <a:solidFill>
-                  <a:srgbClr val="52525B"/>
+                  <a:srgbClr val="475569"/>
                 </a:solidFill>
               </a:defRPr>
             </a:pPr>
@@ -11355,7 +11355,7 @@
             <a:pPr algn="ctr">
               <a:defRPr sz="1050" b="1">
                 <a:solidFill>
-                  <a:srgbClr val="585ECE"/>
+                  <a:srgbClr val="3182F6"/>
                 </a:solidFill>
               </a:defRPr>
             </a:pPr>
@@ -11380,11 +11380,11 @@
             <a:avLst/>
           </a:prstGeom>
           <a:solidFill>
-            <a:srgbClr val="F4F5FF"/>
+            <a:srgbClr val="EEF4FF"/>
           </a:solidFill>
           <a:ln w="15240">
             <a:solidFill>
-              <a:srgbClr val="585ECE"/>
+              <a:srgbClr val="3182F6"/>
             </a:solidFill>
           </a:ln>
         </p:spPr>
@@ -11435,7 +11435,7 @@
             <a:pPr algn="l">
               <a:defRPr sz="1050" b="1">
                 <a:solidFill>
-                  <a:srgbClr val="18181B"/>
+                  <a:srgbClr val="1E293B"/>
                 </a:solidFill>
               </a:defRPr>
             </a:pPr>
@@ -11470,7 +11470,7 @@
             <a:pPr algn="ctr">
               <a:defRPr sz="1050">
                 <a:solidFill>
-                  <a:srgbClr val="52525B"/>
+                  <a:srgbClr val="475569"/>
                 </a:solidFill>
               </a:defRPr>
             </a:pPr>
@@ -11505,7 +11505,7 @@
             <a:pPr algn="ctr">
               <a:defRPr sz="1050">
                 <a:solidFill>
-                  <a:srgbClr val="52525B"/>
+                  <a:srgbClr val="475569"/>
                 </a:solidFill>
               </a:defRPr>
             </a:pPr>
@@ -11540,7 +11540,7 @@
             <a:pPr algn="ctr">
               <a:defRPr sz="1050">
                 <a:solidFill>
-                  <a:srgbClr val="52525B"/>
+                  <a:srgbClr val="475569"/>
                 </a:solidFill>
               </a:defRPr>
             </a:pPr>
@@ -11575,7 +11575,7 @@
             <a:pPr algn="ctr">
               <a:defRPr sz="1050" b="1">
                 <a:solidFill>
-                  <a:srgbClr val="585ECE"/>
+                  <a:srgbClr val="3182F6"/>
                 </a:solidFill>
               </a:defRPr>
             </a:pPr>
@@ -11600,11 +11600,11 @@
             <a:avLst/>
           </a:prstGeom>
           <a:solidFill>
-            <a:srgbClr val="F4F5FF"/>
+            <a:srgbClr val="EEF4FF"/>
           </a:solidFill>
           <a:ln w="15240">
             <a:solidFill>
-              <a:srgbClr val="585ECE"/>
+              <a:srgbClr val="3182F6"/>
             </a:solidFill>
           </a:ln>
         </p:spPr>
@@ -11655,7 +11655,7 @@
             <a:pPr algn="l">
               <a:defRPr sz="1050" b="1">
                 <a:solidFill>
-                  <a:srgbClr val="18181B"/>
+                  <a:srgbClr val="1E293B"/>
                 </a:solidFill>
               </a:defRPr>
             </a:pPr>
@@ -11690,7 +11690,7 @@
             <a:pPr algn="ctr">
               <a:defRPr sz="1050">
                 <a:solidFill>
-                  <a:srgbClr val="52525B"/>
+                  <a:srgbClr val="475569"/>
                 </a:solidFill>
               </a:defRPr>
             </a:pPr>
@@ -11725,7 +11725,7 @@
             <a:pPr algn="ctr">
               <a:defRPr sz="1050">
                 <a:solidFill>
-                  <a:srgbClr val="52525B"/>
+                  <a:srgbClr val="475569"/>
                 </a:solidFill>
               </a:defRPr>
             </a:pPr>
@@ -11760,7 +11760,7 @@
             <a:pPr algn="ctr">
               <a:defRPr sz="1050">
                 <a:solidFill>
-                  <a:srgbClr val="52525B"/>
+                  <a:srgbClr val="475569"/>
                 </a:solidFill>
               </a:defRPr>
             </a:pPr>
@@ -11795,7 +11795,7 @@
             <a:pPr algn="ctr">
               <a:defRPr sz="1050" b="1">
                 <a:solidFill>
-                  <a:srgbClr val="585ECE"/>
+                  <a:srgbClr val="3182F6"/>
                 </a:solidFill>
               </a:defRPr>
             </a:pPr>
@@ -11820,11 +11820,11 @@
             <a:avLst/>
           </a:prstGeom>
           <a:solidFill>
-            <a:srgbClr val="F4F5FF"/>
+            <a:srgbClr val="EEF4FF"/>
           </a:solidFill>
           <a:ln w="15240">
             <a:solidFill>
-              <a:srgbClr val="585ECE"/>
+              <a:srgbClr val="3182F6"/>
             </a:solidFill>
           </a:ln>
         </p:spPr>
@@ -11875,7 +11875,7 @@
             <a:pPr algn="l">
               <a:defRPr sz="1050" b="1">
                 <a:solidFill>
-                  <a:srgbClr val="18181B"/>
+                  <a:srgbClr val="1E293B"/>
                 </a:solidFill>
               </a:defRPr>
             </a:pPr>
@@ -11910,7 +11910,7 @@
             <a:pPr algn="ctr">
               <a:defRPr sz="1050">
                 <a:solidFill>
-                  <a:srgbClr val="52525B"/>
+                  <a:srgbClr val="475569"/>
                 </a:solidFill>
               </a:defRPr>
             </a:pPr>
@@ -11945,7 +11945,7 @@
             <a:pPr algn="ctr">
               <a:defRPr sz="1050">
                 <a:solidFill>
-                  <a:srgbClr val="52525B"/>
+                  <a:srgbClr val="475569"/>
                 </a:solidFill>
               </a:defRPr>
             </a:pPr>
@@ -11980,7 +11980,7 @@
             <a:pPr algn="ctr">
               <a:defRPr sz="1050">
                 <a:solidFill>
-                  <a:srgbClr val="52525B"/>
+                  <a:srgbClr val="475569"/>
                 </a:solidFill>
               </a:defRPr>
             </a:pPr>
@@ -12015,7 +12015,7 @@
             <a:pPr algn="ctr">
               <a:defRPr sz="1050" b="1">
                 <a:solidFill>
-                  <a:srgbClr val="585ECE"/>
+                  <a:srgbClr val="3182F6"/>
                 </a:solidFill>
               </a:defRPr>
             </a:pPr>
@@ -12040,11 +12040,11 @@
             <a:avLst/>
           </a:prstGeom>
           <a:solidFill>
-            <a:srgbClr val="F4F5FF"/>
+            <a:srgbClr val="EEF4FF"/>
           </a:solidFill>
           <a:ln w="15240">
             <a:solidFill>
-              <a:srgbClr val="585ECE"/>
+              <a:srgbClr val="3182F6"/>
             </a:solidFill>
           </a:ln>
         </p:spPr>
@@ -12095,7 +12095,7 @@
             <a:pPr algn="l">
               <a:defRPr sz="1050" b="1">
                 <a:solidFill>
-                  <a:srgbClr val="18181B"/>
+                  <a:srgbClr val="1E293B"/>
                 </a:solidFill>
               </a:defRPr>
             </a:pPr>
@@ -12130,7 +12130,7 @@
             <a:pPr algn="ctr">
               <a:defRPr sz="1050">
                 <a:solidFill>
-                  <a:srgbClr val="52525B"/>
+                  <a:srgbClr val="475569"/>
                 </a:solidFill>
               </a:defRPr>
             </a:pPr>
@@ -12165,7 +12165,7 @@
             <a:pPr algn="ctr">
               <a:defRPr sz="1050">
                 <a:solidFill>
-                  <a:srgbClr val="52525B"/>
+                  <a:srgbClr val="475569"/>
                 </a:solidFill>
               </a:defRPr>
             </a:pPr>
@@ -12200,7 +12200,7 @@
             <a:pPr algn="ctr">
               <a:defRPr sz="1050">
                 <a:solidFill>
-                  <a:srgbClr val="52525B"/>
+                  <a:srgbClr val="475569"/>
                 </a:solidFill>
               </a:defRPr>
             </a:pPr>
@@ -12235,7 +12235,7 @@
             <a:pPr algn="ctr">
               <a:defRPr sz="1050" b="1">
                 <a:solidFill>
-                  <a:srgbClr val="585ECE"/>
+                  <a:srgbClr val="3182F6"/>
                 </a:solidFill>
               </a:defRPr>
             </a:pPr>
@@ -12278,7 +12278,7 @@
             <a:avLst/>
           </a:prstGeom>
           <a:solidFill>
-            <a:srgbClr val="F4F4F6"/>
+            <a:srgbClr val="F8FAFC"/>
           </a:solidFill>
           <a:ln>
             <a:noFill/>
@@ -12321,11 +12321,11 @@
             <a:avLst/>
           </a:prstGeom>
           <a:solidFill>
-            <a:srgbClr val="F4F5FF"/>
+            <a:srgbClr val="EEF4FF"/>
           </a:solidFill>
           <a:ln w="12700">
             <a:solidFill>
-              <a:srgbClr val="585ECE"/>
+              <a:srgbClr val="3182F6"/>
             </a:solidFill>
           </a:ln>
         </p:spPr>
@@ -12376,7 +12376,7 @@
             <a:pPr>
               <a:defRPr sz="1000" b="1">
                 <a:solidFill>
-                  <a:srgbClr val="585ECE"/>
+                  <a:srgbClr val="3182F6"/>
                 </a:solidFill>
                 <a:latin typeface="Pretendard"/>
               </a:defRPr>
@@ -12412,7 +12412,7 @@
             <a:pPr>
               <a:defRPr sz="2300" b="1">
                 <a:solidFill>
-                  <a:srgbClr val="0A0A0A"/>
+                  <a:srgbClr val="0F172A"/>
                 </a:solidFill>
                 <a:latin typeface="Pretendard"/>
               </a:defRPr>
@@ -12448,7 +12448,7 @@
             <a:pPr>
               <a:defRPr sz="1200">
                 <a:solidFill>
-                  <a:srgbClr val="52525B"/>
+                  <a:srgbClr val="475569"/>
                 </a:solidFill>
                 <a:latin typeface="Pretendard"/>
               </a:defRPr>
@@ -12484,7 +12484,7 @@
             <a:pPr>
               <a:defRPr sz="900">
                 <a:solidFill>
-                  <a:srgbClr val="71717A"/>
+                  <a:srgbClr val="64748B"/>
                 </a:solidFill>
                 <a:latin typeface="Pretendard"/>
               </a:defRPr>
@@ -12520,7 +12520,7 @@
             <a:pPr algn="r">
               <a:defRPr sz="1000" b="1">
                 <a:solidFill>
-                  <a:srgbClr val="585ECE"/>
+                  <a:srgbClr val="3182F6"/>
                 </a:solidFill>
                 <a:latin typeface="Pretendard"/>
               </a:defRPr>
@@ -12550,7 +12550,7 @@
           </a:solidFill>
           <a:ln w="22860">
             <a:solidFill>
-              <a:srgbClr val="585ECE"/>
+              <a:srgbClr val="3182F6"/>
             </a:solidFill>
           </a:ln>
         </p:spPr>
@@ -12591,7 +12591,7 @@
             <a:avLst/>
           </a:prstGeom>
           <a:solidFill>
-            <a:srgbClr val="585ECE"/>
+            <a:srgbClr val="3182F6"/>
           </a:solidFill>
           <a:ln>
             <a:noFill/>
@@ -12679,7 +12679,7 @@
             <a:pPr>
               <a:defRPr sz="1600" b="1">
                 <a:solidFill>
-                  <a:srgbClr val="0A0A0A"/>
+                  <a:srgbClr val="0F172A"/>
                 </a:solidFill>
               </a:defRPr>
             </a:pPr>
@@ -12714,7 +12714,7 @@
             <a:pPr>
               <a:defRPr sz="1200" b="1">
                 <a:solidFill>
-                  <a:srgbClr val="585ECE"/>
+                  <a:srgbClr val="3182F6"/>
                 </a:solidFill>
               </a:defRPr>
             </a:pPr>
@@ -12752,7 +12752,7 @@
               </a:lnSpc>
               <a:defRPr sz="1100">
                 <a:solidFill>
-                  <a:srgbClr val="52525B"/>
+                  <a:srgbClr val="475569"/>
                 </a:solidFill>
               </a:defRPr>
             </a:pPr>
@@ -12910,7 +12910,7 @@
             <a:pPr>
               <a:defRPr sz="1600" b="1">
                 <a:solidFill>
-                  <a:srgbClr val="0A0A0A"/>
+                  <a:srgbClr val="0F172A"/>
                 </a:solidFill>
               </a:defRPr>
             </a:pPr>
@@ -12983,7 +12983,7 @@
               </a:lnSpc>
               <a:defRPr sz="1100">
                 <a:solidFill>
-                  <a:srgbClr val="52525B"/>
+                  <a:srgbClr val="475569"/>
                 </a:solidFill>
               </a:defRPr>
             </a:pPr>
@@ -13141,7 +13141,7 @@
             <a:pPr>
               <a:defRPr sz="1600" b="1">
                 <a:solidFill>
-                  <a:srgbClr val="0A0A0A"/>
+                  <a:srgbClr val="0F172A"/>
                 </a:solidFill>
               </a:defRPr>
             </a:pPr>
@@ -13214,7 +13214,7 @@
               </a:lnSpc>
               <a:defRPr sz="1100">
                 <a:solidFill>
-                  <a:srgbClr val="52525B"/>
+                  <a:srgbClr val="475569"/>
                 </a:solidFill>
               </a:defRPr>
             </a:pPr>
@@ -13243,7 +13243,7 @@
           </a:solidFill>
           <a:ln w="19050">
             <a:solidFill>
-              <a:srgbClr val="585ECE"/>
+              <a:srgbClr val="3182F6"/>
             </a:solidFill>
           </a:ln>
         </p:spPr>
@@ -13294,7 +13294,7 @@
             <a:pPr>
               <a:defRPr sz="1100" b="1">
                 <a:solidFill>
-                  <a:srgbClr val="585ECE"/>
+                  <a:srgbClr val="3182F6"/>
                 </a:solidFill>
               </a:defRPr>
             </a:pPr>
@@ -13306,7 +13306,7 @@
             <a:pPr>
               <a:defRPr sz="950">
                 <a:solidFill>
-                  <a:srgbClr val="52525B"/>
+                  <a:srgbClr val="475569"/>
                 </a:solidFill>
               </a:defRPr>
             </a:pPr>
@@ -13353,7 +13353,7 @@
             <a:avLst/>
           </a:prstGeom>
           <a:solidFill>
-            <a:srgbClr val="F4F4F6"/>
+            <a:srgbClr val="F8FAFC"/>
           </a:solidFill>
           <a:ln>
             <a:noFill/>
@@ -13396,11 +13396,11 @@
             <a:avLst/>
           </a:prstGeom>
           <a:solidFill>
-            <a:srgbClr val="F4F5FF"/>
+            <a:srgbClr val="EEF4FF"/>
           </a:solidFill>
           <a:ln w="12700">
             <a:solidFill>
-              <a:srgbClr val="585ECE"/>
+              <a:srgbClr val="3182F6"/>
             </a:solidFill>
           </a:ln>
         </p:spPr>
@@ -13451,7 +13451,7 @@
             <a:pPr>
               <a:defRPr sz="1000" b="1">
                 <a:solidFill>
-                  <a:srgbClr val="585ECE"/>
+                  <a:srgbClr val="3182F6"/>
                 </a:solidFill>
                 <a:latin typeface="Pretendard"/>
               </a:defRPr>
@@ -13487,7 +13487,7 @@
             <a:pPr>
               <a:defRPr sz="2300" b="1">
                 <a:solidFill>
-                  <a:srgbClr val="0A0A0A"/>
+                  <a:srgbClr val="0F172A"/>
                 </a:solidFill>
                 <a:latin typeface="Pretendard"/>
               </a:defRPr>
@@ -13523,7 +13523,7 @@
             <a:pPr>
               <a:defRPr sz="1200">
                 <a:solidFill>
-                  <a:srgbClr val="52525B"/>
+                  <a:srgbClr val="475569"/>
                 </a:solidFill>
                 <a:latin typeface="Pretendard"/>
               </a:defRPr>
@@ -13559,7 +13559,7 @@
             <a:pPr>
               <a:defRPr sz="900">
                 <a:solidFill>
-                  <a:srgbClr val="71717A"/>
+                  <a:srgbClr val="64748B"/>
                 </a:solidFill>
                 <a:latin typeface="Pretendard"/>
               </a:defRPr>
@@ -13595,7 +13595,7 @@
             <a:pPr algn="r">
               <a:defRPr sz="1000" b="1">
                 <a:solidFill>
-                  <a:srgbClr val="585ECE"/>
+                  <a:srgbClr val="3182F6"/>
                 </a:solidFill>
                 <a:latin typeface="Pretendard"/>
               </a:defRPr>
@@ -13625,7 +13625,7 @@
           </a:solidFill>
           <a:ln w="15240">
             <a:solidFill>
-              <a:srgbClr val="585ECE"/>
+              <a:srgbClr val="3182F6"/>
             </a:solidFill>
           </a:ln>
         </p:spPr>
@@ -13666,7 +13666,7 @@
             <a:avLst/>
           </a:prstGeom>
           <a:solidFill>
-            <a:srgbClr val="585ECE"/>
+            <a:srgbClr val="3182F6"/>
           </a:solidFill>
           <a:ln>
             <a:noFill/>
@@ -13754,7 +13754,7 @@
             <a:pPr>
               <a:defRPr sz="1300" b="1">
                 <a:solidFill>
-                  <a:srgbClr val="0A0A0A"/>
+                  <a:srgbClr val="0F172A"/>
                 </a:solidFill>
               </a:defRPr>
             </a:pPr>
@@ -13766,7 +13766,7 @@
             <a:pPr>
               <a:defRPr sz="1000">
                 <a:solidFill>
-                  <a:srgbClr val="71717A"/>
+                  <a:srgbClr val="64748B"/>
                 </a:solidFill>
               </a:defRPr>
             </a:pPr>
@@ -13791,11 +13791,11 @@
             <a:avLst/>
           </a:prstGeom>
           <a:solidFill>
-            <a:srgbClr val="F4F5FF"/>
+            <a:srgbClr val="EEF4FF"/>
           </a:solidFill>
           <a:ln w="12700">
             <a:solidFill>
-              <a:srgbClr val="585ECE"/>
+              <a:srgbClr val="3182F6"/>
             </a:solidFill>
           </a:ln>
         </p:spPr>
@@ -13846,7 +13846,7 @@
             <a:pPr algn="ctr">
               <a:defRPr sz="1100" b="1">
                 <a:solidFill>
-                  <a:srgbClr val="585ECE"/>
+                  <a:srgbClr val="3182F6"/>
                 </a:solidFill>
               </a:defRPr>
             </a:pPr>
@@ -13871,7 +13871,7 @@
             <a:avLst/>
           </a:prstGeom>
           <a:solidFill>
-            <a:srgbClr val="F4F4F6"/>
+            <a:srgbClr val="F8FAFC"/>
           </a:solidFill>
           <a:ln>
             <a:noFill/>
@@ -13924,7 +13924,7 @@
             <a:pPr algn="ctr">
               <a:defRPr sz="950" b="1">
                 <a:solidFill>
-                  <a:srgbClr val="585ECE"/>
+                  <a:srgbClr val="3182F6"/>
                 </a:solidFill>
               </a:defRPr>
             </a:pPr>
@@ -13962,7 +13962,7 @@
               </a:lnSpc>
               <a:defRPr sz="1000">
                 <a:solidFill>
-                  <a:srgbClr val="52525B"/>
+                  <a:srgbClr val="475569"/>
                 </a:solidFill>
               </a:defRPr>
             </a:pPr>
@@ -14124,7 +14124,7 @@
             <a:pPr>
               <a:defRPr sz="1300" b="1">
                 <a:solidFill>
-                  <a:srgbClr val="0A0A0A"/>
+                  <a:srgbClr val="0F172A"/>
                 </a:solidFill>
               </a:defRPr>
             </a:pPr>
@@ -14136,7 +14136,7 @@
             <a:pPr>
               <a:defRPr sz="1000">
                 <a:solidFill>
-                  <a:srgbClr val="71717A"/>
+                  <a:srgbClr val="64748B"/>
                 </a:solidFill>
               </a:defRPr>
             </a:pPr>
@@ -14161,7 +14161,7 @@
             <a:avLst/>
           </a:prstGeom>
           <a:solidFill>
-            <a:srgbClr val="EBEBFC"/>
+            <a:srgbClr val="F5F3FF"/>
           </a:solidFill>
           <a:ln w="12700">
             <a:solidFill>
@@ -14241,7 +14241,7 @@
             <a:avLst/>
           </a:prstGeom>
           <a:solidFill>
-            <a:srgbClr val="F4F4F6"/>
+            <a:srgbClr val="F8FAFC"/>
           </a:solidFill>
           <a:ln>
             <a:noFill/>
@@ -14332,7 +14332,7 @@
               </a:lnSpc>
               <a:defRPr sz="1000">
                 <a:solidFill>
-                  <a:srgbClr val="52525B"/>
+                  <a:srgbClr val="475569"/>
                 </a:solidFill>
               </a:defRPr>
             </a:pPr>
@@ -14494,7 +14494,7 @@
             <a:pPr>
               <a:defRPr sz="1300" b="1">
                 <a:solidFill>
-                  <a:srgbClr val="0A0A0A"/>
+                  <a:srgbClr val="0F172A"/>
                 </a:solidFill>
               </a:defRPr>
             </a:pPr>
@@ -14506,7 +14506,7 @@
             <a:pPr>
               <a:defRPr sz="1000">
                 <a:solidFill>
-                  <a:srgbClr val="71717A"/>
+                  <a:srgbClr val="64748B"/>
                 </a:solidFill>
               </a:defRPr>
             </a:pPr>
@@ -14611,7 +14611,7 @@
             <a:avLst/>
           </a:prstGeom>
           <a:solidFill>
-            <a:srgbClr val="F4F4F6"/>
+            <a:srgbClr val="F8FAFC"/>
           </a:solidFill>
           <a:ln>
             <a:noFill/>
@@ -14702,7 +14702,7 @@
               </a:lnSpc>
               <a:defRPr sz="1000">
                 <a:solidFill>
-                  <a:srgbClr val="52525B"/>
+                  <a:srgbClr val="475569"/>
                 </a:solidFill>
               </a:defRPr>
             </a:pPr>
@@ -14864,7 +14864,7 @@
             <a:pPr>
               <a:defRPr sz="1300" b="1">
                 <a:solidFill>
-                  <a:srgbClr val="0A0A0A"/>
+                  <a:srgbClr val="0F172A"/>
                 </a:solidFill>
               </a:defRPr>
             </a:pPr>
@@ -14876,7 +14876,7 @@
             <a:pPr>
               <a:defRPr sz="1000">
                 <a:solidFill>
-                  <a:srgbClr val="71717A"/>
+                  <a:srgbClr val="64748B"/>
                 </a:solidFill>
               </a:defRPr>
             </a:pPr>
@@ -14901,7 +14901,7 @@
             <a:avLst/>
           </a:prstGeom>
           <a:solidFill>
-            <a:srgbClr val="EBEBFC"/>
+            <a:srgbClr val="F5F3FF"/>
           </a:solidFill>
           <a:ln w="12700">
             <a:solidFill>
@@ -14981,7 +14981,7 @@
             <a:avLst/>
           </a:prstGeom>
           <a:solidFill>
-            <a:srgbClr val="F4F4F6"/>
+            <a:srgbClr val="F8FAFC"/>
           </a:solidFill>
           <a:ln>
             <a:noFill/>
@@ -15072,7 +15072,7 @@
               </a:lnSpc>
               <a:defRPr sz="1000">
                 <a:solidFill>
-                  <a:srgbClr val="52525B"/>
+                  <a:srgbClr val="475569"/>
                 </a:solidFill>
               </a:defRPr>
             </a:pPr>
@@ -15105,7 +15105,7 @@
           </a:solidFill>
           <a:ln w="15240">
             <a:solidFill>
-              <a:srgbClr val="71717A"/>
+              <a:srgbClr val="64748B"/>
             </a:solidFill>
           </a:ln>
         </p:spPr>
@@ -15146,7 +15146,7 @@
             <a:avLst/>
           </a:prstGeom>
           <a:solidFill>
-            <a:srgbClr val="71717A"/>
+            <a:srgbClr val="64748B"/>
           </a:solidFill>
           <a:ln>
             <a:noFill/>
@@ -15234,7 +15234,7 @@
             <a:pPr>
               <a:defRPr sz="1300" b="1">
                 <a:solidFill>
-                  <a:srgbClr val="0A0A0A"/>
+                  <a:srgbClr val="0F172A"/>
                 </a:solidFill>
               </a:defRPr>
             </a:pPr>
@@ -15246,7 +15246,7 @@
             <a:pPr>
               <a:defRPr sz="1000">
                 <a:solidFill>
-                  <a:srgbClr val="71717A"/>
+                  <a:srgbClr val="64748B"/>
                 </a:solidFill>
               </a:defRPr>
             </a:pPr>
@@ -15271,11 +15271,11 @@
             <a:avLst/>
           </a:prstGeom>
           <a:solidFill>
-            <a:srgbClr val="EBEBFC"/>
+            <a:srgbClr val="F5F3FF"/>
           </a:solidFill>
           <a:ln w="12700">
             <a:solidFill>
-              <a:srgbClr val="71717A"/>
+              <a:srgbClr val="64748B"/>
             </a:solidFill>
           </a:ln>
         </p:spPr>
@@ -15326,7 +15326,7 @@
             <a:pPr algn="ctr">
               <a:defRPr sz="1100" b="1">
                 <a:solidFill>
-                  <a:srgbClr val="71717A"/>
+                  <a:srgbClr val="64748B"/>
                 </a:solidFill>
               </a:defRPr>
             </a:pPr>
@@ -15351,7 +15351,7 @@
             <a:avLst/>
           </a:prstGeom>
           <a:solidFill>
-            <a:srgbClr val="F4F4F6"/>
+            <a:srgbClr val="F8FAFC"/>
           </a:solidFill>
           <a:ln>
             <a:noFill/>
@@ -15404,7 +15404,7 @@
             <a:pPr algn="ctr">
               <a:defRPr sz="950" b="1">
                 <a:solidFill>
-                  <a:srgbClr val="71717A"/>
+                  <a:srgbClr val="64748B"/>
                 </a:solidFill>
               </a:defRPr>
             </a:pPr>
@@ -15442,7 +15442,7 @@
               </a:lnSpc>
               <a:defRPr sz="1000">
                 <a:solidFill>
-                  <a:srgbClr val="52525B"/>
+                  <a:srgbClr val="475569"/>
                 </a:solidFill>
               </a:defRPr>
             </a:pPr>
@@ -15489,7 +15489,7 @@
             <a:avLst/>
           </a:prstGeom>
           <a:solidFill>
-            <a:srgbClr val="F4F4F6"/>
+            <a:srgbClr val="F8FAFC"/>
           </a:solidFill>
           <a:ln>
             <a:noFill/>
@@ -15532,11 +15532,11 @@
             <a:avLst/>
           </a:prstGeom>
           <a:solidFill>
-            <a:srgbClr val="F4F5FF"/>
+            <a:srgbClr val="EEF4FF"/>
           </a:solidFill>
           <a:ln w="12700">
             <a:solidFill>
-              <a:srgbClr val="585ECE"/>
+              <a:srgbClr val="3182F6"/>
             </a:solidFill>
           </a:ln>
         </p:spPr>
@@ -15587,7 +15587,7 @@
             <a:pPr>
               <a:defRPr sz="1000" b="1">
                 <a:solidFill>
-                  <a:srgbClr val="585ECE"/>
+                  <a:srgbClr val="3182F6"/>
                 </a:solidFill>
                 <a:latin typeface="Pretendard"/>
               </a:defRPr>
@@ -15623,7 +15623,7 @@
             <a:pPr>
               <a:defRPr sz="2300" b="1">
                 <a:solidFill>
-                  <a:srgbClr val="0A0A0A"/>
+                  <a:srgbClr val="0F172A"/>
                 </a:solidFill>
                 <a:latin typeface="Pretendard"/>
               </a:defRPr>
@@ -15659,7 +15659,7 @@
             <a:pPr>
               <a:defRPr sz="1200">
                 <a:solidFill>
-                  <a:srgbClr val="52525B"/>
+                  <a:srgbClr val="475569"/>
                 </a:solidFill>
                 <a:latin typeface="Pretendard"/>
               </a:defRPr>
@@ -15695,7 +15695,7 @@
             <a:pPr>
               <a:defRPr sz="900">
                 <a:solidFill>
-                  <a:srgbClr val="71717A"/>
+                  <a:srgbClr val="64748B"/>
                 </a:solidFill>
                 <a:latin typeface="Pretendard"/>
               </a:defRPr>
@@ -15731,7 +15731,7 @@
             <a:pPr algn="r">
               <a:defRPr sz="1000" b="1">
                 <a:solidFill>
-                  <a:srgbClr val="585ECE"/>
+                  <a:srgbClr val="3182F6"/>
                 </a:solidFill>
                 <a:latin typeface="Pretendard"/>
               </a:defRPr>
@@ -15761,7 +15761,7 @@
           </a:solidFill>
           <a:ln w="22860">
             <a:solidFill>
-              <a:srgbClr val="585ECE"/>
+              <a:srgbClr val="3182F6"/>
             </a:solidFill>
           </a:ln>
         </p:spPr>
@@ -15802,7 +15802,7 @@
             <a:avLst/>
           </a:prstGeom>
           <a:solidFill>
-            <a:srgbClr val="585ECE"/>
+            <a:srgbClr val="3182F6"/>
           </a:solidFill>
           <a:ln>
             <a:noFill/>
@@ -15890,7 +15890,7 @@
             <a:pPr>
               <a:defRPr sz="1700" b="1">
                 <a:solidFill>
-                  <a:srgbClr val="0A0A0A"/>
+                  <a:srgbClr val="0F172A"/>
                 </a:solidFill>
               </a:defRPr>
             </a:pPr>
@@ -15925,7 +15925,7 @@
             <a:pPr>
               <a:defRPr sz="1200" b="1">
                 <a:solidFill>
-                  <a:srgbClr val="585ECE"/>
+                  <a:srgbClr val="3182F6"/>
                 </a:solidFill>
               </a:defRPr>
             </a:pPr>
@@ -15963,7 +15963,7 @@
               </a:lnSpc>
               <a:defRPr sz="1150">
                 <a:solidFill>
-                  <a:srgbClr val="52525B"/>
+                  <a:srgbClr val="475569"/>
                 </a:solidFill>
               </a:defRPr>
             </a:pPr>
@@ -16126,7 +16126,7 @@
             <a:pPr>
               <a:defRPr sz="1700" b="1">
                 <a:solidFill>
-                  <a:srgbClr val="0A0A0A"/>
+                  <a:srgbClr val="0F172A"/>
                 </a:solidFill>
               </a:defRPr>
             </a:pPr>
@@ -16199,7 +16199,7 @@
               </a:lnSpc>
               <a:defRPr sz="1150">
                 <a:solidFill>
-                  <a:srgbClr val="52525B"/>
+                  <a:srgbClr val="475569"/>
                 </a:solidFill>
               </a:defRPr>
             </a:pPr>
@@ -16362,7 +16362,7 @@
             <a:pPr>
               <a:defRPr sz="1700" b="1">
                 <a:solidFill>
-                  <a:srgbClr val="0A0A0A"/>
+                  <a:srgbClr val="0F172A"/>
                 </a:solidFill>
               </a:defRPr>
             </a:pPr>
@@ -16435,7 +16435,7 @@
               </a:lnSpc>
               <a:defRPr sz="1150">
                 <a:solidFill>
-                  <a:srgbClr val="52525B"/>
+                  <a:srgbClr val="475569"/>
                 </a:solidFill>
               </a:defRPr>
             </a:pPr>

</xml_diff>